<commit_message>
Improve poster workflow arrow graphics
Co-authored-by: Shyam <shyam.nexus@gmail.com>
</commit_message>
<xml_diff>
--- a/Coding Embedded Workstream - Common Idea Poster.pptx
+++ b/Coding Embedded Workstream - Common Idea Poster.pptx
@@ -5021,16 +5021,16 @@
       </p:sp>
       <p:sp>
         <p:nvSpPr>
-          <p:cNvPr id="48" name="Rectangle 47"/>
+          <p:cNvPr id="48" name="Right Arrow 47"/>
           <p:cNvSpPr/>
           <p:nvPr/>
         </p:nvSpPr>
         <p:spPr>
           <a:xfrm>
-            <a:off x="1124712" y="4023359"/>
-            <a:ext cx="585216" cy="32004"/>
-          </a:xfrm>
-          <a:prstGeom prst="rect">
+            <a:off x="1188720" y="3959352"/>
+            <a:ext cx="960120" cy="182880"/>
+          </a:xfrm>
+          <a:prstGeom prst="rightArrow">
             <a:avLst/>
           </a:prstGeom>
           <a:solidFill>
@@ -5064,20 +5064,20 @@
       </p:sp>
       <p:sp>
         <p:nvSpPr>
-          <p:cNvPr id="49" name="Rectangle 48"/>
+          <p:cNvPr id="49" name="Oval 48"/>
           <p:cNvSpPr/>
           <p:nvPr/>
         </p:nvSpPr>
         <p:spPr>
           <a:xfrm>
-            <a:off x="1709928" y="3954779"/>
-            <a:ext cx="18288" cy="164592"/>
-          </a:xfrm>
-          <a:prstGeom prst="rect">
-            <a:avLst/>
-          </a:prstGeom>
-          <a:solidFill>
-            <a:srgbClr val="00C8F0"/>
+            <a:off x="2377439" y="3803904"/>
+            <a:ext cx="493776" cy="493776"/>
+          </a:xfrm>
+          <a:prstGeom prst="ellipse">
+            <a:avLst/>
+          </a:prstGeom>
+          <a:solidFill>
+            <a:srgbClr val="FF8C00"/>
           </a:solidFill>
           <a:ln>
             <a:noFill/>
@@ -5107,695 +5107,7 @@
       </p:sp>
       <p:sp>
         <p:nvSpPr>
-          <p:cNvPr id="50" name="Rectangle 49"/>
-          <p:cNvSpPr/>
-          <p:nvPr/>
-        </p:nvSpPr>
-        <p:spPr>
-          <a:xfrm>
-            <a:off x="1709928" y="4055363"/>
-            <a:ext cx="18288" cy="164592"/>
-          </a:xfrm>
-          <a:prstGeom prst="rect">
-            <a:avLst/>
-          </a:prstGeom>
-          <a:solidFill>
-            <a:srgbClr val="00C8F0"/>
-          </a:solidFill>
-          <a:ln>
-            <a:noFill/>
-          </a:ln>
-        </p:spPr>
-        <p:style>
-          <a:lnRef idx="1">
-            <a:schemeClr val="accent1"/>
-          </a:lnRef>
-          <a:fillRef idx="3">
-            <a:schemeClr val="accent1"/>
-          </a:fillRef>
-          <a:effectRef idx="2">
-            <a:schemeClr val="accent1"/>
-          </a:effectRef>
-          <a:fontRef idx="minor">
-            <a:schemeClr val="lt1"/>
-          </a:fontRef>
-        </p:style>
-        <p:txBody>
-          <a:bodyPr rtlCol="0" anchor="ctr"/>
-          <a:lstStyle/>
-          <a:p>
-            <a:pPr algn="ctr"/>
-          </a:p>
-        </p:txBody>
-      </p:sp>
-      <p:sp>
-        <p:nvSpPr>
-          <p:cNvPr id="51" name="Rectangle 50"/>
-          <p:cNvSpPr/>
-          <p:nvPr/>
-        </p:nvSpPr>
-        <p:spPr>
-          <a:xfrm>
-            <a:off x="1726387" y="3971238"/>
-            <a:ext cx="18288" cy="148133"/>
-          </a:xfrm>
-          <a:prstGeom prst="rect">
-            <a:avLst/>
-          </a:prstGeom>
-          <a:solidFill>
-            <a:srgbClr val="00C8F0"/>
-          </a:solidFill>
-          <a:ln>
-            <a:noFill/>
-          </a:ln>
-        </p:spPr>
-        <p:style>
-          <a:lnRef idx="1">
-            <a:schemeClr val="accent1"/>
-          </a:lnRef>
-          <a:fillRef idx="3">
-            <a:schemeClr val="accent1"/>
-          </a:fillRef>
-          <a:effectRef idx="2">
-            <a:schemeClr val="accent1"/>
-          </a:effectRef>
-          <a:fontRef idx="minor">
-            <a:schemeClr val="lt1"/>
-          </a:fontRef>
-        </p:style>
-        <p:txBody>
-          <a:bodyPr rtlCol="0" anchor="ctr"/>
-          <a:lstStyle/>
-          <a:p>
-            <a:pPr algn="ctr"/>
-          </a:p>
-        </p:txBody>
-      </p:sp>
-      <p:sp>
-        <p:nvSpPr>
-          <p:cNvPr id="52" name="Rectangle 51"/>
-          <p:cNvSpPr/>
-          <p:nvPr/>
-        </p:nvSpPr>
-        <p:spPr>
-          <a:xfrm>
-            <a:off x="1726387" y="4038904"/>
-            <a:ext cx="18288" cy="148133"/>
-          </a:xfrm>
-          <a:prstGeom prst="rect">
-            <a:avLst/>
-          </a:prstGeom>
-          <a:solidFill>
-            <a:srgbClr val="00C8F0"/>
-          </a:solidFill>
-          <a:ln>
-            <a:noFill/>
-          </a:ln>
-        </p:spPr>
-        <p:style>
-          <a:lnRef idx="1">
-            <a:schemeClr val="accent1"/>
-          </a:lnRef>
-          <a:fillRef idx="3">
-            <a:schemeClr val="accent1"/>
-          </a:fillRef>
-          <a:effectRef idx="2">
-            <a:schemeClr val="accent1"/>
-          </a:effectRef>
-          <a:fontRef idx="minor">
-            <a:schemeClr val="lt1"/>
-          </a:fontRef>
-        </p:style>
-        <p:txBody>
-          <a:bodyPr rtlCol="0" anchor="ctr"/>
-          <a:lstStyle/>
-          <a:p>
-            <a:pPr algn="ctr"/>
-          </a:p>
-        </p:txBody>
-      </p:sp>
-      <p:sp>
-        <p:nvSpPr>
-          <p:cNvPr id="53" name="Rectangle 52"/>
-          <p:cNvSpPr/>
-          <p:nvPr/>
-        </p:nvSpPr>
-        <p:spPr>
-          <a:xfrm>
-            <a:off x="1742846" y="3987697"/>
-            <a:ext cx="18288" cy="131674"/>
-          </a:xfrm>
-          <a:prstGeom prst="rect">
-            <a:avLst/>
-          </a:prstGeom>
-          <a:solidFill>
-            <a:srgbClr val="00C8F0"/>
-          </a:solidFill>
-          <a:ln>
-            <a:noFill/>
-          </a:ln>
-        </p:spPr>
-        <p:style>
-          <a:lnRef idx="1">
-            <a:schemeClr val="accent1"/>
-          </a:lnRef>
-          <a:fillRef idx="3">
-            <a:schemeClr val="accent1"/>
-          </a:fillRef>
-          <a:effectRef idx="2">
-            <a:schemeClr val="accent1"/>
-          </a:effectRef>
-          <a:fontRef idx="minor">
-            <a:schemeClr val="lt1"/>
-          </a:fontRef>
-        </p:style>
-        <p:txBody>
-          <a:bodyPr rtlCol="0" anchor="ctr"/>
-          <a:lstStyle/>
-          <a:p>
-            <a:pPr algn="ctr"/>
-          </a:p>
-        </p:txBody>
-      </p:sp>
-      <p:sp>
-        <p:nvSpPr>
-          <p:cNvPr id="54" name="Rectangle 53"/>
-          <p:cNvSpPr/>
-          <p:nvPr/>
-        </p:nvSpPr>
-        <p:spPr>
-          <a:xfrm>
-            <a:off x="1742846" y="4022445"/>
-            <a:ext cx="18288" cy="131674"/>
-          </a:xfrm>
-          <a:prstGeom prst="rect">
-            <a:avLst/>
-          </a:prstGeom>
-          <a:solidFill>
-            <a:srgbClr val="00C8F0"/>
-          </a:solidFill>
-          <a:ln>
-            <a:noFill/>
-          </a:ln>
-        </p:spPr>
-        <p:style>
-          <a:lnRef idx="1">
-            <a:schemeClr val="accent1"/>
-          </a:lnRef>
-          <a:fillRef idx="3">
-            <a:schemeClr val="accent1"/>
-          </a:fillRef>
-          <a:effectRef idx="2">
-            <a:schemeClr val="accent1"/>
-          </a:effectRef>
-          <a:fontRef idx="minor">
-            <a:schemeClr val="lt1"/>
-          </a:fontRef>
-        </p:style>
-        <p:txBody>
-          <a:bodyPr rtlCol="0" anchor="ctr"/>
-          <a:lstStyle/>
-          <a:p>
-            <a:pPr algn="ctr"/>
-          </a:p>
-        </p:txBody>
-      </p:sp>
-      <p:sp>
-        <p:nvSpPr>
-          <p:cNvPr id="55" name="Rectangle 54"/>
-          <p:cNvSpPr/>
-          <p:nvPr/>
-        </p:nvSpPr>
-        <p:spPr>
-          <a:xfrm>
-            <a:off x="1759305" y="4004156"/>
-            <a:ext cx="18288" cy="115215"/>
-          </a:xfrm>
-          <a:prstGeom prst="rect">
-            <a:avLst/>
-          </a:prstGeom>
-          <a:solidFill>
-            <a:srgbClr val="00C8F0"/>
-          </a:solidFill>
-          <a:ln>
-            <a:noFill/>
-          </a:ln>
-        </p:spPr>
-        <p:style>
-          <a:lnRef idx="1">
-            <a:schemeClr val="accent1"/>
-          </a:lnRef>
-          <a:fillRef idx="3">
-            <a:schemeClr val="accent1"/>
-          </a:fillRef>
-          <a:effectRef idx="2">
-            <a:schemeClr val="accent1"/>
-          </a:effectRef>
-          <a:fontRef idx="minor">
-            <a:schemeClr val="lt1"/>
-          </a:fontRef>
-        </p:style>
-        <p:txBody>
-          <a:bodyPr rtlCol="0" anchor="ctr"/>
-          <a:lstStyle/>
-          <a:p>
-            <a:pPr algn="ctr"/>
-          </a:p>
-        </p:txBody>
-      </p:sp>
-      <p:sp>
-        <p:nvSpPr>
-          <p:cNvPr id="56" name="Rectangle 55"/>
-          <p:cNvSpPr/>
-          <p:nvPr/>
-        </p:nvSpPr>
-        <p:spPr>
-          <a:xfrm>
-            <a:off x="1759305" y="4005986"/>
-            <a:ext cx="18288" cy="115215"/>
-          </a:xfrm>
-          <a:prstGeom prst="rect">
-            <a:avLst/>
-          </a:prstGeom>
-          <a:solidFill>
-            <a:srgbClr val="00C8F0"/>
-          </a:solidFill>
-          <a:ln>
-            <a:noFill/>
-          </a:ln>
-        </p:spPr>
-        <p:style>
-          <a:lnRef idx="1">
-            <a:schemeClr val="accent1"/>
-          </a:lnRef>
-          <a:fillRef idx="3">
-            <a:schemeClr val="accent1"/>
-          </a:fillRef>
-          <a:effectRef idx="2">
-            <a:schemeClr val="accent1"/>
-          </a:effectRef>
-          <a:fontRef idx="minor">
-            <a:schemeClr val="lt1"/>
-          </a:fontRef>
-        </p:style>
-        <p:txBody>
-          <a:bodyPr rtlCol="0" anchor="ctr"/>
-          <a:lstStyle/>
-          <a:p>
-            <a:pPr algn="ctr"/>
-          </a:p>
-        </p:txBody>
-      </p:sp>
-      <p:sp>
-        <p:nvSpPr>
-          <p:cNvPr id="57" name="Rectangle 56"/>
-          <p:cNvSpPr/>
-          <p:nvPr/>
-        </p:nvSpPr>
-        <p:spPr>
-          <a:xfrm>
-            <a:off x="1775764" y="4020615"/>
-            <a:ext cx="18288" cy="98756"/>
-          </a:xfrm>
-          <a:prstGeom prst="rect">
-            <a:avLst/>
-          </a:prstGeom>
-          <a:solidFill>
-            <a:srgbClr val="00C8F0"/>
-          </a:solidFill>
-          <a:ln>
-            <a:noFill/>
-          </a:ln>
-        </p:spPr>
-        <p:style>
-          <a:lnRef idx="1">
-            <a:schemeClr val="accent1"/>
-          </a:lnRef>
-          <a:fillRef idx="3">
-            <a:schemeClr val="accent1"/>
-          </a:fillRef>
-          <a:effectRef idx="2">
-            <a:schemeClr val="accent1"/>
-          </a:effectRef>
-          <a:fontRef idx="minor">
-            <a:schemeClr val="lt1"/>
-          </a:fontRef>
-        </p:style>
-        <p:txBody>
-          <a:bodyPr rtlCol="0" anchor="ctr"/>
-          <a:lstStyle/>
-          <a:p>
-            <a:pPr algn="ctr"/>
-          </a:p>
-        </p:txBody>
-      </p:sp>
-      <p:sp>
-        <p:nvSpPr>
-          <p:cNvPr id="58" name="Rectangle 57"/>
-          <p:cNvSpPr/>
-          <p:nvPr/>
-        </p:nvSpPr>
-        <p:spPr>
-          <a:xfrm>
-            <a:off x="1775764" y="3989527"/>
-            <a:ext cx="18288" cy="98756"/>
-          </a:xfrm>
-          <a:prstGeom prst="rect">
-            <a:avLst/>
-          </a:prstGeom>
-          <a:solidFill>
-            <a:srgbClr val="00C8F0"/>
-          </a:solidFill>
-          <a:ln>
-            <a:noFill/>
-          </a:ln>
-        </p:spPr>
-        <p:style>
-          <a:lnRef idx="1">
-            <a:schemeClr val="accent1"/>
-          </a:lnRef>
-          <a:fillRef idx="3">
-            <a:schemeClr val="accent1"/>
-          </a:fillRef>
-          <a:effectRef idx="2">
-            <a:schemeClr val="accent1"/>
-          </a:effectRef>
-          <a:fontRef idx="minor">
-            <a:schemeClr val="lt1"/>
-          </a:fontRef>
-        </p:style>
-        <p:txBody>
-          <a:bodyPr rtlCol="0" anchor="ctr"/>
-          <a:lstStyle/>
-          <a:p>
-            <a:pPr algn="ctr"/>
-          </a:p>
-        </p:txBody>
-      </p:sp>
-      <p:sp>
-        <p:nvSpPr>
-          <p:cNvPr id="59" name="Rectangle 58"/>
-          <p:cNvSpPr/>
-          <p:nvPr/>
-        </p:nvSpPr>
-        <p:spPr>
-          <a:xfrm>
-            <a:off x="1792223" y="4037074"/>
-            <a:ext cx="18288" cy="82297"/>
-          </a:xfrm>
-          <a:prstGeom prst="rect">
-            <a:avLst/>
-          </a:prstGeom>
-          <a:solidFill>
-            <a:srgbClr val="00C8F0"/>
-          </a:solidFill>
-          <a:ln>
-            <a:noFill/>
-          </a:ln>
-        </p:spPr>
-        <p:style>
-          <a:lnRef idx="1">
-            <a:schemeClr val="accent1"/>
-          </a:lnRef>
-          <a:fillRef idx="3">
-            <a:schemeClr val="accent1"/>
-          </a:fillRef>
-          <a:effectRef idx="2">
-            <a:schemeClr val="accent1"/>
-          </a:effectRef>
-          <a:fontRef idx="minor">
-            <a:schemeClr val="lt1"/>
-          </a:fontRef>
-        </p:style>
-        <p:txBody>
-          <a:bodyPr rtlCol="0" anchor="ctr"/>
-          <a:lstStyle/>
-          <a:p>
-            <a:pPr algn="ctr"/>
-          </a:p>
-        </p:txBody>
-      </p:sp>
-      <p:sp>
-        <p:nvSpPr>
-          <p:cNvPr id="60" name="Rectangle 59"/>
-          <p:cNvSpPr/>
-          <p:nvPr/>
-        </p:nvSpPr>
-        <p:spPr>
-          <a:xfrm>
-            <a:off x="1792223" y="3973068"/>
-            <a:ext cx="18288" cy="82297"/>
-          </a:xfrm>
-          <a:prstGeom prst="rect">
-            <a:avLst/>
-          </a:prstGeom>
-          <a:solidFill>
-            <a:srgbClr val="00C8F0"/>
-          </a:solidFill>
-          <a:ln>
-            <a:noFill/>
-          </a:ln>
-        </p:spPr>
-        <p:style>
-          <a:lnRef idx="1">
-            <a:schemeClr val="accent1"/>
-          </a:lnRef>
-          <a:fillRef idx="3">
-            <a:schemeClr val="accent1"/>
-          </a:fillRef>
-          <a:effectRef idx="2">
-            <a:schemeClr val="accent1"/>
-          </a:effectRef>
-          <a:fontRef idx="minor">
-            <a:schemeClr val="lt1"/>
-          </a:fontRef>
-        </p:style>
-        <p:txBody>
-          <a:bodyPr rtlCol="0" anchor="ctr"/>
-          <a:lstStyle/>
-          <a:p>
-            <a:pPr algn="ctr"/>
-          </a:p>
-        </p:txBody>
-      </p:sp>
-      <p:sp>
-        <p:nvSpPr>
-          <p:cNvPr id="61" name="Rectangle 60"/>
-          <p:cNvSpPr/>
-          <p:nvPr/>
-        </p:nvSpPr>
-        <p:spPr>
-          <a:xfrm>
-            <a:off x="1808682" y="4053533"/>
-            <a:ext cx="18288" cy="65838"/>
-          </a:xfrm>
-          <a:prstGeom prst="rect">
-            <a:avLst/>
-          </a:prstGeom>
-          <a:solidFill>
-            <a:srgbClr val="00C8F0"/>
-          </a:solidFill>
-          <a:ln>
-            <a:noFill/>
-          </a:ln>
-        </p:spPr>
-        <p:style>
-          <a:lnRef idx="1">
-            <a:schemeClr val="accent1"/>
-          </a:lnRef>
-          <a:fillRef idx="3">
-            <a:schemeClr val="accent1"/>
-          </a:fillRef>
-          <a:effectRef idx="2">
-            <a:schemeClr val="accent1"/>
-          </a:effectRef>
-          <a:fontRef idx="minor">
-            <a:schemeClr val="lt1"/>
-          </a:fontRef>
-        </p:style>
-        <p:txBody>
-          <a:bodyPr rtlCol="0" anchor="ctr"/>
-          <a:lstStyle/>
-          <a:p>
-            <a:pPr algn="ctr"/>
-          </a:p>
-        </p:txBody>
-      </p:sp>
-      <p:sp>
-        <p:nvSpPr>
-          <p:cNvPr id="62" name="Rectangle 61"/>
-          <p:cNvSpPr/>
-          <p:nvPr/>
-        </p:nvSpPr>
-        <p:spPr>
-          <a:xfrm>
-            <a:off x="1808682" y="3956609"/>
-            <a:ext cx="18288" cy="65838"/>
-          </a:xfrm>
-          <a:prstGeom prst="rect">
-            <a:avLst/>
-          </a:prstGeom>
-          <a:solidFill>
-            <a:srgbClr val="00C8F0"/>
-          </a:solidFill>
-          <a:ln>
-            <a:noFill/>
-          </a:ln>
-        </p:spPr>
-        <p:style>
-          <a:lnRef idx="1">
-            <a:schemeClr val="accent1"/>
-          </a:lnRef>
-          <a:fillRef idx="3">
-            <a:schemeClr val="accent1"/>
-          </a:fillRef>
-          <a:effectRef idx="2">
-            <a:schemeClr val="accent1"/>
-          </a:effectRef>
-          <a:fontRef idx="minor">
-            <a:schemeClr val="lt1"/>
-          </a:fontRef>
-        </p:style>
-        <p:txBody>
-          <a:bodyPr rtlCol="0" anchor="ctr"/>
-          <a:lstStyle/>
-          <a:p>
-            <a:pPr algn="ctr"/>
-          </a:p>
-        </p:txBody>
-      </p:sp>
-      <p:sp>
-        <p:nvSpPr>
-          <p:cNvPr id="63" name="Rectangle 62"/>
-          <p:cNvSpPr/>
-          <p:nvPr/>
-        </p:nvSpPr>
-        <p:spPr>
-          <a:xfrm>
-            <a:off x="1825141" y="4069992"/>
-            <a:ext cx="18288" cy="49379"/>
-          </a:xfrm>
-          <a:prstGeom prst="rect">
-            <a:avLst/>
-          </a:prstGeom>
-          <a:solidFill>
-            <a:srgbClr val="00C8F0"/>
-          </a:solidFill>
-          <a:ln>
-            <a:noFill/>
-          </a:ln>
-        </p:spPr>
-        <p:style>
-          <a:lnRef idx="1">
-            <a:schemeClr val="accent1"/>
-          </a:lnRef>
-          <a:fillRef idx="3">
-            <a:schemeClr val="accent1"/>
-          </a:fillRef>
-          <a:effectRef idx="2">
-            <a:schemeClr val="accent1"/>
-          </a:effectRef>
-          <a:fontRef idx="minor">
-            <a:schemeClr val="lt1"/>
-          </a:fontRef>
-        </p:style>
-        <p:txBody>
-          <a:bodyPr rtlCol="0" anchor="ctr"/>
-          <a:lstStyle/>
-          <a:p>
-            <a:pPr algn="ctr"/>
-          </a:p>
-        </p:txBody>
-      </p:sp>
-      <p:sp>
-        <p:nvSpPr>
-          <p:cNvPr id="64" name="Rectangle 63"/>
-          <p:cNvSpPr/>
-          <p:nvPr/>
-        </p:nvSpPr>
-        <p:spPr>
-          <a:xfrm>
-            <a:off x="1825141" y="3940150"/>
-            <a:ext cx="18288" cy="49379"/>
-          </a:xfrm>
-          <a:prstGeom prst="rect">
-            <a:avLst/>
-          </a:prstGeom>
-          <a:solidFill>
-            <a:srgbClr val="00C8F0"/>
-          </a:solidFill>
-          <a:ln>
-            <a:noFill/>
-          </a:ln>
-        </p:spPr>
-        <p:style>
-          <a:lnRef idx="1">
-            <a:schemeClr val="accent1"/>
-          </a:lnRef>
-          <a:fillRef idx="3">
-            <a:schemeClr val="accent1"/>
-          </a:fillRef>
-          <a:effectRef idx="2">
-            <a:schemeClr val="accent1"/>
-          </a:effectRef>
-          <a:fontRef idx="minor">
-            <a:schemeClr val="lt1"/>
-          </a:fontRef>
-        </p:style>
-        <p:txBody>
-          <a:bodyPr rtlCol="0" anchor="ctr"/>
-          <a:lstStyle/>
-          <a:p>
-            <a:pPr algn="ctr"/>
-          </a:p>
-        </p:txBody>
-      </p:sp>
-      <p:sp>
-        <p:nvSpPr>
-          <p:cNvPr id="65" name="Oval 64"/>
-          <p:cNvSpPr/>
-          <p:nvPr/>
-        </p:nvSpPr>
-        <p:spPr>
-          <a:xfrm>
-            <a:off x="2377439" y="3803904"/>
-            <a:ext cx="493776" cy="493776"/>
-          </a:xfrm>
-          <a:prstGeom prst="ellipse">
-            <a:avLst/>
-          </a:prstGeom>
-          <a:solidFill>
-            <a:srgbClr val="FF8C00"/>
-          </a:solidFill>
-          <a:ln>
-            <a:noFill/>
-          </a:ln>
-        </p:spPr>
-        <p:style>
-          <a:lnRef idx="1">
-            <a:schemeClr val="accent1"/>
-          </a:lnRef>
-          <a:fillRef idx="3">
-            <a:schemeClr val="accent1"/>
-          </a:fillRef>
-          <a:effectRef idx="2">
-            <a:schemeClr val="accent1"/>
-          </a:effectRef>
-          <a:fontRef idx="minor">
-            <a:schemeClr val="lt1"/>
-          </a:fontRef>
-        </p:style>
-        <p:txBody>
-          <a:bodyPr rtlCol="0" anchor="ctr"/>
-          <a:lstStyle/>
-          <a:p>
-            <a:pPr algn="ctr"/>
-          </a:p>
-        </p:txBody>
-      </p:sp>
-      <p:sp>
-        <p:nvSpPr>
-          <p:cNvPr id="66" name="TextBox 65"/>
+          <p:cNvPr id="50" name="TextBox 49"/>
           <p:cNvSpPr txBox="1"/>
           <p:nvPr/>
         </p:nvSpPr>
@@ -5830,7 +5142,7 @@
       </p:sp>
       <p:sp>
         <p:nvSpPr>
-          <p:cNvPr id="67" name="Rounded Rectangle 66"/>
+          <p:cNvPr id="51" name="Rounded Rectangle 50"/>
           <p:cNvSpPr/>
           <p:nvPr/>
         </p:nvSpPr>
@@ -5873,7 +5185,7 @@
       </p:sp>
       <p:sp>
         <p:nvSpPr>
-          <p:cNvPr id="68" name="TextBox 67"/>
+          <p:cNvPr id="52" name="TextBox 51"/>
           <p:cNvSpPr txBox="1"/>
           <p:nvPr/>
         </p:nvSpPr>
@@ -5909,16 +5221,16 @@
       </p:sp>
       <p:sp>
         <p:nvSpPr>
-          <p:cNvPr id="69" name="Rectangle 68"/>
+          <p:cNvPr id="53" name="Right Arrow 52"/>
           <p:cNvSpPr/>
           <p:nvPr/>
         </p:nvSpPr>
         <p:spPr>
           <a:xfrm>
-            <a:off x="2999231" y="4023359"/>
-            <a:ext cx="585216" cy="32004"/>
-          </a:xfrm>
-          <a:prstGeom prst="rect">
+            <a:off x="3063239" y="3959352"/>
+            <a:ext cx="960120" cy="182880"/>
+          </a:xfrm>
+          <a:prstGeom prst="rightArrow">
             <a:avLst/>
           </a:prstGeom>
           <a:solidFill>
@@ -5952,20 +5264,20 @@
       </p:sp>
       <p:sp>
         <p:nvSpPr>
-          <p:cNvPr id="70" name="Rectangle 69"/>
+          <p:cNvPr id="54" name="Oval 53"/>
           <p:cNvSpPr/>
           <p:nvPr/>
         </p:nvSpPr>
         <p:spPr>
           <a:xfrm>
-            <a:off x="3584447" y="3954779"/>
-            <a:ext cx="18288" cy="164592"/>
-          </a:xfrm>
-          <a:prstGeom prst="rect">
-            <a:avLst/>
-          </a:prstGeom>
-          <a:solidFill>
-            <a:srgbClr val="00C8F0"/>
+            <a:off x="4251959" y="3803904"/>
+            <a:ext cx="493776" cy="493776"/>
+          </a:xfrm>
+          <a:prstGeom prst="ellipse">
+            <a:avLst/>
+          </a:prstGeom>
+          <a:solidFill>
+            <a:srgbClr val="8B5CF6"/>
           </a:solidFill>
           <a:ln>
             <a:noFill/>
@@ -5995,695 +5307,7 @@
       </p:sp>
       <p:sp>
         <p:nvSpPr>
-          <p:cNvPr id="71" name="Rectangle 70"/>
-          <p:cNvSpPr/>
-          <p:nvPr/>
-        </p:nvSpPr>
-        <p:spPr>
-          <a:xfrm>
-            <a:off x="3584447" y="4055363"/>
-            <a:ext cx="18288" cy="164592"/>
-          </a:xfrm>
-          <a:prstGeom prst="rect">
-            <a:avLst/>
-          </a:prstGeom>
-          <a:solidFill>
-            <a:srgbClr val="00C8F0"/>
-          </a:solidFill>
-          <a:ln>
-            <a:noFill/>
-          </a:ln>
-        </p:spPr>
-        <p:style>
-          <a:lnRef idx="1">
-            <a:schemeClr val="accent1"/>
-          </a:lnRef>
-          <a:fillRef idx="3">
-            <a:schemeClr val="accent1"/>
-          </a:fillRef>
-          <a:effectRef idx="2">
-            <a:schemeClr val="accent1"/>
-          </a:effectRef>
-          <a:fontRef idx="minor">
-            <a:schemeClr val="lt1"/>
-          </a:fontRef>
-        </p:style>
-        <p:txBody>
-          <a:bodyPr rtlCol="0" anchor="ctr"/>
-          <a:lstStyle/>
-          <a:p>
-            <a:pPr algn="ctr"/>
-          </a:p>
-        </p:txBody>
-      </p:sp>
-      <p:sp>
-        <p:nvSpPr>
-          <p:cNvPr id="72" name="Rectangle 71"/>
-          <p:cNvSpPr/>
-          <p:nvPr/>
-        </p:nvSpPr>
-        <p:spPr>
-          <a:xfrm>
-            <a:off x="3600906" y="3971238"/>
-            <a:ext cx="18288" cy="148133"/>
-          </a:xfrm>
-          <a:prstGeom prst="rect">
-            <a:avLst/>
-          </a:prstGeom>
-          <a:solidFill>
-            <a:srgbClr val="00C8F0"/>
-          </a:solidFill>
-          <a:ln>
-            <a:noFill/>
-          </a:ln>
-        </p:spPr>
-        <p:style>
-          <a:lnRef idx="1">
-            <a:schemeClr val="accent1"/>
-          </a:lnRef>
-          <a:fillRef idx="3">
-            <a:schemeClr val="accent1"/>
-          </a:fillRef>
-          <a:effectRef idx="2">
-            <a:schemeClr val="accent1"/>
-          </a:effectRef>
-          <a:fontRef idx="minor">
-            <a:schemeClr val="lt1"/>
-          </a:fontRef>
-        </p:style>
-        <p:txBody>
-          <a:bodyPr rtlCol="0" anchor="ctr"/>
-          <a:lstStyle/>
-          <a:p>
-            <a:pPr algn="ctr"/>
-          </a:p>
-        </p:txBody>
-      </p:sp>
-      <p:sp>
-        <p:nvSpPr>
-          <p:cNvPr id="73" name="Rectangle 72"/>
-          <p:cNvSpPr/>
-          <p:nvPr/>
-        </p:nvSpPr>
-        <p:spPr>
-          <a:xfrm>
-            <a:off x="3600906" y="4038904"/>
-            <a:ext cx="18288" cy="148133"/>
-          </a:xfrm>
-          <a:prstGeom prst="rect">
-            <a:avLst/>
-          </a:prstGeom>
-          <a:solidFill>
-            <a:srgbClr val="00C8F0"/>
-          </a:solidFill>
-          <a:ln>
-            <a:noFill/>
-          </a:ln>
-        </p:spPr>
-        <p:style>
-          <a:lnRef idx="1">
-            <a:schemeClr val="accent1"/>
-          </a:lnRef>
-          <a:fillRef idx="3">
-            <a:schemeClr val="accent1"/>
-          </a:fillRef>
-          <a:effectRef idx="2">
-            <a:schemeClr val="accent1"/>
-          </a:effectRef>
-          <a:fontRef idx="minor">
-            <a:schemeClr val="lt1"/>
-          </a:fontRef>
-        </p:style>
-        <p:txBody>
-          <a:bodyPr rtlCol="0" anchor="ctr"/>
-          <a:lstStyle/>
-          <a:p>
-            <a:pPr algn="ctr"/>
-          </a:p>
-        </p:txBody>
-      </p:sp>
-      <p:sp>
-        <p:nvSpPr>
-          <p:cNvPr id="74" name="Rectangle 73"/>
-          <p:cNvSpPr/>
-          <p:nvPr/>
-        </p:nvSpPr>
-        <p:spPr>
-          <a:xfrm>
-            <a:off x="3617365" y="3987697"/>
-            <a:ext cx="18288" cy="131674"/>
-          </a:xfrm>
-          <a:prstGeom prst="rect">
-            <a:avLst/>
-          </a:prstGeom>
-          <a:solidFill>
-            <a:srgbClr val="00C8F0"/>
-          </a:solidFill>
-          <a:ln>
-            <a:noFill/>
-          </a:ln>
-        </p:spPr>
-        <p:style>
-          <a:lnRef idx="1">
-            <a:schemeClr val="accent1"/>
-          </a:lnRef>
-          <a:fillRef idx="3">
-            <a:schemeClr val="accent1"/>
-          </a:fillRef>
-          <a:effectRef idx="2">
-            <a:schemeClr val="accent1"/>
-          </a:effectRef>
-          <a:fontRef idx="minor">
-            <a:schemeClr val="lt1"/>
-          </a:fontRef>
-        </p:style>
-        <p:txBody>
-          <a:bodyPr rtlCol="0" anchor="ctr"/>
-          <a:lstStyle/>
-          <a:p>
-            <a:pPr algn="ctr"/>
-          </a:p>
-        </p:txBody>
-      </p:sp>
-      <p:sp>
-        <p:nvSpPr>
-          <p:cNvPr id="75" name="Rectangle 74"/>
-          <p:cNvSpPr/>
-          <p:nvPr/>
-        </p:nvSpPr>
-        <p:spPr>
-          <a:xfrm>
-            <a:off x="3617365" y="4022445"/>
-            <a:ext cx="18288" cy="131674"/>
-          </a:xfrm>
-          <a:prstGeom prst="rect">
-            <a:avLst/>
-          </a:prstGeom>
-          <a:solidFill>
-            <a:srgbClr val="00C8F0"/>
-          </a:solidFill>
-          <a:ln>
-            <a:noFill/>
-          </a:ln>
-        </p:spPr>
-        <p:style>
-          <a:lnRef idx="1">
-            <a:schemeClr val="accent1"/>
-          </a:lnRef>
-          <a:fillRef idx="3">
-            <a:schemeClr val="accent1"/>
-          </a:fillRef>
-          <a:effectRef idx="2">
-            <a:schemeClr val="accent1"/>
-          </a:effectRef>
-          <a:fontRef idx="minor">
-            <a:schemeClr val="lt1"/>
-          </a:fontRef>
-        </p:style>
-        <p:txBody>
-          <a:bodyPr rtlCol="0" anchor="ctr"/>
-          <a:lstStyle/>
-          <a:p>
-            <a:pPr algn="ctr"/>
-          </a:p>
-        </p:txBody>
-      </p:sp>
-      <p:sp>
-        <p:nvSpPr>
-          <p:cNvPr id="76" name="Rectangle 75"/>
-          <p:cNvSpPr/>
-          <p:nvPr/>
-        </p:nvSpPr>
-        <p:spPr>
-          <a:xfrm>
-            <a:off x="3633824" y="4004156"/>
-            <a:ext cx="18288" cy="115215"/>
-          </a:xfrm>
-          <a:prstGeom prst="rect">
-            <a:avLst/>
-          </a:prstGeom>
-          <a:solidFill>
-            <a:srgbClr val="00C8F0"/>
-          </a:solidFill>
-          <a:ln>
-            <a:noFill/>
-          </a:ln>
-        </p:spPr>
-        <p:style>
-          <a:lnRef idx="1">
-            <a:schemeClr val="accent1"/>
-          </a:lnRef>
-          <a:fillRef idx="3">
-            <a:schemeClr val="accent1"/>
-          </a:fillRef>
-          <a:effectRef idx="2">
-            <a:schemeClr val="accent1"/>
-          </a:effectRef>
-          <a:fontRef idx="minor">
-            <a:schemeClr val="lt1"/>
-          </a:fontRef>
-        </p:style>
-        <p:txBody>
-          <a:bodyPr rtlCol="0" anchor="ctr"/>
-          <a:lstStyle/>
-          <a:p>
-            <a:pPr algn="ctr"/>
-          </a:p>
-        </p:txBody>
-      </p:sp>
-      <p:sp>
-        <p:nvSpPr>
-          <p:cNvPr id="77" name="Rectangle 76"/>
-          <p:cNvSpPr/>
-          <p:nvPr/>
-        </p:nvSpPr>
-        <p:spPr>
-          <a:xfrm>
-            <a:off x="3633824" y="4005986"/>
-            <a:ext cx="18288" cy="115215"/>
-          </a:xfrm>
-          <a:prstGeom prst="rect">
-            <a:avLst/>
-          </a:prstGeom>
-          <a:solidFill>
-            <a:srgbClr val="00C8F0"/>
-          </a:solidFill>
-          <a:ln>
-            <a:noFill/>
-          </a:ln>
-        </p:spPr>
-        <p:style>
-          <a:lnRef idx="1">
-            <a:schemeClr val="accent1"/>
-          </a:lnRef>
-          <a:fillRef idx="3">
-            <a:schemeClr val="accent1"/>
-          </a:fillRef>
-          <a:effectRef idx="2">
-            <a:schemeClr val="accent1"/>
-          </a:effectRef>
-          <a:fontRef idx="minor">
-            <a:schemeClr val="lt1"/>
-          </a:fontRef>
-        </p:style>
-        <p:txBody>
-          <a:bodyPr rtlCol="0" anchor="ctr"/>
-          <a:lstStyle/>
-          <a:p>
-            <a:pPr algn="ctr"/>
-          </a:p>
-        </p:txBody>
-      </p:sp>
-      <p:sp>
-        <p:nvSpPr>
-          <p:cNvPr id="78" name="Rectangle 77"/>
-          <p:cNvSpPr/>
-          <p:nvPr/>
-        </p:nvSpPr>
-        <p:spPr>
-          <a:xfrm>
-            <a:off x="3650283" y="4020615"/>
-            <a:ext cx="18288" cy="98756"/>
-          </a:xfrm>
-          <a:prstGeom prst="rect">
-            <a:avLst/>
-          </a:prstGeom>
-          <a:solidFill>
-            <a:srgbClr val="00C8F0"/>
-          </a:solidFill>
-          <a:ln>
-            <a:noFill/>
-          </a:ln>
-        </p:spPr>
-        <p:style>
-          <a:lnRef idx="1">
-            <a:schemeClr val="accent1"/>
-          </a:lnRef>
-          <a:fillRef idx="3">
-            <a:schemeClr val="accent1"/>
-          </a:fillRef>
-          <a:effectRef idx="2">
-            <a:schemeClr val="accent1"/>
-          </a:effectRef>
-          <a:fontRef idx="minor">
-            <a:schemeClr val="lt1"/>
-          </a:fontRef>
-        </p:style>
-        <p:txBody>
-          <a:bodyPr rtlCol="0" anchor="ctr"/>
-          <a:lstStyle/>
-          <a:p>
-            <a:pPr algn="ctr"/>
-          </a:p>
-        </p:txBody>
-      </p:sp>
-      <p:sp>
-        <p:nvSpPr>
-          <p:cNvPr id="79" name="Rectangle 78"/>
-          <p:cNvSpPr/>
-          <p:nvPr/>
-        </p:nvSpPr>
-        <p:spPr>
-          <a:xfrm>
-            <a:off x="3650283" y="3989527"/>
-            <a:ext cx="18288" cy="98756"/>
-          </a:xfrm>
-          <a:prstGeom prst="rect">
-            <a:avLst/>
-          </a:prstGeom>
-          <a:solidFill>
-            <a:srgbClr val="00C8F0"/>
-          </a:solidFill>
-          <a:ln>
-            <a:noFill/>
-          </a:ln>
-        </p:spPr>
-        <p:style>
-          <a:lnRef idx="1">
-            <a:schemeClr val="accent1"/>
-          </a:lnRef>
-          <a:fillRef idx="3">
-            <a:schemeClr val="accent1"/>
-          </a:fillRef>
-          <a:effectRef idx="2">
-            <a:schemeClr val="accent1"/>
-          </a:effectRef>
-          <a:fontRef idx="minor">
-            <a:schemeClr val="lt1"/>
-          </a:fontRef>
-        </p:style>
-        <p:txBody>
-          <a:bodyPr rtlCol="0" anchor="ctr"/>
-          <a:lstStyle/>
-          <a:p>
-            <a:pPr algn="ctr"/>
-          </a:p>
-        </p:txBody>
-      </p:sp>
-      <p:sp>
-        <p:nvSpPr>
-          <p:cNvPr id="80" name="Rectangle 79"/>
-          <p:cNvSpPr/>
-          <p:nvPr/>
-        </p:nvSpPr>
-        <p:spPr>
-          <a:xfrm>
-            <a:off x="3666742" y="4037074"/>
-            <a:ext cx="18288" cy="82297"/>
-          </a:xfrm>
-          <a:prstGeom prst="rect">
-            <a:avLst/>
-          </a:prstGeom>
-          <a:solidFill>
-            <a:srgbClr val="00C8F0"/>
-          </a:solidFill>
-          <a:ln>
-            <a:noFill/>
-          </a:ln>
-        </p:spPr>
-        <p:style>
-          <a:lnRef idx="1">
-            <a:schemeClr val="accent1"/>
-          </a:lnRef>
-          <a:fillRef idx="3">
-            <a:schemeClr val="accent1"/>
-          </a:fillRef>
-          <a:effectRef idx="2">
-            <a:schemeClr val="accent1"/>
-          </a:effectRef>
-          <a:fontRef idx="minor">
-            <a:schemeClr val="lt1"/>
-          </a:fontRef>
-        </p:style>
-        <p:txBody>
-          <a:bodyPr rtlCol="0" anchor="ctr"/>
-          <a:lstStyle/>
-          <a:p>
-            <a:pPr algn="ctr"/>
-          </a:p>
-        </p:txBody>
-      </p:sp>
-      <p:sp>
-        <p:nvSpPr>
-          <p:cNvPr id="81" name="Rectangle 80"/>
-          <p:cNvSpPr/>
-          <p:nvPr/>
-        </p:nvSpPr>
-        <p:spPr>
-          <a:xfrm>
-            <a:off x="3666742" y="3973068"/>
-            <a:ext cx="18288" cy="82297"/>
-          </a:xfrm>
-          <a:prstGeom prst="rect">
-            <a:avLst/>
-          </a:prstGeom>
-          <a:solidFill>
-            <a:srgbClr val="00C8F0"/>
-          </a:solidFill>
-          <a:ln>
-            <a:noFill/>
-          </a:ln>
-        </p:spPr>
-        <p:style>
-          <a:lnRef idx="1">
-            <a:schemeClr val="accent1"/>
-          </a:lnRef>
-          <a:fillRef idx="3">
-            <a:schemeClr val="accent1"/>
-          </a:fillRef>
-          <a:effectRef idx="2">
-            <a:schemeClr val="accent1"/>
-          </a:effectRef>
-          <a:fontRef idx="minor">
-            <a:schemeClr val="lt1"/>
-          </a:fontRef>
-        </p:style>
-        <p:txBody>
-          <a:bodyPr rtlCol="0" anchor="ctr"/>
-          <a:lstStyle/>
-          <a:p>
-            <a:pPr algn="ctr"/>
-          </a:p>
-        </p:txBody>
-      </p:sp>
-      <p:sp>
-        <p:nvSpPr>
-          <p:cNvPr id="82" name="Rectangle 81"/>
-          <p:cNvSpPr/>
-          <p:nvPr/>
-        </p:nvSpPr>
-        <p:spPr>
-          <a:xfrm>
-            <a:off x="3683201" y="4053533"/>
-            <a:ext cx="18288" cy="65838"/>
-          </a:xfrm>
-          <a:prstGeom prst="rect">
-            <a:avLst/>
-          </a:prstGeom>
-          <a:solidFill>
-            <a:srgbClr val="00C8F0"/>
-          </a:solidFill>
-          <a:ln>
-            <a:noFill/>
-          </a:ln>
-        </p:spPr>
-        <p:style>
-          <a:lnRef idx="1">
-            <a:schemeClr val="accent1"/>
-          </a:lnRef>
-          <a:fillRef idx="3">
-            <a:schemeClr val="accent1"/>
-          </a:fillRef>
-          <a:effectRef idx="2">
-            <a:schemeClr val="accent1"/>
-          </a:effectRef>
-          <a:fontRef idx="minor">
-            <a:schemeClr val="lt1"/>
-          </a:fontRef>
-        </p:style>
-        <p:txBody>
-          <a:bodyPr rtlCol="0" anchor="ctr"/>
-          <a:lstStyle/>
-          <a:p>
-            <a:pPr algn="ctr"/>
-          </a:p>
-        </p:txBody>
-      </p:sp>
-      <p:sp>
-        <p:nvSpPr>
-          <p:cNvPr id="83" name="Rectangle 82"/>
-          <p:cNvSpPr/>
-          <p:nvPr/>
-        </p:nvSpPr>
-        <p:spPr>
-          <a:xfrm>
-            <a:off x="3683201" y="3956609"/>
-            <a:ext cx="18288" cy="65838"/>
-          </a:xfrm>
-          <a:prstGeom prst="rect">
-            <a:avLst/>
-          </a:prstGeom>
-          <a:solidFill>
-            <a:srgbClr val="00C8F0"/>
-          </a:solidFill>
-          <a:ln>
-            <a:noFill/>
-          </a:ln>
-        </p:spPr>
-        <p:style>
-          <a:lnRef idx="1">
-            <a:schemeClr val="accent1"/>
-          </a:lnRef>
-          <a:fillRef idx="3">
-            <a:schemeClr val="accent1"/>
-          </a:fillRef>
-          <a:effectRef idx="2">
-            <a:schemeClr val="accent1"/>
-          </a:effectRef>
-          <a:fontRef idx="minor">
-            <a:schemeClr val="lt1"/>
-          </a:fontRef>
-        </p:style>
-        <p:txBody>
-          <a:bodyPr rtlCol="0" anchor="ctr"/>
-          <a:lstStyle/>
-          <a:p>
-            <a:pPr algn="ctr"/>
-          </a:p>
-        </p:txBody>
-      </p:sp>
-      <p:sp>
-        <p:nvSpPr>
-          <p:cNvPr id="84" name="Rectangle 83"/>
-          <p:cNvSpPr/>
-          <p:nvPr/>
-        </p:nvSpPr>
-        <p:spPr>
-          <a:xfrm>
-            <a:off x="3699660" y="4069992"/>
-            <a:ext cx="18288" cy="49379"/>
-          </a:xfrm>
-          <a:prstGeom prst="rect">
-            <a:avLst/>
-          </a:prstGeom>
-          <a:solidFill>
-            <a:srgbClr val="00C8F0"/>
-          </a:solidFill>
-          <a:ln>
-            <a:noFill/>
-          </a:ln>
-        </p:spPr>
-        <p:style>
-          <a:lnRef idx="1">
-            <a:schemeClr val="accent1"/>
-          </a:lnRef>
-          <a:fillRef idx="3">
-            <a:schemeClr val="accent1"/>
-          </a:fillRef>
-          <a:effectRef idx="2">
-            <a:schemeClr val="accent1"/>
-          </a:effectRef>
-          <a:fontRef idx="minor">
-            <a:schemeClr val="lt1"/>
-          </a:fontRef>
-        </p:style>
-        <p:txBody>
-          <a:bodyPr rtlCol="0" anchor="ctr"/>
-          <a:lstStyle/>
-          <a:p>
-            <a:pPr algn="ctr"/>
-          </a:p>
-        </p:txBody>
-      </p:sp>
-      <p:sp>
-        <p:nvSpPr>
-          <p:cNvPr id="85" name="Rectangle 84"/>
-          <p:cNvSpPr/>
-          <p:nvPr/>
-        </p:nvSpPr>
-        <p:spPr>
-          <a:xfrm>
-            <a:off x="3699660" y="3940150"/>
-            <a:ext cx="18288" cy="49379"/>
-          </a:xfrm>
-          <a:prstGeom prst="rect">
-            <a:avLst/>
-          </a:prstGeom>
-          <a:solidFill>
-            <a:srgbClr val="00C8F0"/>
-          </a:solidFill>
-          <a:ln>
-            <a:noFill/>
-          </a:ln>
-        </p:spPr>
-        <p:style>
-          <a:lnRef idx="1">
-            <a:schemeClr val="accent1"/>
-          </a:lnRef>
-          <a:fillRef idx="3">
-            <a:schemeClr val="accent1"/>
-          </a:fillRef>
-          <a:effectRef idx="2">
-            <a:schemeClr val="accent1"/>
-          </a:effectRef>
-          <a:fontRef idx="minor">
-            <a:schemeClr val="lt1"/>
-          </a:fontRef>
-        </p:style>
-        <p:txBody>
-          <a:bodyPr rtlCol="0" anchor="ctr"/>
-          <a:lstStyle/>
-          <a:p>
-            <a:pPr algn="ctr"/>
-          </a:p>
-        </p:txBody>
-      </p:sp>
-      <p:sp>
-        <p:nvSpPr>
-          <p:cNvPr id="86" name="Oval 85"/>
-          <p:cNvSpPr/>
-          <p:nvPr/>
-        </p:nvSpPr>
-        <p:spPr>
-          <a:xfrm>
-            <a:off x="4251959" y="3803904"/>
-            <a:ext cx="493776" cy="493776"/>
-          </a:xfrm>
-          <a:prstGeom prst="ellipse">
-            <a:avLst/>
-          </a:prstGeom>
-          <a:solidFill>
-            <a:srgbClr val="8B5CF6"/>
-          </a:solidFill>
-          <a:ln>
-            <a:noFill/>
-          </a:ln>
-        </p:spPr>
-        <p:style>
-          <a:lnRef idx="1">
-            <a:schemeClr val="accent1"/>
-          </a:lnRef>
-          <a:fillRef idx="3">
-            <a:schemeClr val="accent1"/>
-          </a:fillRef>
-          <a:effectRef idx="2">
-            <a:schemeClr val="accent1"/>
-          </a:effectRef>
-          <a:fontRef idx="minor">
-            <a:schemeClr val="lt1"/>
-          </a:fontRef>
-        </p:style>
-        <p:txBody>
-          <a:bodyPr rtlCol="0" anchor="ctr"/>
-          <a:lstStyle/>
-          <a:p>
-            <a:pPr algn="ctr"/>
-          </a:p>
-        </p:txBody>
-      </p:sp>
-      <p:sp>
-        <p:nvSpPr>
-          <p:cNvPr id="87" name="TextBox 86"/>
+          <p:cNvPr id="55" name="TextBox 54"/>
           <p:cNvSpPr txBox="1"/>
           <p:nvPr/>
         </p:nvSpPr>
@@ -6718,7 +5342,7 @@
       </p:sp>
       <p:sp>
         <p:nvSpPr>
-          <p:cNvPr id="88" name="Rounded Rectangle 87"/>
+          <p:cNvPr id="56" name="Rounded Rectangle 55"/>
           <p:cNvSpPr/>
           <p:nvPr/>
         </p:nvSpPr>
@@ -6761,7 +5385,7 @@
       </p:sp>
       <p:sp>
         <p:nvSpPr>
-          <p:cNvPr id="89" name="TextBox 88"/>
+          <p:cNvPr id="57" name="TextBox 56"/>
           <p:cNvSpPr txBox="1"/>
           <p:nvPr/>
         </p:nvSpPr>
@@ -6797,16 +5421,16 @@
       </p:sp>
       <p:sp>
         <p:nvSpPr>
-          <p:cNvPr id="90" name="Rectangle 89"/>
+          <p:cNvPr id="58" name="Right Arrow 57"/>
           <p:cNvSpPr/>
           <p:nvPr/>
         </p:nvSpPr>
         <p:spPr>
           <a:xfrm>
-            <a:off x="4873751" y="4023359"/>
-            <a:ext cx="585216" cy="32004"/>
-          </a:xfrm>
-          <a:prstGeom prst="rect">
+            <a:off x="4937759" y="3959352"/>
+            <a:ext cx="960120" cy="182880"/>
+          </a:xfrm>
+          <a:prstGeom prst="rightArrow">
             <a:avLst/>
           </a:prstGeom>
           <a:solidFill>
@@ -6840,20 +5464,20 @@
       </p:sp>
       <p:sp>
         <p:nvSpPr>
-          <p:cNvPr id="91" name="Rectangle 90"/>
+          <p:cNvPr id="59" name="Oval 58"/>
           <p:cNvSpPr/>
           <p:nvPr/>
         </p:nvSpPr>
         <p:spPr>
           <a:xfrm>
-            <a:off x="5458967" y="3954779"/>
-            <a:ext cx="18288" cy="164592"/>
-          </a:xfrm>
-          <a:prstGeom prst="rect">
-            <a:avLst/>
-          </a:prstGeom>
-          <a:solidFill>
-            <a:srgbClr val="00C8F0"/>
+            <a:off x="6126479" y="3803904"/>
+            <a:ext cx="493776" cy="493776"/>
+          </a:xfrm>
+          <a:prstGeom prst="ellipse">
+            <a:avLst/>
+          </a:prstGeom>
+          <a:solidFill>
+            <a:srgbClr val="00A89A"/>
           </a:solidFill>
           <a:ln>
             <a:noFill/>
@@ -6883,695 +5507,7 @@
       </p:sp>
       <p:sp>
         <p:nvSpPr>
-          <p:cNvPr id="92" name="Rectangle 91"/>
-          <p:cNvSpPr/>
-          <p:nvPr/>
-        </p:nvSpPr>
-        <p:spPr>
-          <a:xfrm>
-            <a:off x="5458967" y="4055363"/>
-            <a:ext cx="18288" cy="164592"/>
-          </a:xfrm>
-          <a:prstGeom prst="rect">
-            <a:avLst/>
-          </a:prstGeom>
-          <a:solidFill>
-            <a:srgbClr val="00C8F0"/>
-          </a:solidFill>
-          <a:ln>
-            <a:noFill/>
-          </a:ln>
-        </p:spPr>
-        <p:style>
-          <a:lnRef idx="1">
-            <a:schemeClr val="accent1"/>
-          </a:lnRef>
-          <a:fillRef idx="3">
-            <a:schemeClr val="accent1"/>
-          </a:fillRef>
-          <a:effectRef idx="2">
-            <a:schemeClr val="accent1"/>
-          </a:effectRef>
-          <a:fontRef idx="minor">
-            <a:schemeClr val="lt1"/>
-          </a:fontRef>
-        </p:style>
-        <p:txBody>
-          <a:bodyPr rtlCol="0" anchor="ctr"/>
-          <a:lstStyle/>
-          <a:p>
-            <a:pPr algn="ctr"/>
-          </a:p>
-        </p:txBody>
-      </p:sp>
-      <p:sp>
-        <p:nvSpPr>
-          <p:cNvPr id="93" name="Rectangle 92"/>
-          <p:cNvSpPr/>
-          <p:nvPr/>
-        </p:nvSpPr>
-        <p:spPr>
-          <a:xfrm>
-            <a:off x="5475426" y="3971238"/>
-            <a:ext cx="18288" cy="148133"/>
-          </a:xfrm>
-          <a:prstGeom prst="rect">
-            <a:avLst/>
-          </a:prstGeom>
-          <a:solidFill>
-            <a:srgbClr val="00C8F0"/>
-          </a:solidFill>
-          <a:ln>
-            <a:noFill/>
-          </a:ln>
-        </p:spPr>
-        <p:style>
-          <a:lnRef idx="1">
-            <a:schemeClr val="accent1"/>
-          </a:lnRef>
-          <a:fillRef idx="3">
-            <a:schemeClr val="accent1"/>
-          </a:fillRef>
-          <a:effectRef idx="2">
-            <a:schemeClr val="accent1"/>
-          </a:effectRef>
-          <a:fontRef idx="minor">
-            <a:schemeClr val="lt1"/>
-          </a:fontRef>
-        </p:style>
-        <p:txBody>
-          <a:bodyPr rtlCol="0" anchor="ctr"/>
-          <a:lstStyle/>
-          <a:p>
-            <a:pPr algn="ctr"/>
-          </a:p>
-        </p:txBody>
-      </p:sp>
-      <p:sp>
-        <p:nvSpPr>
-          <p:cNvPr id="94" name="Rectangle 93"/>
-          <p:cNvSpPr/>
-          <p:nvPr/>
-        </p:nvSpPr>
-        <p:spPr>
-          <a:xfrm>
-            <a:off x="5475426" y="4038904"/>
-            <a:ext cx="18288" cy="148133"/>
-          </a:xfrm>
-          <a:prstGeom prst="rect">
-            <a:avLst/>
-          </a:prstGeom>
-          <a:solidFill>
-            <a:srgbClr val="00C8F0"/>
-          </a:solidFill>
-          <a:ln>
-            <a:noFill/>
-          </a:ln>
-        </p:spPr>
-        <p:style>
-          <a:lnRef idx="1">
-            <a:schemeClr val="accent1"/>
-          </a:lnRef>
-          <a:fillRef idx="3">
-            <a:schemeClr val="accent1"/>
-          </a:fillRef>
-          <a:effectRef idx="2">
-            <a:schemeClr val="accent1"/>
-          </a:effectRef>
-          <a:fontRef idx="minor">
-            <a:schemeClr val="lt1"/>
-          </a:fontRef>
-        </p:style>
-        <p:txBody>
-          <a:bodyPr rtlCol="0" anchor="ctr"/>
-          <a:lstStyle/>
-          <a:p>
-            <a:pPr algn="ctr"/>
-          </a:p>
-        </p:txBody>
-      </p:sp>
-      <p:sp>
-        <p:nvSpPr>
-          <p:cNvPr id="95" name="Rectangle 94"/>
-          <p:cNvSpPr/>
-          <p:nvPr/>
-        </p:nvSpPr>
-        <p:spPr>
-          <a:xfrm>
-            <a:off x="5491885" y="3987697"/>
-            <a:ext cx="18288" cy="131674"/>
-          </a:xfrm>
-          <a:prstGeom prst="rect">
-            <a:avLst/>
-          </a:prstGeom>
-          <a:solidFill>
-            <a:srgbClr val="00C8F0"/>
-          </a:solidFill>
-          <a:ln>
-            <a:noFill/>
-          </a:ln>
-        </p:spPr>
-        <p:style>
-          <a:lnRef idx="1">
-            <a:schemeClr val="accent1"/>
-          </a:lnRef>
-          <a:fillRef idx="3">
-            <a:schemeClr val="accent1"/>
-          </a:fillRef>
-          <a:effectRef idx="2">
-            <a:schemeClr val="accent1"/>
-          </a:effectRef>
-          <a:fontRef idx="minor">
-            <a:schemeClr val="lt1"/>
-          </a:fontRef>
-        </p:style>
-        <p:txBody>
-          <a:bodyPr rtlCol="0" anchor="ctr"/>
-          <a:lstStyle/>
-          <a:p>
-            <a:pPr algn="ctr"/>
-          </a:p>
-        </p:txBody>
-      </p:sp>
-      <p:sp>
-        <p:nvSpPr>
-          <p:cNvPr id="96" name="Rectangle 95"/>
-          <p:cNvSpPr/>
-          <p:nvPr/>
-        </p:nvSpPr>
-        <p:spPr>
-          <a:xfrm>
-            <a:off x="5491885" y="4022445"/>
-            <a:ext cx="18288" cy="131674"/>
-          </a:xfrm>
-          <a:prstGeom prst="rect">
-            <a:avLst/>
-          </a:prstGeom>
-          <a:solidFill>
-            <a:srgbClr val="00C8F0"/>
-          </a:solidFill>
-          <a:ln>
-            <a:noFill/>
-          </a:ln>
-        </p:spPr>
-        <p:style>
-          <a:lnRef idx="1">
-            <a:schemeClr val="accent1"/>
-          </a:lnRef>
-          <a:fillRef idx="3">
-            <a:schemeClr val="accent1"/>
-          </a:fillRef>
-          <a:effectRef idx="2">
-            <a:schemeClr val="accent1"/>
-          </a:effectRef>
-          <a:fontRef idx="minor">
-            <a:schemeClr val="lt1"/>
-          </a:fontRef>
-        </p:style>
-        <p:txBody>
-          <a:bodyPr rtlCol="0" anchor="ctr"/>
-          <a:lstStyle/>
-          <a:p>
-            <a:pPr algn="ctr"/>
-          </a:p>
-        </p:txBody>
-      </p:sp>
-      <p:sp>
-        <p:nvSpPr>
-          <p:cNvPr id="97" name="Rectangle 96"/>
-          <p:cNvSpPr/>
-          <p:nvPr/>
-        </p:nvSpPr>
-        <p:spPr>
-          <a:xfrm>
-            <a:off x="5508344" y="4004156"/>
-            <a:ext cx="18288" cy="115215"/>
-          </a:xfrm>
-          <a:prstGeom prst="rect">
-            <a:avLst/>
-          </a:prstGeom>
-          <a:solidFill>
-            <a:srgbClr val="00C8F0"/>
-          </a:solidFill>
-          <a:ln>
-            <a:noFill/>
-          </a:ln>
-        </p:spPr>
-        <p:style>
-          <a:lnRef idx="1">
-            <a:schemeClr val="accent1"/>
-          </a:lnRef>
-          <a:fillRef idx="3">
-            <a:schemeClr val="accent1"/>
-          </a:fillRef>
-          <a:effectRef idx="2">
-            <a:schemeClr val="accent1"/>
-          </a:effectRef>
-          <a:fontRef idx="minor">
-            <a:schemeClr val="lt1"/>
-          </a:fontRef>
-        </p:style>
-        <p:txBody>
-          <a:bodyPr rtlCol="0" anchor="ctr"/>
-          <a:lstStyle/>
-          <a:p>
-            <a:pPr algn="ctr"/>
-          </a:p>
-        </p:txBody>
-      </p:sp>
-      <p:sp>
-        <p:nvSpPr>
-          <p:cNvPr id="98" name="Rectangle 97"/>
-          <p:cNvSpPr/>
-          <p:nvPr/>
-        </p:nvSpPr>
-        <p:spPr>
-          <a:xfrm>
-            <a:off x="5508344" y="4005986"/>
-            <a:ext cx="18288" cy="115215"/>
-          </a:xfrm>
-          <a:prstGeom prst="rect">
-            <a:avLst/>
-          </a:prstGeom>
-          <a:solidFill>
-            <a:srgbClr val="00C8F0"/>
-          </a:solidFill>
-          <a:ln>
-            <a:noFill/>
-          </a:ln>
-        </p:spPr>
-        <p:style>
-          <a:lnRef idx="1">
-            <a:schemeClr val="accent1"/>
-          </a:lnRef>
-          <a:fillRef idx="3">
-            <a:schemeClr val="accent1"/>
-          </a:fillRef>
-          <a:effectRef idx="2">
-            <a:schemeClr val="accent1"/>
-          </a:effectRef>
-          <a:fontRef idx="minor">
-            <a:schemeClr val="lt1"/>
-          </a:fontRef>
-        </p:style>
-        <p:txBody>
-          <a:bodyPr rtlCol="0" anchor="ctr"/>
-          <a:lstStyle/>
-          <a:p>
-            <a:pPr algn="ctr"/>
-          </a:p>
-        </p:txBody>
-      </p:sp>
-      <p:sp>
-        <p:nvSpPr>
-          <p:cNvPr id="99" name="Rectangle 98"/>
-          <p:cNvSpPr/>
-          <p:nvPr/>
-        </p:nvSpPr>
-        <p:spPr>
-          <a:xfrm>
-            <a:off x="5524803" y="4020615"/>
-            <a:ext cx="18288" cy="98756"/>
-          </a:xfrm>
-          <a:prstGeom prst="rect">
-            <a:avLst/>
-          </a:prstGeom>
-          <a:solidFill>
-            <a:srgbClr val="00C8F0"/>
-          </a:solidFill>
-          <a:ln>
-            <a:noFill/>
-          </a:ln>
-        </p:spPr>
-        <p:style>
-          <a:lnRef idx="1">
-            <a:schemeClr val="accent1"/>
-          </a:lnRef>
-          <a:fillRef idx="3">
-            <a:schemeClr val="accent1"/>
-          </a:fillRef>
-          <a:effectRef idx="2">
-            <a:schemeClr val="accent1"/>
-          </a:effectRef>
-          <a:fontRef idx="minor">
-            <a:schemeClr val="lt1"/>
-          </a:fontRef>
-        </p:style>
-        <p:txBody>
-          <a:bodyPr rtlCol="0" anchor="ctr"/>
-          <a:lstStyle/>
-          <a:p>
-            <a:pPr algn="ctr"/>
-          </a:p>
-        </p:txBody>
-      </p:sp>
-      <p:sp>
-        <p:nvSpPr>
-          <p:cNvPr id="100" name="Rectangle 99"/>
-          <p:cNvSpPr/>
-          <p:nvPr/>
-        </p:nvSpPr>
-        <p:spPr>
-          <a:xfrm>
-            <a:off x="5524803" y="3989527"/>
-            <a:ext cx="18288" cy="98756"/>
-          </a:xfrm>
-          <a:prstGeom prst="rect">
-            <a:avLst/>
-          </a:prstGeom>
-          <a:solidFill>
-            <a:srgbClr val="00C8F0"/>
-          </a:solidFill>
-          <a:ln>
-            <a:noFill/>
-          </a:ln>
-        </p:spPr>
-        <p:style>
-          <a:lnRef idx="1">
-            <a:schemeClr val="accent1"/>
-          </a:lnRef>
-          <a:fillRef idx="3">
-            <a:schemeClr val="accent1"/>
-          </a:fillRef>
-          <a:effectRef idx="2">
-            <a:schemeClr val="accent1"/>
-          </a:effectRef>
-          <a:fontRef idx="minor">
-            <a:schemeClr val="lt1"/>
-          </a:fontRef>
-        </p:style>
-        <p:txBody>
-          <a:bodyPr rtlCol="0" anchor="ctr"/>
-          <a:lstStyle/>
-          <a:p>
-            <a:pPr algn="ctr"/>
-          </a:p>
-        </p:txBody>
-      </p:sp>
-      <p:sp>
-        <p:nvSpPr>
-          <p:cNvPr id="101" name="Rectangle 100"/>
-          <p:cNvSpPr/>
-          <p:nvPr/>
-        </p:nvSpPr>
-        <p:spPr>
-          <a:xfrm>
-            <a:off x="5541262" y="4037074"/>
-            <a:ext cx="18288" cy="82297"/>
-          </a:xfrm>
-          <a:prstGeom prst="rect">
-            <a:avLst/>
-          </a:prstGeom>
-          <a:solidFill>
-            <a:srgbClr val="00C8F0"/>
-          </a:solidFill>
-          <a:ln>
-            <a:noFill/>
-          </a:ln>
-        </p:spPr>
-        <p:style>
-          <a:lnRef idx="1">
-            <a:schemeClr val="accent1"/>
-          </a:lnRef>
-          <a:fillRef idx="3">
-            <a:schemeClr val="accent1"/>
-          </a:fillRef>
-          <a:effectRef idx="2">
-            <a:schemeClr val="accent1"/>
-          </a:effectRef>
-          <a:fontRef idx="minor">
-            <a:schemeClr val="lt1"/>
-          </a:fontRef>
-        </p:style>
-        <p:txBody>
-          <a:bodyPr rtlCol="0" anchor="ctr"/>
-          <a:lstStyle/>
-          <a:p>
-            <a:pPr algn="ctr"/>
-          </a:p>
-        </p:txBody>
-      </p:sp>
-      <p:sp>
-        <p:nvSpPr>
-          <p:cNvPr id="102" name="Rectangle 101"/>
-          <p:cNvSpPr/>
-          <p:nvPr/>
-        </p:nvSpPr>
-        <p:spPr>
-          <a:xfrm>
-            <a:off x="5541262" y="3973068"/>
-            <a:ext cx="18288" cy="82297"/>
-          </a:xfrm>
-          <a:prstGeom prst="rect">
-            <a:avLst/>
-          </a:prstGeom>
-          <a:solidFill>
-            <a:srgbClr val="00C8F0"/>
-          </a:solidFill>
-          <a:ln>
-            <a:noFill/>
-          </a:ln>
-        </p:spPr>
-        <p:style>
-          <a:lnRef idx="1">
-            <a:schemeClr val="accent1"/>
-          </a:lnRef>
-          <a:fillRef idx="3">
-            <a:schemeClr val="accent1"/>
-          </a:fillRef>
-          <a:effectRef idx="2">
-            <a:schemeClr val="accent1"/>
-          </a:effectRef>
-          <a:fontRef idx="minor">
-            <a:schemeClr val="lt1"/>
-          </a:fontRef>
-        </p:style>
-        <p:txBody>
-          <a:bodyPr rtlCol="0" anchor="ctr"/>
-          <a:lstStyle/>
-          <a:p>
-            <a:pPr algn="ctr"/>
-          </a:p>
-        </p:txBody>
-      </p:sp>
-      <p:sp>
-        <p:nvSpPr>
-          <p:cNvPr id="103" name="Rectangle 102"/>
-          <p:cNvSpPr/>
-          <p:nvPr/>
-        </p:nvSpPr>
-        <p:spPr>
-          <a:xfrm>
-            <a:off x="5557721" y="4053533"/>
-            <a:ext cx="18288" cy="65838"/>
-          </a:xfrm>
-          <a:prstGeom prst="rect">
-            <a:avLst/>
-          </a:prstGeom>
-          <a:solidFill>
-            <a:srgbClr val="00C8F0"/>
-          </a:solidFill>
-          <a:ln>
-            <a:noFill/>
-          </a:ln>
-        </p:spPr>
-        <p:style>
-          <a:lnRef idx="1">
-            <a:schemeClr val="accent1"/>
-          </a:lnRef>
-          <a:fillRef idx="3">
-            <a:schemeClr val="accent1"/>
-          </a:fillRef>
-          <a:effectRef idx="2">
-            <a:schemeClr val="accent1"/>
-          </a:effectRef>
-          <a:fontRef idx="minor">
-            <a:schemeClr val="lt1"/>
-          </a:fontRef>
-        </p:style>
-        <p:txBody>
-          <a:bodyPr rtlCol="0" anchor="ctr"/>
-          <a:lstStyle/>
-          <a:p>
-            <a:pPr algn="ctr"/>
-          </a:p>
-        </p:txBody>
-      </p:sp>
-      <p:sp>
-        <p:nvSpPr>
-          <p:cNvPr id="104" name="Rectangle 103"/>
-          <p:cNvSpPr/>
-          <p:nvPr/>
-        </p:nvSpPr>
-        <p:spPr>
-          <a:xfrm>
-            <a:off x="5557721" y="3956609"/>
-            <a:ext cx="18288" cy="65838"/>
-          </a:xfrm>
-          <a:prstGeom prst="rect">
-            <a:avLst/>
-          </a:prstGeom>
-          <a:solidFill>
-            <a:srgbClr val="00C8F0"/>
-          </a:solidFill>
-          <a:ln>
-            <a:noFill/>
-          </a:ln>
-        </p:spPr>
-        <p:style>
-          <a:lnRef idx="1">
-            <a:schemeClr val="accent1"/>
-          </a:lnRef>
-          <a:fillRef idx="3">
-            <a:schemeClr val="accent1"/>
-          </a:fillRef>
-          <a:effectRef idx="2">
-            <a:schemeClr val="accent1"/>
-          </a:effectRef>
-          <a:fontRef idx="minor">
-            <a:schemeClr val="lt1"/>
-          </a:fontRef>
-        </p:style>
-        <p:txBody>
-          <a:bodyPr rtlCol="0" anchor="ctr"/>
-          <a:lstStyle/>
-          <a:p>
-            <a:pPr algn="ctr"/>
-          </a:p>
-        </p:txBody>
-      </p:sp>
-      <p:sp>
-        <p:nvSpPr>
-          <p:cNvPr id="105" name="Rectangle 104"/>
-          <p:cNvSpPr/>
-          <p:nvPr/>
-        </p:nvSpPr>
-        <p:spPr>
-          <a:xfrm>
-            <a:off x="5574180" y="4069992"/>
-            <a:ext cx="18288" cy="49379"/>
-          </a:xfrm>
-          <a:prstGeom prst="rect">
-            <a:avLst/>
-          </a:prstGeom>
-          <a:solidFill>
-            <a:srgbClr val="00C8F0"/>
-          </a:solidFill>
-          <a:ln>
-            <a:noFill/>
-          </a:ln>
-        </p:spPr>
-        <p:style>
-          <a:lnRef idx="1">
-            <a:schemeClr val="accent1"/>
-          </a:lnRef>
-          <a:fillRef idx="3">
-            <a:schemeClr val="accent1"/>
-          </a:fillRef>
-          <a:effectRef idx="2">
-            <a:schemeClr val="accent1"/>
-          </a:effectRef>
-          <a:fontRef idx="minor">
-            <a:schemeClr val="lt1"/>
-          </a:fontRef>
-        </p:style>
-        <p:txBody>
-          <a:bodyPr rtlCol="0" anchor="ctr"/>
-          <a:lstStyle/>
-          <a:p>
-            <a:pPr algn="ctr"/>
-          </a:p>
-        </p:txBody>
-      </p:sp>
-      <p:sp>
-        <p:nvSpPr>
-          <p:cNvPr id="106" name="Rectangle 105"/>
-          <p:cNvSpPr/>
-          <p:nvPr/>
-        </p:nvSpPr>
-        <p:spPr>
-          <a:xfrm>
-            <a:off x="5574180" y="3940150"/>
-            <a:ext cx="18288" cy="49379"/>
-          </a:xfrm>
-          <a:prstGeom prst="rect">
-            <a:avLst/>
-          </a:prstGeom>
-          <a:solidFill>
-            <a:srgbClr val="00C8F0"/>
-          </a:solidFill>
-          <a:ln>
-            <a:noFill/>
-          </a:ln>
-        </p:spPr>
-        <p:style>
-          <a:lnRef idx="1">
-            <a:schemeClr val="accent1"/>
-          </a:lnRef>
-          <a:fillRef idx="3">
-            <a:schemeClr val="accent1"/>
-          </a:fillRef>
-          <a:effectRef idx="2">
-            <a:schemeClr val="accent1"/>
-          </a:effectRef>
-          <a:fontRef idx="minor">
-            <a:schemeClr val="lt1"/>
-          </a:fontRef>
-        </p:style>
-        <p:txBody>
-          <a:bodyPr rtlCol="0" anchor="ctr"/>
-          <a:lstStyle/>
-          <a:p>
-            <a:pPr algn="ctr"/>
-          </a:p>
-        </p:txBody>
-      </p:sp>
-      <p:sp>
-        <p:nvSpPr>
-          <p:cNvPr id="107" name="Oval 106"/>
-          <p:cNvSpPr/>
-          <p:nvPr/>
-        </p:nvSpPr>
-        <p:spPr>
-          <a:xfrm>
-            <a:off x="6126479" y="3803904"/>
-            <a:ext cx="493776" cy="493776"/>
-          </a:xfrm>
-          <a:prstGeom prst="ellipse">
-            <a:avLst/>
-          </a:prstGeom>
-          <a:solidFill>
-            <a:srgbClr val="00A89A"/>
-          </a:solidFill>
-          <a:ln>
-            <a:noFill/>
-          </a:ln>
-        </p:spPr>
-        <p:style>
-          <a:lnRef idx="1">
-            <a:schemeClr val="accent1"/>
-          </a:lnRef>
-          <a:fillRef idx="3">
-            <a:schemeClr val="accent1"/>
-          </a:fillRef>
-          <a:effectRef idx="2">
-            <a:schemeClr val="accent1"/>
-          </a:effectRef>
-          <a:fontRef idx="minor">
-            <a:schemeClr val="lt1"/>
-          </a:fontRef>
-        </p:style>
-        <p:txBody>
-          <a:bodyPr rtlCol="0" anchor="ctr"/>
-          <a:lstStyle/>
-          <a:p>
-            <a:pPr algn="ctr"/>
-          </a:p>
-        </p:txBody>
-      </p:sp>
-      <p:sp>
-        <p:nvSpPr>
-          <p:cNvPr id="108" name="TextBox 107"/>
+          <p:cNvPr id="60" name="TextBox 59"/>
           <p:cNvSpPr txBox="1"/>
           <p:nvPr/>
         </p:nvSpPr>
@@ -7606,7 +5542,7 @@
       </p:sp>
       <p:sp>
         <p:nvSpPr>
-          <p:cNvPr id="109" name="Rounded Rectangle 108"/>
+          <p:cNvPr id="61" name="Rounded Rectangle 60"/>
           <p:cNvSpPr/>
           <p:nvPr/>
         </p:nvSpPr>
@@ -7649,7 +5585,7 @@
       </p:sp>
       <p:sp>
         <p:nvSpPr>
-          <p:cNvPr id="110" name="TextBox 109"/>
+          <p:cNvPr id="62" name="TextBox 61"/>
           <p:cNvSpPr txBox="1"/>
           <p:nvPr/>
         </p:nvSpPr>
@@ -7685,16 +5621,16 @@
       </p:sp>
       <p:sp>
         <p:nvSpPr>
-          <p:cNvPr id="111" name="Rectangle 110"/>
+          <p:cNvPr id="63" name="Right Arrow 62"/>
           <p:cNvSpPr/>
           <p:nvPr/>
         </p:nvSpPr>
         <p:spPr>
           <a:xfrm>
-            <a:off x="6748271" y="4023359"/>
-            <a:ext cx="585216" cy="32004"/>
-          </a:xfrm>
-          <a:prstGeom prst="rect">
+            <a:off x="6812279" y="3959352"/>
+            <a:ext cx="960120" cy="182880"/>
+          </a:xfrm>
+          <a:prstGeom prst="rightArrow">
             <a:avLst/>
           </a:prstGeom>
           <a:solidFill>
@@ -7728,20 +5664,20 @@
       </p:sp>
       <p:sp>
         <p:nvSpPr>
-          <p:cNvPr id="112" name="Rectangle 111"/>
+          <p:cNvPr id="64" name="Oval 63"/>
           <p:cNvSpPr/>
           <p:nvPr/>
         </p:nvSpPr>
         <p:spPr>
           <a:xfrm>
-            <a:off x="7333487" y="3954779"/>
-            <a:ext cx="18288" cy="164592"/>
-          </a:xfrm>
-          <a:prstGeom prst="rect">
-            <a:avLst/>
-          </a:prstGeom>
-          <a:solidFill>
-            <a:srgbClr val="00C8F0"/>
+            <a:off x="8001000" y="3803904"/>
+            <a:ext cx="493776" cy="493776"/>
+          </a:xfrm>
+          <a:prstGeom prst="ellipse">
+            <a:avLst/>
+          </a:prstGeom>
+          <a:solidFill>
+            <a:srgbClr val="00D48A"/>
           </a:solidFill>
           <a:ln>
             <a:noFill/>
@@ -7771,695 +5707,7 @@
       </p:sp>
       <p:sp>
         <p:nvSpPr>
-          <p:cNvPr id="113" name="Rectangle 112"/>
-          <p:cNvSpPr/>
-          <p:nvPr/>
-        </p:nvSpPr>
-        <p:spPr>
-          <a:xfrm>
-            <a:off x="7333487" y="4055363"/>
-            <a:ext cx="18288" cy="164592"/>
-          </a:xfrm>
-          <a:prstGeom prst="rect">
-            <a:avLst/>
-          </a:prstGeom>
-          <a:solidFill>
-            <a:srgbClr val="00C8F0"/>
-          </a:solidFill>
-          <a:ln>
-            <a:noFill/>
-          </a:ln>
-        </p:spPr>
-        <p:style>
-          <a:lnRef idx="1">
-            <a:schemeClr val="accent1"/>
-          </a:lnRef>
-          <a:fillRef idx="3">
-            <a:schemeClr val="accent1"/>
-          </a:fillRef>
-          <a:effectRef idx="2">
-            <a:schemeClr val="accent1"/>
-          </a:effectRef>
-          <a:fontRef idx="minor">
-            <a:schemeClr val="lt1"/>
-          </a:fontRef>
-        </p:style>
-        <p:txBody>
-          <a:bodyPr rtlCol="0" anchor="ctr"/>
-          <a:lstStyle/>
-          <a:p>
-            <a:pPr algn="ctr"/>
-          </a:p>
-        </p:txBody>
-      </p:sp>
-      <p:sp>
-        <p:nvSpPr>
-          <p:cNvPr id="114" name="Rectangle 113"/>
-          <p:cNvSpPr/>
-          <p:nvPr/>
-        </p:nvSpPr>
-        <p:spPr>
-          <a:xfrm>
-            <a:off x="7349946" y="3971238"/>
-            <a:ext cx="18288" cy="148133"/>
-          </a:xfrm>
-          <a:prstGeom prst="rect">
-            <a:avLst/>
-          </a:prstGeom>
-          <a:solidFill>
-            <a:srgbClr val="00C8F0"/>
-          </a:solidFill>
-          <a:ln>
-            <a:noFill/>
-          </a:ln>
-        </p:spPr>
-        <p:style>
-          <a:lnRef idx="1">
-            <a:schemeClr val="accent1"/>
-          </a:lnRef>
-          <a:fillRef idx="3">
-            <a:schemeClr val="accent1"/>
-          </a:fillRef>
-          <a:effectRef idx="2">
-            <a:schemeClr val="accent1"/>
-          </a:effectRef>
-          <a:fontRef idx="minor">
-            <a:schemeClr val="lt1"/>
-          </a:fontRef>
-        </p:style>
-        <p:txBody>
-          <a:bodyPr rtlCol="0" anchor="ctr"/>
-          <a:lstStyle/>
-          <a:p>
-            <a:pPr algn="ctr"/>
-          </a:p>
-        </p:txBody>
-      </p:sp>
-      <p:sp>
-        <p:nvSpPr>
-          <p:cNvPr id="115" name="Rectangle 114"/>
-          <p:cNvSpPr/>
-          <p:nvPr/>
-        </p:nvSpPr>
-        <p:spPr>
-          <a:xfrm>
-            <a:off x="7349946" y="4038904"/>
-            <a:ext cx="18288" cy="148133"/>
-          </a:xfrm>
-          <a:prstGeom prst="rect">
-            <a:avLst/>
-          </a:prstGeom>
-          <a:solidFill>
-            <a:srgbClr val="00C8F0"/>
-          </a:solidFill>
-          <a:ln>
-            <a:noFill/>
-          </a:ln>
-        </p:spPr>
-        <p:style>
-          <a:lnRef idx="1">
-            <a:schemeClr val="accent1"/>
-          </a:lnRef>
-          <a:fillRef idx="3">
-            <a:schemeClr val="accent1"/>
-          </a:fillRef>
-          <a:effectRef idx="2">
-            <a:schemeClr val="accent1"/>
-          </a:effectRef>
-          <a:fontRef idx="minor">
-            <a:schemeClr val="lt1"/>
-          </a:fontRef>
-        </p:style>
-        <p:txBody>
-          <a:bodyPr rtlCol="0" anchor="ctr"/>
-          <a:lstStyle/>
-          <a:p>
-            <a:pPr algn="ctr"/>
-          </a:p>
-        </p:txBody>
-      </p:sp>
-      <p:sp>
-        <p:nvSpPr>
-          <p:cNvPr id="116" name="Rectangle 115"/>
-          <p:cNvSpPr/>
-          <p:nvPr/>
-        </p:nvSpPr>
-        <p:spPr>
-          <a:xfrm>
-            <a:off x="7366405" y="3987697"/>
-            <a:ext cx="18288" cy="131674"/>
-          </a:xfrm>
-          <a:prstGeom prst="rect">
-            <a:avLst/>
-          </a:prstGeom>
-          <a:solidFill>
-            <a:srgbClr val="00C8F0"/>
-          </a:solidFill>
-          <a:ln>
-            <a:noFill/>
-          </a:ln>
-        </p:spPr>
-        <p:style>
-          <a:lnRef idx="1">
-            <a:schemeClr val="accent1"/>
-          </a:lnRef>
-          <a:fillRef idx="3">
-            <a:schemeClr val="accent1"/>
-          </a:fillRef>
-          <a:effectRef idx="2">
-            <a:schemeClr val="accent1"/>
-          </a:effectRef>
-          <a:fontRef idx="minor">
-            <a:schemeClr val="lt1"/>
-          </a:fontRef>
-        </p:style>
-        <p:txBody>
-          <a:bodyPr rtlCol="0" anchor="ctr"/>
-          <a:lstStyle/>
-          <a:p>
-            <a:pPr algn="ctr"/>
-          </a:p>
-        </p:txBody>
-      </p:sp>
-      <p:sp>
-        <p:nvSpPr>
-          <p:cNvPr id="117" name="Rectangle 116"/>
-          <p:cNvSpPr/>
-          <p:nvPr/>
-        </p:nvSpPr>
-        <p:spPr>
-          <a:xfrm>
-            <a:off x="7366405" y="4022445"/>
-            <a:ext cx="18288" cy="131674"/>
-          </a:xfrm>
-          <a:prstGeom prst="rect">
-            <a:avLst/>
-          </a:prstGeom>
-          <a:solidFill>
-            <a:srgbClr val="00C8F0"/>
-          </a:solidFill>
-          <a:ln>
-            <a:noFill/>
-          </a:ln>
-        </p:spPr>
-        <p:style>
-          <a:lnRef idx="1">
-            <a:schemeClr val="accent1"/>
-          </a:lnRef>
-          <a:fillRef idx="3">
-            <a:schemeClr val="accent1"/>
-          </a:fillRef>
-          <a:effectRef idx="2">
-            <a:schemeClr val="accent1"/>
-          </a:effectRef>
-          <a:fontRef idx="minor">
-            <a:schemeClr val="lt1"/>
-          </a:fontRef>
-        </p:style>
-        <p:txBody>
-          <a:bodyPr rtlCol="0" anchor="ctr"/>
-          <a:lstStyle/>
-          <a:p>
-            <a:pPr algn="ctr"/>
-          </a:p>
-        </p:txBody>
-      </p:sp>
-      <p:sp>
-        <p:nvSpPr>
-          <p:cNvPr id="118" name="Rectangle 117"/>
-          <p:cNvSpPr/>
-          <p:nvPr/>
-        </p:nvSpPr>
-        <p:spPr>
-          <a:xfrm>
-            <a:off x="7382864" y="4004156"/>
-            <a:ext cx="18288" cy="115215"/>
-          </a:xfrm>
-          <a:prstGeom prst="rect">
-            <a:avLst/>
-          </a:prstGeom>
-          <a:solidFill>
-            <a:srgbClr val="00C8F0"/>
-          </a:solidFill>
-          <a:ln>
-            <a:noFill/>
-          </a:ln>
-        </p:spPr>
-        <p:style>
-          <a:lnRef idx="1">
-            <a:schemeClr val="accent1"/>
-          </a:lnRef>
-          <a:fillRef idx="3">
-            <a:schemeClr val="accent1"/>
-          </a:fillRef>
-          <a:effectRef idx="2">
-            <a:schemeClr val="accent1"/>
-          </a:effectRef>
-          <a:fontRef idx="minor">
-            <a:schemeClr val="lt1"/>
-          </a:fontRef>
-        </p:style>
-        <p:txBody>
-          <a:bodyPr rtlCol="0" anchor="ctr"/>
-          <a:lstStyle/>
-          <a:p>
-            <a:pPr algn="ctr"/>
-          </a:p>
-        </p:txBody>
-      </p:sp>
-      <p:sp>
-        <p:nvSpPr>
-          <p:cNvPr id="119" name="Rectangle 118"/>
-          <p:cNvSpPr/>
-          <p:nvPr/>
-        </p:nvSpPr>
-        <p:spPr>
-          <a:xfrm>
-            <a:off x="7382864" y="4005986"/>
-            <a:ext cx="18288" cy="115215"/>
-          </a:xfrm>
-          <a:prstGeom prst="rect">
-            <a:avLst/>
-          </a:prstGeom>
-          <a:solidFill>
-            <a:srgbClr val="00C8F0"/>
-          </a:solidFill>
-          <a:ln>
-            <a:noFill/>
-          </a:ln>
-        </p:spPr>
-        <p:style>
-          <a:lnRef idx="1">
-            <a:schemeClr val="accent1"/>
-          </a:lnRef>
-          <a:fillRef idx="3">
-            <a:schemeClr val="accent1"/>
-          </a:fillRef>
-          <a:effectRef idx="2">
-            <a:schemeClr val="accent1"/>
-          </a:effectRef>
-          <a:fontRef idx="minor">
-            <a:schemeClr val="lt1"/>
-          </a:fontRef>
-        </p:style>
-        <p:txBody>
-          <a:bodyPr rtlCol="0" anchor="ctr"/>
-          <a:lstStyle/>
-          <a:p>
-            <a:pPr algn="ctr"/>
-          </a:p>
-        </p:txBody>
-      </p:sp>
-      <p:sp>
-        <p:nvSpPr>
-          <p:cNvPr id="120" name="Rectangle 119"/>
-          <p:cNvSpPr/>
-          <p:nvPr/>
-        </p:nvSpPr>
-        <p:spPr>
-          <a:xfrm>
-            <a:off x="7399323" y="4020615"/>
-            <a:ext cx="18288" cy="98756"/>
-          </a:xfrm>
-          <a:prstGeom prst="rect">
-            <a:avLst/>
-          </a:prstGeom>
-          <a:solidFill>
-            <a:srgbClr val="00C8F0"/>
-          </a:solidFill>
-          <a:ln>
-            <a:noFill/>
-          </a:ln>
-        </p:spPr>
-        <p:style>
-          <a:lnRef idx="1">
-            <a:schemeClr val="accent1"/>
-          </a:lnRef>
-          <a:fillRef idx="3">
-            <a:schemeClr val="accent1"/>
-          </a:fillRef>
-          <a:effectRef idx="2">
-            <a:schemeClr val="accent1"/>
-          </a:effectRef>
-          <a:fontRef idx="minor">
-            <a:schemeClr val="lt1"/>
-          </a:fontRef>
-        </p:style>
-        <p:txBody>
-          <a:bodyPr rtlCol="0" anchor="ctr"/>
-          <a:lstStyle/>
-          <a:p>
-            <a:pPr algn="ctr"/>
-          </a:p>
-        </p:txBody>
-      </p:sp>
-      <p:sp>
-        <p:nvSpPr>
-          <p:cNvPr id="121" name="Rectangle 120"/>
-          <p:cNvSpPr/>
-          <p:nvPr/>
-        </p:nvSpPr>
-        <p:spPr>
-          <a:xfrm>
-            <a:off x="7399323" y="3989527"/>
-            <a:ext cx="18288" cy="98756"/>
-          </a:xfrm>
-          <a:prstGeom prst="rect">
-            <a:avLst/>
-          </a:prstGeom>
-          <a:solidFill>
-            <a:srgbClr val="00C8F0"/>
-          </a:solidFill>
-          <a:ln>
-            <a:noFill/>
-          </a:ln>
-        </p:spPr>
-        <p:style>
-          <a:lnRef idx="1">
-            <a:schemeClr val="accent1"/>
-          </a:lnRef>
-          <a:fillRef idx="3">
-            <a:schemeClr val="accent1"/>
-          </a:fillRef>
-          <a:effectRef idx="2">
-            <a:schemeClr val="accent1"/>
-          </a:effectRef>
-          <a:fontRef idx="minor">
-            <a:schemeClr val="lt1"/>
-          </a:fontRef>
-        </p:style>
-        <p:txBody>
-          <a:bodyPr rtlCol="0" anchor="ctr"/>
-          <a:lstStyle/>
-          <a:p>
-            <a:pPr algn="ctr"/>
-          </a:p>
-        </p:txBody>
-      </p:sp>
-      <p:sp>
-        <p:nvSpPr>
-          <p:cNvPr id="122" name="Rectangle 121"/>
-          <p:cNvSpPr/>
-          <p:nvPr/>
-        </p:nvSpPr>
-        <p:spPr>
-          <a:xfrm>
-            <a:off x="7415782" y="4037074"/>
-            <a:ext cx="18288" cy="82297"/>
-          </a:xfrm>
-          <a:prstGeom prst="rect">
-            <a:avLst/>
-          </a:prstGeom>
-          <a:solidFill>
-            <a:srgbClr val="00C8F0"/>
-          </a:solidFill>
-          <a:ln>
-            <a:noFill/>
-          </a:ln>
-        </p:spPr>
-        <p:style>
-          <a:lnRef idx="1">
-            <a:schemeClr val="accent1"/>
-          </a:lnRef>
-          <a:fillRef idx="3">
-            <a:schemeClr val="accent1"/>
-          </a:fillRef>
-          <a:effectRef idx="2">
-            <a:schemeClr val="accent1"/>
-          </a:effectRef>
-          <a:fontRef idx="minor">
-            <a:schemeClr val="lt1"/>
-          </a:fontRef>
-        </p:style>
-        <p:txBody>
-          <a:bodyPr rtlCol="0" anchor="ctr"/>
-          <a:lstStyle/>
-          <a:p>
-            <a:pPr algn="ctr"/>
-          </a:p>
-        </p:txBody>
-      </p:sp>
-      <p:sp>
-        <p:nvSpPr>
-          <p:cNvPr id="123" name="Rectangle 122"/>
-          <p:cNvSpPr/>
-          <p:nvPr/>
-        </p:nvSpPr>
-        <p:spPr>
-          <a:xfrm>
-            <a:off x="7415782" y="3973068"/>
-            <a:ext cx="18288" cy="82297"/>
-          </a:xfrm>
-          <a:prstGeom prst="rect">
-            <a:avLst/>
-          </a:prstGeom>
-          <a:solidFill>
-            <a:srgbClr val="00C8F0"/>
-          </a:solidFill>
-          <a:ln>
-            <a:noFill/>
-          </a:ln>
-        </p:spPr>
-        <p:style>
-          <a:lnRef idx="1">
-            <a:schemeClr val="accent1"/>
-          </a:lnRef>
-          <a:fillRef idx="3">
-            <a:schemeClr val="accent1"/>
-          </a:fillRef>
-          <a:effectRef idx="2">
-            <a:schemeClr val="accent1"/>
-          </a:effectRef>
-          <a:fontRef idx="minor">
-            <a:schemeClr val="lt1"/>
-          </a:fontRef>
-        </p:style>
-        <p:txBody>
-          <a:bodyPr rtlCol="0" anchor="ctr"/>
-          <a:lstStyle/>
-          <a:p>
-            <a:pPr algn="ctr"/>
-          </a:p>
-        </p:txBody>
-      </p:sp>
-      <p:sp>
-        <p:nvSpPr>
-          <p:cNvPr id="124" name="Rectangle 123"/>
-          <p:cNvSpPr/>
-          <p:nvPr/>
-        </p:nvSpPr>
-        <p:spPr>
-          <a:xfrm>
-            <a:off x="7432241" y="4053533"/>
-            <a:ext cx="18288" cy="65838"/>
-          </a:xfrm>
-          <a:prstGeom prst="rect">
-            <a:avLst/>
-          </a:prstGeom>
-          <a:solidFill>
-            <a:srgbClr val="00C8F0"/>
-          </a:solidFill>
-          <a:ln>
-            <a:noFill/>
-          </a:ln>
-        </p:spPr>
-        <p:style>
-          <a:lnRef idx="1">
-            <a:schemeClr val="accent1"/>
-          </a:lnRef>
-          <a:fillRef idx="3">
-            <a:schemeClr val="accent1"/>
-          </a:fillRef>
-          <a:effectRef idx="2">
-            <a:schemeClr val="accent1"/>
-          </a:effectRef>
-          <a:fontRef idx="minor">
-            <a:schemeClr val="lt1"/>
-          </a:fontRef>
-        </p:style>
-        <p:txBody>
-          <a:bodyPr rtlCol="0" anchor="ctr"/>
-          <a:lstStyle/>
-          <a:p>
-            <a:pPr algn="ctr"/>
-          </a:p>
-        </p:txBody>
-      </p:sp>
-      <p:sp>
-        <p:nvSpPr>
-          <p:cNvPr id="125" name="Rectangle 124"/>
-          <p:cNvSpPr/>
-          <p:nvPr/>
-        </p:nvSpPr>
-        <p:spPr>
-          <a:xfrm>
-            <a:off x="7432241" y="3956609"/>
-            <a:ext cx="18288" cy="65838"/>
-          </a:xfrm>
-          <a:prstGeom prst="rect">
-            <a:avLst/>
-          </a:prstGeom>
-          <a:solidFill>
-            <a:srgbClr val="00C8F0"/>
-          </a:solidFill>
-          <a:ln>
-            <a:noFill/>
-          </a:ln>
-        </p:spPr>
-        <p:style>
-          <a:lnRef idx="1">
-            <a:schemeClr val="accent1"/>
-          </a:lnRef>
-          <a:fillRef idx="3">
-            <a:schemeClr val="accent1"/>
-          </a:fillRef>
-          <a:effectRef idx="2">
-            <a:schemeClr val="accent1"/>
-          </a:effectRef>
-          <a:fontRef idx="minor">
-            <a:schemeClr val="lt1"/>
-          </a:fontRef>
-        </p:style>
-        <p:txBody>
-          <a:bodyPr rtlCol="0" anchor="ctr"/>
-          <a:lstStyle/>
-          <a:p>
-            <a:pPr algn="ctr"/>
-          </a:p>
-        </p:txBody>
-      </p:sp>
-      <p:sp>
-        <p:nvSpPr>
-          <p:cNvPr id="126" name="Rectangle 125"/>
-          <p:cNvSpPr/>
-          <p:nvPr/>
-        </p:nvSpPr>
-        <p:spPr>
-          <a:xfrm>
-            <a:off x="7448700" y="4069992"/>
-            <a:ext cx="18288" cy="49379"/>
-          </a:xfrm>
-          <a:prstGeom prst="rect">
-            <a:avLst/>
-          </a:prstGeom>
-          <a:solidFill>
-            <a:srgbClr val="00C8F0"/>
-          </a:solidFill>
-          <a:ln>
-            <a:noFill/>
-          </a:ln>
-        </p:spPr>
-        <p:style>
-          <a:lnRef idx="1">
-            <a:schemeClr val="accent1"/>
-          </a:lnRef>
-          <a:fillRef idx="3">
-            <a:schemeClr val="accent1"/>
-          </a:fillRef>
-          <a:effectRef idx="2">
-            <a:schemeClr val="accent1"/>
-          </a:effectRef>
-          <a:fontRef idx="minor">
-            <a:schemeClr val="lt1"/>
-          </a:fontRef>
-        </p:style>
-        <p:txBody>
-          <a:bodyPr rtlCol="0" anchor="ctr"/>
-          <a:lstStyle/>
-          <a:p>
-            <a:pPr algn="ctr"/>
-          </a:p>
-        </p:txBody>
-      </p:sp>
-      <p:sp>
-        <p:nvSpPr>
-          <p:cNvPr id="127" name="Rectangle 126"/>
-          <p:cNvSpPr/>
-          <p:nvPr/>
-        </p:nvSpPr>
-        <p:spPr>
-          <a:xfrm>
-            <a:off x="7448700" y="3940150"/>
-            <a:ext cx="18288" cy="49379"/>
-          </a:xfrm>
-          <a:prstGeom prst="rect">
-            <a:avLst/>
-          </a:prstGeom>
-          <a:solidFill>
-            <a:srgbClr val="00C8F0"/>
-          </a:solidFill>
-          <a:ln>
-            <a:noFill/>
-          </a:ln>
-        </p:spPr>
-        <p:style>
-          <a:lnRef idx="1">
-            <a:schemeClr val="accent1"/>
-          </a:lnRef>
-          <a:fillRef idx="3">
-            <a:schemeClr val="accent1"/>
-          </a:fillRef>
-          <a:effectRef idx="2">
-            <a:schemeClr val="accent1"/>
-          </a:effectRef>
-          <a:fontRef idx="minor">
-            <a:schemeClr val="lt1"/>
-          </a:fontRef>
-        </p:style>
-        <p:txBody>
-          <a:bodyPr rtlCol="0" anchor="ctr"/>
-          <a:lstStyle/>
-          <a:p>
-            <a:pPr algn="ctr"/>
-          </a:p>
-        </p:txBody>
-      </p:sp>
-      <p:sp>
-        <p:nvSpPr>
-          <p:cNvPr id="128" name="Oval 127"/>
-          <p:cNvSpPr/>
-          <p:nvPr/>
-        </p:nvSpPr>
-        <p:spPr>
-          <a:xfrm>
-            <a:off x="8001000" y="3803904"/>
-            <a:ext cx="493776" cy="493776"/>
-          </a:xfrm>
-          <a:prstGeom prst="ellipse">
-            <a:avLst/>
-          </a:prstGeom>
-          <a:solidFill>
-            <a:srgbClr val="00D48A"/>
-          </a:solidFill>
-          <a:ln>
-            <a:noFill/>
-          </a:ln>
-        </p:spPr>
-        <p:style>
-          <a:lnRef idx="1">
-            <a:schemeClr val="accent1"/>
-          </a:lnRef>
-          <a:fillRef idx="3">
-            <a:schemeClr val="accent1"/>
-          </a:fillRef>
-          <a:effectRef idx="2">
-            <a:schemeClr val="accent1"/>
-          </a:effectRef>
-          <a:fontRef idx="minor">
-            <a:schemeClr val="lt1"/>
-          </a:fontRef>
-        </p:style>
-        <p:txBody>
-          <a:bodyPr rtlCol="0" anchor="ctr"/>
-          <a:lstStyle/>
-          <a:p>
-            <a:pPr algn="ctr"/>
-          </a:p>
-        </p:txBody>
-      </p:sp>
-      <p:sp>
-        <p:nvSpPr>
-          <p:cNvPr id="129" name="TextBox 128"/>
+          <p:cNvPr id="65" name="TextBox 64"/>
           <p:cNvSpPr txBox="1"/>
           <p:nvPr/>
         </p:nvSpPr>
@@ -8494,7 +5742,7 @@
       </p:sp>
       <p:sp>
         <p:nvSpPr>
-          <p:cNvPr id="130" name="Rounded Rectangle 129"/>
+          <p:cNvPr id="66" name="Rounded Rectangle 65"/>
           <p:cNvSpPr/>
           <p:nvPr/>
         </p:nvSpPr>
@@ -8537,7 +5785,7 @@
       </p:sp>
       <p:sp>
         <p:nvSpPr>
-          <p:cNvPr id="131" name="TextBox 130"/>
+          <p:cNvPr id="67" name="TextBox 66"/>
           <p:cNvSpPr txBox="1"/>
           <p:nvPr/>
         </p:nvSpPr>
@@ -8573,16 +5821,16 @@
       </p:sp>
       <p:sp>
         <p:nvSpPr>
-          <p:cNvPr id="132" name="Rectangle 131"/>
+          <p:cNvPr id="68" name="Right Arrow 67"/>
           <p:cNvSpPr/>
           <p:nvPr/>
         </p:nvSpPr>
         <p:spPr>
           <a:xfrm>
-            <a:off x="8622792" y="4023359"/>
-            <a:ext cx="585216" cy="32004"/>
-          </a:xfrm>
-          <a:prstGeom prst="rect">
+            <a:off x="8686800" y="3959352"/>
+            <a:ext cx="960120" cy="182880"/>
+          </a:xfrm>
+          <a:prstGeom prst="rightArrow">
             <a:avLst/>
           </a:prstGeom>
           <a:solidFill>
@@ -8616,16 +5864,16 @@
       </p:sp>
       <p:sp>
         <p:nvSpPr>
-          <p:cNvPr id="133" name="Rectangle 132"/>
+          <p:cNvPr id="69" name="Oval 68"/>
           <p:cNvSpPr/>
           <p:nvPr/>
         </p:nvSpPr>
         <p:spPr>
           <a:xfrm>
-            <a:off x="9208008" y="3954779"/>
-            <a:ext cx="18288" cy="164592"/>
-          </a:xfrm>
-          <a:prstGeom prst="rect">
+            <a:off x="9875520" y="3803904"/>
+            <a:ext cx="493776" cy="493776"/>
+          </a:xfrm>
+          <a:prstGeom prst="ellipse">
             <a:avLst/>
           </a:prstGeom>
           <a:solidFill>
@@ -8659,695 +5907,7 @@
       </p:sp>
       <p:sp>
         <p:nvSpPr>
-          <p:cNvPr id="134" name="Rectangle 133"/>
-          <p:cNvSpPr/>
-          <p:nvPr/>
-        </p:nvSpPr>
-        <p:spPr>
-          <a:xfrm>
-            <a:off x="9208008" y="4055363"/>
-            <a:ext cx="18288" cy="164592"/>
-          </a:xfrm>
-          <a:prstGeom prst="rect">
-            <a:avLst/>
-          </a:prstGeom>
-          <a:solidFill>
-            <a:srgbClr val="00C8F0"/>
-          </a:solidFill>
-          <a:ln>
-            <a:noFill/>
-          </a:ln>
-        </p:spPr>
-        <p:style>
-          <a:lnRef idx="1">
-            <a:schemeClr val="accent1"/>
-          </a:lnRef>
-          <a:fillRef idx="3">
-            <a:schemeClr val="accent1"/>
-          </a:fillRef>
-          <a:effectRef idx="2">
-            <a:schemeClr val="accent1"/>
-          </a:effectRef>
-          <a:fontRef idx="minor">
-            <a:schemeClr val="lt1"/>
-          </a:fontRef>
-        </p:style>
-        <p:txBody>
-          <a:bodyPr rtlCol="0" anchor="ctr"/>
-          <a:lstStyle/>
-          <a:p>
-            <a:pPr algn="ctr"/>
-          </a:p>
-        </p:txBody>
-      </p:sp>
-      <p:sp>
-        <p:nvSpPr>
-          <p:cNvPr id="135" name="Rectangle 134"/>
-          <p:cNvSpPr/>
-          <p:nvPr/>
-        </p:nvSpPr>
-        <p:spPr>
-          <a:xfrm>
-            <a:off x="9224467" y="3971238"/>
-            <a:ext cx="18288" cy="148133"/>
-          </a:xfrm>
-          <a:prstGeom prst="rect">
-            <a:avLst/>
-          </a:prstGeom>
-          <a:solidFill>
-            <a:srgbClr val="00C8F0"/>
-          </a:solidFill>
-          <a:ln>
-            <a:noFill/>
-          </a:ln>
-        </p:spPr>
-        <p:style>
-          <a:lnRef idx="1">
-            <a:schemeClr val="accent1"/>
-          </a:lnRef>
-          <a:fillRef idx="3">
-            <a:schemeClr val="accent1"/>
-          </a:fillRef>
-          <a:effectRef idx="2">
-            <a:schemeClr val="accent1"/>
-          </a:effectRef>
-          <a:fontRef idx="minor">
-            <a:schemeClr val="lt1"/>
-          </a:fontRef>
-        </p:style>
-        <p:txBody>
-          <a:bodyPr rtlCol="0" anchor="ctr"/>
-          <a:lstStyle/>
-          <a:p>
-            <a:pPr algn="ctr"/>
-          </a:p>
-        </p:txBody>
-      </p:sp>
-      <p:sp>
-        <p:nvSpPr>
-          <p:cNvPr id="136" name="Rectangle 135"/>
-          <p:cNvSpPr/>
-          <p:nvPr/>
-        </p:nvSpPr>
-        <p:spPr>
-          <a:xfrm>
-            <a:off x="9224467" y="4038904"/>
-            <a:ext cx="18288" cy="148133"/>
-          </a:xfrm>
-          <a:prstGeom prst="rect">
-            <a:avLst/>
-          </a:prstGeom>
-          <a:solidFill>
-            <a:srgbClr val="00C8F0"/>
-          </a:solidFill>
-          <a:ln>
-            <a:noFill/>
-          </a:ln>
-        </p:spPr>
-        <p:style>
-          <a:lnRef idx="1">
-            <a:schemeClr val="accent1"/>
-          </a:lnRef>
-          <a:fillRef idx="3">
-            <a:schemeClr val="accent1"/>
-          </a:fillRef>
-          <a:effectRef idx="2">
-            <a:schemeClr val="accent1"/>
-          </a:effectRef>
-          <a:fontRef idx="minor">
-            <a:schemeClr val="lt1"/>
-          </a:fontRef>
-        </p:style>
-        <p:txBody>
-          <a:bodyPr rtlCol="0" anchor="ctr"/>
-          <a:lstStyle/>
-          <a:p>
-            <a:pPr algn="ctr"/>
-          </a:p>
-        </p:txBody>
-      </p:sp>
-      <p:sp>
-        <p:nvSpPr>
-          <p:cNvPr id="137" name="Rectangle 136"/>
-          <p:cNvSpPr/>
-          <p:nvPr/>
-        </p:nvSpPr>
-        <p:spPr>
-          <a:xfrm>
-            <a:off x="9240926" y="3987697"/>
-            <a:ext cx="18288" cy="131674"/>
-          </a:xfrm>
-          <a:prstGeom prst="rect">
-            <a:avLst/>
-          </a:prstGeom>
-          <a:solidFill>
-            <a:srgbClr val="00C8F0"/>
-          </a:solidFill>
-          <a:ln>
-            <a:noFill/>
-          </a:ln>
-        </p:spPr>
-        <p:style>
-          <a:lnRef idx="1">
-            <a:schemeClr val="accent1"/>
-          </a:lnRef>
-          <a:fillRef idx="3">
-            <a:schemeClr val="accent1"/>
-          </a:fillRef>
-          <a:effectRef idx="2">
-            <a:schemeClr val="accent1"/>
-          </a:effectRef>
-          <a:fontRef idx="minor">
-            <a:schemeClr val="lt1"/>
-          </a:fontRef>
-        </p:style>
-        <p:txBody>
-          <a:bodyPr rtlCol="0" anchor="ctr"/>
-          <a:lstStyle/>
-          <a:p>
-            <a:pPr algn="ctr"/>
-          </a:p>
-        </p:txBody>
-      </p:sp>
-      <p:sp>
-        <p:nvSpPr>
-          <p:cNvPr id="138" name="Rectangle 137"/>
-          <p:cNvSpPr/>
-          <p:nvPr/>
-        </p:nvSpPr>
-        <p:spPr>
-          <a:xfrm>
-            <a:off x="9240926" y="4022445"/>
-            <a:ext cx="18288" cy="131674"/>
-          </a:xfrm>
-          <a:prstGeom prst="rect">
-            <a:avLst/>
-          </a:prstGeom>
-          <a:solidFill>
-            <a:srgbClr val="00C8F0"/>
-          </a:solidFill>
-          <a:ln>
-            <a:noFill/>
-          </a:ln>
-        </p:spPr>
-        <p:style>
-          <a:lnRef idx="1">
-            <a:schemeClr val="accent1"/>
-          </a:lnRef>
-          <a:fillRef idx="3">
-            <a:schemeClr val="accent1"/>
-          </a:fillRef>
-          <a:effectRef idx="2">
-            <a:schemeClr val="accent1"/>
-          </a:effectRef>
-          <a:fontRef idx="minor">
-            <a:schemeClr val="lt1"/>
-          </a:fontRef>
-        </p:style>
-        <p:txBody>
-          <a:bodyPr rtlCol="0" anchor="ctr"/>
-          <a:lstStyle/>
-          <a:p>
-            <a:pPr algn="ctr"/>
-          </a:p>
-        </p:txBody>
-      </p:sp>
-      <p:sp>
-        <p:nvSpPr>
-          <p:cNvPr id="139" name="Rectangle 138"/>
-          <p:cNvSpPr/>
-          <p:nvPr/>
-        </p:nvSpPr>
-        <p:spPr>
-          <a:xfrm>
-            <a:off x="9257385" y="4004156"/>
-            <a:ext cx="18288" cy="115215"/>
-          </a:xfrm>
-          <a:prstGeom prst="rect">
-            <a:avLst/>
-          </a:prstGeom>
-          <a:solidFill>
-            <a:srgbClr val="00C8F0"/>
-          </a:solidFill>
-          <a:ln>
-            <a:noFill/>
-          </a:ln>
-        </p:spPr>
-        <p:style>
-          <a:lnRef idx="1">
-            <a:schemeClr val="accent1"/>
-          </a:lnRef>
-          <a:fillRef idx="3">
-            <a:schemeClr val="accent1"/>
-          </a:fillRef>
-          <a:effectRef idx="2">
-            <a:schemeClr val="accent1"/>
-          </a:effectRef>
-          <a:fontRef idx="minor">
-            <a:schemeClr val="lt1"/>
-          </a:fontRef>
-        </p:style>
-        <p:txBody>
-          <a:bodyPr rtlCol="0" anchor="ctr"/>
-          <a:lstStyle/>
-          <a:p>
-            <a:pPr algn="ctr"/>
-          </a:p>
-        </p:txBody>
-      </p:sp>
-      <p:sp>
-        <p:nvSpPr>
-          <p:cNvPr id="140" name="Rectangle 139"/>
-          <p:cNvSpPr/>
-          <p:nvPr/>
-        </p:nvSpPr>
-        <p:spPr>
-          <a:xfrm>
-            <a:off x="9257385" y="4005986"/>
-            <a:ext cx="18288" cy="115215"/>
-          </a:xfrm>
-          <a:prstGeom prst="rect">
-            <a:avLst/>
-          </a:prstGeom>
-          <a:solidFill>
-            <a:srgbClr val="00C8F0"/>
-          </a:solidFill>
-          <a:ln>
-            <a:noFill/>
-          </a:ln>
-        </p:spPr>
-        <p:style>
-          <a:lnRef idx="1">
-            <a:schemeClr val="accent1"/>
-          </a:lnRef>
-          <a:fillRef idx="3">
-            <a:schemeClr val="accent1"/>
-          </a:fillRef>
-          <a:effectRef idx="2">
-            <a:schemeClr val="accent1"/>
-          </a:effectRef>
-          <a:fontRef idx="minor">
-            <a:schemeClr val="lt1"/>
-          </a:fontRef>
-        </p:style>
-        <p:txBody>
-          <a:bodyPr rtlCol="0" anchor="ctr"/>
-          <a:lstStyle/>
-          <a:p>
-            <a:pPr algn="ctr"/>
-          </a:p>
-        </p:txBody>
-      </p:sp>
-      <p:sp>
-        <p:nvSpPr>
-          <p:cNvPr id="141" name="Rectangle 140"/>
-          <p:cNvSpPr/>
-          <p:nvPr/>
-        </p:nvSpPr>
-        <p:spPr>
-          <a:xfrm>
-            <a:off x="9273844" y="4020615"/>
-            <a:ext cx="18288" cy="98756"/>
-          </a:xfrm>
-          <a:prstGeom prst="rect">
-            <a:avLst/>
-          </a:prstGeom>
-          <a:solidFill>
-            <a:srgbClr val="00C8F0"/>
-          </a:solidFill>
-          <a:ln>
-            <a:noFill/>
-          </a:ln>
-        </p:spPr>
-        <p:style>
-          <a:lnRef idx="1">
-            <a:schemeClr val="accent1"/>
-          </a:lnRef>
-          <a:fillRef idx="3">
-            <a:schemeClr val="accent1"/>
-          </a:fillRef>
-          <a:effectRef idx="2">
-            <a:schemeClr val="accent1"/>
-          </a:effectRef>
-          <a:fontRef idx="minor">
-            <a:schemeClr val="lt1"/>
-          </a:fontRef>
-        </p:style>
-        <p:txBody>
-          <a:bodyPr rtlCol="0" anchor="ctr"/>
-          <a:lstStyle/>
-          <a:p>
-            <a:pPr algn="ctr"/>
-          </a:p>
-        </p:txBody>
-      </p:sp>
-      <p:sp>
-        <p:nvSpPr>
-          <p:cNvPr id="142" name="Rectangle 141"/>
-          <p:cNvSpPr/>
-          <p:nvPr/>
-        </p:nvSpPr>
-        <p:spPr>
-          <a:xfrm>
-            <a:off x="9273844" y="3989527"/>
-            <a:ext cx="18288" cy="98756"/>
-          </a:xfrm>
-          <a:prstGeom prst="rect">
-            <a:avLst/>
-          </a:prstGeom>
-          <a:solidFill>
-            <a:srgbClr val="00C8F0"/>
-          </a:solidFill>
-          <a:ln>
-            <a:noFill/>
-          </a:ln>
-        </p:spPr>
-        <p:style>
-          <a:lnRef idx="1">
-            <a:schemeClr val="accent1"/>
-          </a:lnRef>
-          <a:fillRef idx="3">
-            <a:schemeClr val="accent1"/>
-          </a:fillRef>
-          <a:effectRef idx="2">
-            <a:schemeClr val="accent1"/>
-          </a:effectRef>
-          <a:fontRef idx="minor">
-            <a:schemeClr val="lt1"/>
-          </a:fontRef>
-        </p:style>
-        <p:txBody>
-          <a:bodyPr rtlCol="0" anchor="ctr"/>
-          <a:lstStyle/>
-          <a:p>
-            <a:pPr algn="ctr"/>
-          </a:p>
-        </p:txBody>
-      </p:sp>
-      <p:sp>
-        <p:nvSpPr>
-          <p:cNvPr id="143" name="Rectangle 142"/>
-          <p:cNvSpPr/>
-          <p:nvPr/>
-        </p:nvSpPr>
-        <p:spPr>
-          <a:xfrm>
-            <a:off x="9290303" y="4037074"/>
-            <a:ext cx="18288" cy="82297"/>
-          </a:xfrm>
-          <a:prstGeom prst="rect">
-            <a:avLst/>
-          </a:prstGeom>
-          <a:solidFill>
-            <a:srgbClr val="00C8F0"/>
-          </a:solidFill>
-          <a:ln>
-            <a:noFill/>
-          </a:ln>
-        </p:spPr>
-        <p:style>
-          <a:lnRef idx="1">
-            <a:schemeClr val="accent1"/>
-          </a:lnRef>
-          <a:fillRef idx="3">
-            <a:schemeClr val="accent1"/>
-          </a:fillRef>
-          <a:effectRef idx="2">
-            <a:schemeClr val="accent1"/>
-          </a:effectRef>
-          <a:fontRef idx="minor">
-            <a:schemeClr val="lt1"/>
-          </a:fontRef>
-        </p:style>
-        <p:txBody>
-          <a:bodyPr rtlCol="0" anchor="ctr"/>
-          <a:lstStyle/>
-          <a:p>
-            <a:pPr algn="ctr"/>
-          </a:p>
-        </p:txBody>
-      </p:sp>
-      <p:sp>
-        <p:nvSpPr>
-          <p:cNvPr id="144" name="Rectangle 143"/>
-          <p:cNvSpPr/>
-          <p:nvPr/>
-        </p:nvSpPr>
-        <p:spPr>
-          <a:xfrm>
-            <a:off x="9290303" y="3973068"/>
-            <a:ext cx="18288" cy="82297"/>
-          </a:xfrm>
-          <a:prstGeom prst="rect">
-            <a:avLst/>
-          </a:prstGeom>
-          <a:solidFill>
-            <a:srgbClr val="00C8F0"/>
-          </a:solidFill>
-          <a:ln>
-            <a:noFill/>
-          </a:ln>
-        </p:spPr>
-        <p:style>
-          <a:lnRef idx="1">
-            <a:schemeClr val="accent1"/>
-          </a:lnRef>
-          <a:fillRef idx="3">
-            <a:schemeClr val="accent1"/>
-          </a:fillRef>
-          <a:effectRef idx="2">
-            <a:schemeClr val="accent1"/>
-          </a:effectRef>
-          <a:fontRef idx="minor">
-            <a:schemeClr val="lt1"/>
-          </a:fontRef>
-        </p:style>
-        <p:txBody>
-          <a:bodyPr rtlCol="0" anchor="ctr"/>
-          <a:lstStyle/>
-          <a:p>
-            <a:pPr algn="ctr"/>
-          </a:p>
-        </p:txBody>
-      </p:sp>
-      <p:sp>
-        <p:nvSpPr>
-          <p:cNvPr id="145" name="Rectangle 144"/>
-          <p:cNvSpPr/>
-          <p:nvPr/>
-        </p:nvSpPr>
-        <p:spPr>
-          <a:xfrm>
-            <a:off x="9306762" y="4053533"/>
-            <a:ext cx="18288" cy="65838"/>
-          </a:xfrm>
-          <a:prstGeom prst="rect">
-            <a:avLst/>
-          </a:prstGeom>
-          <a:solidFill>
-            <a:srgbClr val="00C8F0"/>
-          </a:solidFill>
-          <a:ln>
-            <a:noFill/>
-          </a:ln>
-        </p:spPr>
-        <p:style>
-          <a:lnRef idx="1">
-            <a:schemeClr val="accent1"/>
-          </a:lnRef>
-          <a:fillRef idx="3">
-            <a:schemeClr val="accent1"/>
-          </a:fillRef>
-          <a:effectRef idx="2">
-            <a:schemeClr val="accent1"/>
-          </a:effectRef>
-          <a:fontRef idx="minor">
-            <a:schemeClr val="lt1"/>
-          </a:fontRef>
-        </p:style>
-        <p:txBody>
-          <a:bodyPr rtlCol="0" anchor="ctr"/>
-          <a:lstStyle/>
-          <a:p>
-            <a:pPr algn="ctr"/>
-          </a:p>
-        </p:txBody>
-      </p:sp>
-      <p:sp>
-        <p:nvSpPr>
-          <p:cNvPr id="146" name="Rectangle 145"/>
-          <p:cNvSpPr/>
-          <p:nvPr/>
-        </p:nvSpPr>
-        <p:spPr>
-          <a:xfrm>
-            <a:off x="9306762" y="3956609"/>
-            <a:ext cx="18288" cy="65838"/>
-          </a:xfrm>
-          <a:prstGeom prst="rect">
-            <a:avLst/>
-          </a:prstGeom>
-          <a:solidFill>
-            <a:srgbClr val="00C8F0"/>
-          </a:solidFill>
-          <a:ln>
-            <a:noFill/>
-          </a:ln>
-        </p:spPr>
-        <p:style>
-          <a:lnRef idx="1">
-            <a:schemeClr val="accent1"/>
-          </a:lnRef>
-          <a:fillRef idx="3">
-            <a:schemeClr val="accent1"/>
-          </a:fillRef>
-          <a:effectRef idx="2">
-            <a:schemeClr val="accent1"/>
-          </a:effectRef>
-          <a:fontRef idx="minor">
-            <a:schemeClr val="lt1"/>
-          </a:fontRef>
-        </p:style>
-        <p:txBody>
-          <a:bodyPr rtlCol="0" anchor="ctr"/>
-          <a:lstStyle/>
-          <a:p>
-            <a:pPr algn="ctr"/>
-          </a:p>
-        </p:txBody>
-      </p:sp>
-      <p:sp>
-        <p:nvSpPr>
-          <p:cNvPr id="147" name="Rectangle 146"/>
-          <p:cNvSpPr/>
-          <p:nvPr/>
-        </p:nvSpPr>
-        <p:spPr>
-          <a:xfrm>
-            <a:off x="9323221" y="4069992"/>
-            <a:ext cx="18288" cy="49379"/>
-          </a:xfrm>
-          <a:prstGeom prst="rect">
-            <a:avLst/>
-          </a:prstGeom>
-          <a:solidFill>
-            <a:srgbClr val="00C8F0"/>
-          </a:solidFill>
-          <a:ln>
-            <a:noFill/>
-          </a:ln>
-        </p:spPr>
-        <p:style>
-          <a:lnRef idx="1">
-            <a:schemeClr val="accent1"/>
-          </a:lnRef>
-          <a:fillRef idx="3">
-            <a:schemeClr val="accent1"/>
-          </a:fillRef>
-          <a:effectRef idx="2">
-            <a:schemeClr val="accent1"/>
-          </a:effectRef>
-          <a:fontRef idx="minor">
-            <a:schemeClr val="lt1"/>
-          </a:fontRef>
-        </p:style>
-        <p:txBody>
-          <a:bodyPr rtlCol="0" anchor="ctr"/>
-          <a:lstStyle/>
-          <a:p>
-            <a:pPr algn="ctr"/>
-          </a:p>
-        </p:txBody>
-      </p:sp>
-      <p:sp>
-        <p:nvSpPr>
-          <p:cNvPr id="148" name="Rectangle 147"/>
-          <p:cNvSpPr/>
-          <p:nvPr/>
-        </p:nvSpPr>
-        <p:spPr>
-          <a:xfrm>
-            <a:off x="9323221" y="3940150"/>
-            <a:ext cx="18288" cy="49379"/>
-          </a:xfrm>
-          <a:prstGeom prst="rect">
-            <a:avLst/>
-          </a:prstGeom>
-          <a:solidFill>
-            <a:srgbClr val="00C8F0"/>
-          </a:solidFill>
-          <a:ln>
-            <a:noFill/>
-          </a:ln>
-        </p:spPr>
-        <p:style>
-          <a:lnRef idx="1">
-            <a:schemeClr val="accent1"/>
-          </a:lnRef>
-          <a:fillRef idx="3">
-            <a:schemeClr val="accent1"/>
-          </a:fillRef>
-          <a:effectRef idx="2">
-            <a:schemeClr val="accent1"/>
-          </a:effectRef>
-          <a:fontRef idx="minor">
-            <a:schemeClr val="lt1"/>
-          </a:fontRef>
-        </p:style>
-        <p:txBody>
-          <a:bodyPr rtlCol="0" anchor="ctr"/>
-          <a:lstStyle/>
-          <a:p>
-            <a:pPr algn="ctr"/>
-          </a:p>
-        </p:txBody>
-      </p:sp>
-      <p:sp>
-        <p:nvSpPr>
-          <p:cNvPr id="149" name="Oval 148"/>
-          <p:cNvSpPr/>
-          <p:nvPr/>
-        </p:nvSpPr>
-        <p:spPr>
-          <a:xfrm>
-            <a:off x="9875520" y="3803904"/>
-            <a:ext cx="493776" cy="493776"/>
-          </a:xfrm>
-          <a:prstGeom prst="ellipse">
-            <a:avLst/>
-          </a:prstGeom>
-          <a:solidFill>
-            <a:srgbClr val="00C8F0"/>
-          </a:solidFill>
-          <a:ln>
-            <a:noFill/>
-          </a:ln>
-        </p:spPr>
-        <p:style>
-          <a:lnRef idx="1">
-            <a:schemeClr val="accent1"/>
-          </a:lnRef>
-          <a:fillRef idx="3">
-            <a:schemeClr val="accent1"/>
-          </a:fillRef>
-          <a:effectRef idx="2">
-            <a:schemeClr val="accent1"/>
-          </a:effectRef>
-          <a:fontRef idx="minor">
-            <a:schemeClr val="lt1"/>
-          </a:fontRef>
-        </p:style>
-        <p:txBody>
-          <a:bodyPr rtlCol="0" anchor="ctr"/>
-          <a:lstStyle/>
-          <a:p>
-            <a:pPr algn="ctr"/>
-          </a:p>
-        </p:txBody>
-      </p:sp>
-      <p:sp>
-        <p:nvSpPr>
-          <p:cNvPr id="150" name="TextBox 149"/>
+          <p:cNvPr id="70" name="TextBox 69"/>
           <p:cNvSpPr txBox="1"/>
           <p:nvPr/>
         </p:nvSpPr>
@@ -9382,7 +5942,7 @@
       </p:sp>
       <p:sp>
         <p:nvSpPr>
-          <p:cNvPr id="151" name="Rounded Rectangle 150"/>
+          <p:cNvPr id="71" name="Rounded Rectangle 70"/>
           <p:cNvSpPr/>
           <p:nvPr/>
         </p:nvSpPr>
@@ -9425,7 +5985,7 @@
       </p:sp>
       <p:sp>
         <p:nvSpPr>
-          <p:cNvPr id="152" name="TextBox 151"/>
+          <p:cNvPr id="72" name="TextBox 71"/>
           <p:cNvSpPr txBox="1"/>
           <p:nvPr/>
         </p:nvSpPr>
@@ -9461,7 +6021,7 @@
       </p:sp>
       <p:sp>
         <p:nvSpPr>
-          <p:cNvPr id="153" name="Rounded Rectangle 152"/>
+          <p:cNvPr id="73" name="Rounded Rectangle 72"/>
           <p:cNvSpPr/>
           <p:nvPr/>
         </p:nvSpPr>
@@ -9504,7 +6064,7 @@
       </p:sp>
       <p:sp>
         <p:nvSpPr>
-          <p:cNvPr id="154" name="Rectangle 153"/>
+          <p:cNvPr id="74" name="Rectangle 73"/>
           <p:cNvSpPr/>
           <p:nvPr/>
         </p:nvSpPr>
@@ -9547,7 +6107,7 @@
       </p:sp>
       <p:sp>
         <p:nvSpPr>
-          <p:cNvPr id="155" name="TextBox 154"/>
+          <p:cNvPr id="75" name="TextBox 74"/>
           <p:cNvSpPr txBox="1"/>
           <p:nvPr/>
         </p:nvSpPr>
@@ -9582,7 +6142,7 @@
       </p:sp>
       <p:sp>
         <p:nvSpPr>
-          <p:cNvPr id="156" name="TextBox 155"/>
+          <p:cNvPr id="76" name="TextBox 75"/>
           <p:cNvSpPr txBox="1"/>
           <p:nvPr/>
         </p:nvSpPr>
@@ -9665,7 +6225,7 @@
       </p:sp>
       <p:sp>
         <p:nvSpPr>
-          <p:cNvPr id="157" name="Rounded Rectangle 156"/>
+          <p:cNvPr id="77" name="Rounded Rectangle 76"/>
           <p:cNvSpPr/>
           <p:nvPr/>
         </p:nvSpPr>
@@ -9708,7 +6268,7 @@
       </p:sp>
       <p:sp>
         <p:nvSpPr>
-          <p:cNvPr id="158" name="Rectangle 157"/>
+          <p:cNvPr id="78" name="Rectangle 77"/>
           <p:cNvSpPr/>
           <p:nvPr/>
         </p:nvSpPr>
@@ -9751,7 +6311,7 @@
       </p:sp>
       <p:sp>
         <p:nvSpPr>
-          <p:cNvPr id="159" name="TextBox 158"/>
+          <p:cNvPr id="79" name="TextBox 78"/>
           <p:cNvSpPr txBox="1"/>
           <p:nvPr/>
         </p:nvSpPr>
@@ -9786,7 +6346,7 @@
       </p:sp>
       <p:sp>
         <p:nvSpPr>
-          <p:cNvPr id="160" name="TextBox 159"/>
+          <p:cNvPr id="80" name="TextBox 79"/>
           <p:cNvSpPr txBox="1"/>
           <p:nvPr/>
         </p:nvSpPr>
@@ -9821,7 +6381,7 @@
       </p:sp>
       <p:sp>
         <p:nvSpPr>
-          <p:cNvPr id="161" name="TextBox 160"/>
+          <p:cNvPr id="81" name="TextBox 80"/>
           <p:cNvSpPr txBox="1"/>
           <p:nvPr/>
         </p:nvSpPr>
@@ -9856,7 +6416,7 @@
       </p:sp>
       <p:sp>
         <p:nvSpPr>
-          <p:cNvPr id="162" name="Rounded Rectangle 161"/>
+          <p:cNvPr id="82" name="Rounded Rectangle 81"/>
           <p:cNvSpPr/>
           <p:nvPr/>
         </p:nvSpPr>
@@ -9899,7 +6459,7 @@
       </p:sp>
       <p:sp>
         <p:nvSpPr>
-          <p:cNvPr id="163" name="Rectangle 162"/>
+          <p:cNvPr id="83" name="Rectangle 82"/>
           <p:cNvSpPr/>
           <p:nvPr/>
         </p:nvSpPr>
@@ -9942,7 +6502,7 @@
       </p:sp>
       <p:sp>
         <p:nvSpPr>
-          <p:cNvPr id="164" name="TextBox 163"/>
+          <p:cNvPr id="84" name="TextBox 83"/>
           <p:cNvSpPr txBox="1"/>
           <p:nvPr/>
         </p:nvSpPr>
@@ -9977,7 +6537,7 @@
       </p:sp>
       <p:sp>
         <p:nvSpPr>
-          <p:cNvPr id="165" name="TextBox 164"/>
+          <p:cNvPr id="85" name="TextBox 84"/>
           <p:cNvSpPr txBox="1"/>
           <p:nvPr/>
         </p:nvSpPr>
@@ -10012,7 +6572,7 @@
       </p:sp>
       <p:sp>
         <p:nvSpPr>
-          <p:cNvPr id="166" name="Rounded Rectangle 165"/>
+          <p:cNvPr id="86" name="Rounded Rectangle 85"/>
           <p:cNvSpPr/>
           <p:nvPr/>
         </p:nvSpPr>
@@ -10055,7 +6615,7 @@
       </p:sp>
       <p:sp>
         <p:nvSpPr>
-          <p:cNvPr id="167" name="Rectangle 166"/>
+          <p:cNvPr id="87" name="Rectangle 86"/>
           <p:cNvSpPr/>
           <p:nvPr/>
         </p:nvSpPr>
@@ -10098,7 +6658,7 @@
       </p:sp>
       <p:sp>
         <p:nvSpPr>
-          <p:cNvPr id="168" name="TextBox 167"/>
+          <p:cNvPr id="88" name="TextBox 87"/>
           <p:cNvSpPr txBox="1"/>
           <p:nvPr/>
         </p:nvSpPr>
@@ -10133,7 +6693,7 @@
       </p:sp>
       <p:sp>
         <p:nvSpPr>
-          <p:cNvPr id="169" name="TextBox 168"/>
+          <p:cNvPr id="89" name="TextBox 88"/>
           <p:cNvSpPr txBox="1"/>
           <p:nvPr/>
         </p:nvSpPr>
@@ -10168,7 +6728,7 @@
       </p:sp>
       <p:sp>
         <p:nvSpPr>
-          <p:cNvPr id="170" name="Rounded Rectangle 169"/>
+          <p:cNvPr id="90" name="Rounded Rectangle 89"/>
           <p:cNvSpPr/>
           <p:nvPr/>
         </p:nvSpPr>
@@ -10211,7 +6771,7 @@
       </p:sp>
       <p:sp>
         <p:nvSpPr>
-          <p:cNvPr id="171" name="Rectangle 170"/>
+          <p:cNvPr id="91" name="Rectangle 90"/>
           <p:cNvSpPr/>
           <p:nvPr/>
         </p:nvSpPr>
@@ -10254,7 +6814,7 @@
       </p:sp>
       <p:sp>
         <p:nvSpPr>
-          <p:cNvPr id="172" name="TextBox 171"/>
+          <p:cNvPr id="92" name="TextBox 91"/>
           <p:cNvSpPr txBox="1"/>
           <p:nvPr/>
         </p:nvSpPr>
@@ -10289,7 +6849,7 @@
       </p:sp>
       <p:sp>
         <p:nvSpPr>
-          <p:cNvPr id="173" name="TextBox 172"/>
+          <p:cNvPr id="93" name="TextBox 92"/>
           <p:cNvSpPr txBox="1"/>
           <p:nvPr/>
         </p:nvSpPr>
@@ -10324,7 +6884,7 @@
       </p:sp>
       <p:sp>
         <p:nvSpPr>
-          <p:cNvPr id="174" name="Rounded Rectangle 173"/>
+          <p:cNvPr id="94" name="Rounded Rectangle 93"/>
           <p:cNvSpPr/>
           <p:nvPr/>
         </p:nvSpPr>
@@ -10367,7 +6927,7 @@
       </p:sp>
       <p:sp>
         <p:nvSpPr>
-          <p:cNvPr id="175" name="Rectangle 174"/>
+          <p:cNvPr id="95" name="Rectangle 94"/>
           <p:cNvSpPr/>
           <p:nvPr/>
         </p:nvSpPr>
@@ -10410,7 +6970,7 @@
       </p:sp>
       <p:sp>
         <p:nvSpPr>
-          <p:cNvPr id="176" name="TextBox 175"/>
+          <p:cNvPr id="96" name="TextBox 95"/>
           <p:cNvSpPr txBox="1"/>
           <p:nvPr/>
         </p:nvSpPr>
@@ -10445,7 +7005,7 @@
       </p:sp>
       <p:sp>
         <p:nvSpPr>
-          <p:cNvPr id="177" name="TextBox 176"/>
+          <p:cNvPr id="97" name="TextBox 96"/>
           <p:cNvSpPr txBox="1"/>
           <p:nvPr/>
         </p:nvSpPr>
@@ -10480,7 +7040,7 @@
       </p:sp>
       <p:sp>
         <p:nvSpPr>
-          <p:cNvPr id="178" name="TextBox 177"/>
+          <p:cNvPr id="98" name="TextBox 97"/>
           <p:cNvSpPr txBox="1"/>
           <p:nvPr/>
         </p:nvSpPr>
@@ -10515,7 +7075,7 @@
       </p:sp>
       <p:sp>
         <p:nvSpPr>
-          <p:cNvPr id="179" name="TextBox 178"/>
+          <p:cNvPr id="99" name="TextBox 98"/>
           <p:cNvSpPr txBox="1"/>
           <p:nvPr/>
         </p:nvSpPr>

</xml_diff>

<commit_message>
Recreate poster around AEPLO NPI gate demo
Co-authored-by: Shyam <shyam.nexus@gmail.com>
</commit_message>
<xml_diff>
--- a/Coding Embedded Workstream - Common Idea Poster.pptx
+++ b/Coding Embedded Workstream - Common Idea Poster.pptx
@@ -3189,7 +3189,7 @@
             <a:avLst/>
           </a:prstGeom>
           <a:solidFill>
-            <a:srgbClr val="0072C6"/>
+            <a:srgbClr val="8B5CF6"/>
           </a:solidFill>
           <a:ln>
             <a:noFill/>
@@ -3225,8 +3225,8 @@
         </p:nvSpPr>
         <p:spPr>
           <a:xfrm>
-            <a:off x="8412480" y="320040"/>
-            <a:ext cx="3566160" cy="9144"/>
+            <a:off x="8046720" y="292608"/>
+            <a:ext cx="3886200" cy="7315"/>
           </a:xfrm>
           <a:prstGeom prst="rect">
             <a:avLst/>
@@ -3268,8 +3268,8 @@
         </p:nvSpPr>
         <p:spPr>
           <a:xfrm>
-            <a:off x="8412480" y="758952"/>
-            <a:ext cx="3566160" cy="9144"/>
+            <a:off x="8046720" y="621792"/>
+            <a:ext cx="3886200" cy="7315"/>
           </a:xfrm>
           <a:prstGeom prst="rect">
             <a:avLst/>
@@ -3311,8 +3311,8 @@
         </p:nvSpPr>
         <p:spPr>
           <a:xfrm>
-            <a:off x="8412480" y="1197864"/>
-            <a:ext cx="3566160" cy="9144"/>
+            <a:off x="8046720" y="950976"/>
+            <a:ext cx="3886200" cy="7315"/>
           </a:xfrm>
           <a:prstGeom prst="rect">
             <a:avLst/>
@@ -3354,8 +3354,8 @@
         </p:nvSpPr>
         <p:spPr>
           <a:xfrm>
-            <a:off x="8412480" y="1636776"/>
-            <a:ext cx="3566160" cy="9144"/>
+            <a:off x="8046720" y="1280160"/>
+            <a:ext cx="3886200" cy="7315"/>
           </a:xfrm>
           <a:prstGeom prst="rect">
             <a:avLst/>
@@ -3397,8 +3397,8 @@
         </p:nvSpPr>
         <p:spPr>
           <a:xfrm>
-            <a:off x="8412480" y="2075688"/>
-            <a:ext cx="3566160" cy="9144"/>
+            <a:off x="8046720" y="1609344"/>
+            <a:ext cx="3886200" cy="7315"/>
           </a:xfrm>
           <a:prstGeom prst="rect">
             <a:avLst/>
@@ -3440,8 +3440,8 @@
         </p:nvSpPr>
         <p:spPr>
           <a:xfrm>
-            <a:off x="8412480" y="2514600"/>
-            <a:ext cx="3566160" cy="9144"/>
+            <a:off x="8046720" y="1938527"/>
+            <a:ext cx="3886200" cy="7315"/>
           </a:xfrm>
           <a:prstGeom prst="rect">
             <a:avLst/>
@@ -3483,8 +3483,8 @@
         </p:nvSpPr>
         <p:spPr>
           <a:xfrm>
-            <a:off x="8412480" y="2953512"/>
-            <a:ext cx="3566160" cy="9144"/>
+            <a:off x="8046720" y="2267712"/>
+            <a:ext cx="3886200" cy="7315"/>
           </a:xfrm>
           <a:prstGeom prst="rect">
             <a:avLst/>
@@ -3526,8 +3526,8 @@
         </p:nvSpPr>
         <p:spPr>
           <a:xfrm>
-            <a:off x="8412480" y="3392424"/>
-            <a:ext cx="3566160" cy="9144"/>
+            <a:off x="8046720" y="2596896"/>
+            <a:ext cx="3886200" cy="7315"/>
           </a:xfrm>
           <a:prstGeom prst="rect">
             <a:avLst/>
@@ -3569,8 +3569,8 @@
         </p:nvSpPr>
         <p:spPr>
           <a:xfrm>
-            <a:off x="8412480" y="3831335"/>
-            <a:ext cx="3566160" cy="9144"/>
+            <a:off x="8046720" y="2926079"/>
+            <a:ext cx="3886200" cy="7315"/>
           </a:xfrm>
           <a:prstGeom prst="rect">
             <a:avLst/>
@@ -3612,8 +3612,8 @@
         </p:nvSpPr>
         <p:spPr>
           <a:xfrm>
-            <a:off x="8412480" y="4270248"/>
-            <a:ext cx="3566160" cy="9144"/>
+            <a:off x="8046720" y="3255263"/>
+            <a:ext cx="3886200" cy="7315"/>
           </a:xfrm>
           <a:prstGeom prst="rect">
             <a:avLst/>
@@ -3655,8 +3655,8 @@
         </p:nvSpPr>
         <p:spPr>
           <a:xfrm>
-            <a:off x="8412480" y="4709159"/>
-            <a:ext cx="3566160" cy="9144"/>
+            <a:off x="8046720" y="3584447"/>
+            <a:ext cx="3886200" cy="7315"/>
           </a:xfrm>
           <a:prstGeom prst="rect">
             <a:avLst/>
@@ -3698,8 +3698,8 @@
         </p:nvSpPr>
         <p:spPr>
           <a:xfrm>
-            <a:off x="8412480" y="5148071"/>
-            <a:ext cx="3566160" cy="9144"/>
+            <a:off x="8046720" y="3913632"/>
+            <a:ext cx="3886200" cy="7315"/>
           </a:xfrm>
           <a:prstGeom prst="rect">
             <a:avLst/>
@@ -3741,8 +3741,8 @@
         </p:nvSpPr>
         <p:spPr>
           <a:xfrm>
-            <a:off x="8412480" y="5586983"/>
-            <a:ext cx="3566160" cy="9144"/>
+            <a:off x="8046720" y="4242816"/>
+            <a:ext cx="3886200" cy="7315"/>
           </a:xfrm>
           <a:prstGeom prst="rect">
             <a:avLst/>
@@ -3784,8 +3784,8 @@
         </p:nvSpPr>
         <p:spPr>
           <a:xfrm>
-            <a:off x="8458200" y="320040"/>
-            <a:ext cx="9144" cy="5806440"/>
+            <a:off x="8046720" y="4572000"/>
+            <a:ext cx="3886200" cy="7315"/>
           </a:xfrm>
           <a:prstGeom prst="rect">
             <a:avLst/>
@@ -3827,8 +3827,8 @@
         </p:nvSpPr>
         <p:spPr>
           <a:xfrm>
-            <a:off x="8933688" y="320040"/>
-            <a:ext cx="9144" cy="5806440"/>
+            <a:off x="8046720" y="4901184"/>
+            <a:ext cx="3886200" cy="7315"/>
           </a:xfrm>
           <a:prstGeom prst="rect">
             <a:avLst/>
@@ -3870,8 +3870,8 @@
         </p:nvSpPr>
         <p:spPr>
           <a:xfrm>
-            <a:off x="9409176" y="320040"/>
-            <a:ext cx="9144" cy="5806440"/>
+            <a:off x="8046720" y="5230368"/>
+            <a:ext cx="3886200" cy="7315"/>
           </a:xfrm>
           <a:prstGeom prst="rect">
             <a:avLst/>
@@ -3913,8 +3913,8 @@
         </p:nvSpPr>
         <p:spPr>
           <a:xfrm>
-            <a:off x="9884664" y="320040"/>
-            <a:ext cx="9144" cy="5806440"/>
+            <a:off x="8046720" y="5559552"/>
+            <a:ext cx="3886200" cy="7315"/>
           </a:xfrm>
           <a:prstGeom prst="rect">
             <a:avLst/>
@@ -3956,8 +3956,8 @@
         </p:nvSpPr>
         <p:spPr>
           <a:xfrm>
-            <a:off x="10360152" y="320040"/>
-            <a:ext cx="9144" cy="5806440"/>
+            <a:off x="8046720" y="5888736"/>
+            <a:ext cx="3886200" cy="7315"/>
           </a:xfrm>
           <a:prstGeom prst="rect">
             <a:avLst/>
@@ -3999,8 +3999,8 @@
         </p:nvSpPr>
         <p:spPr>
           <a:xfrm>
-            <a:off x="10835640" y="320040"/>
-            <a:ext cx="9144" cy="5806440"/>
+            <a:off x="8092440" y="292608"/>
+            <a:ext cx="7315" cy="5897880"/>
           </a:xfrm>
           <a:prstGeom prst="rect">
             <a:avLst/>
@@ -4042,8 +4042,8 @@
         </p:nvSpPr>
         <p:spPr>
           <a:xfrm>
-            <a:off x="11311128" y="320040"/>
-            <a:ext cx="9144" cy="5806440"/>
+            <a:off x="8476488" y="292608"/>
+            <a:ext cx="7315" cy="5897880"/>
           </a:xfrm>
           <a:prstGeom prst="rect">
             <a:avLst/>
@@ -4085,8 +4085,8 @@
         </p:nvSpPr>
         <p:spPr>
           <a:xfrm>
-            <a:off x="11786616" y="320040"/>
-            <a:ext cx="9144" cy="5806440"/>
+            <a:off x="8860536" y="292608"/>
+            <a:ext cx="7315" cy="5897880"/>
           </a:xfrm>
           <a:prstGeom prst="rect">
             <a:avLst/>
@@ -4122,16 +4122,16 @@
       </p:sp>
       <p:sp>
         <p:nvSpPr>
-          <p:cNvPr id="26" name="Oval 25"/>
+          <p:cNvPr id="26" name="Rectangle 25"/>
           <p:cNvSpPr/>
           <p:nvPr/>
         </p:nvSpPr>
         <p:spPr>
           <a:xfrm>
-            <a:off x="9418320" y="914400"/>
-            <a:ext cx="2057400" cy="2057400"/>
-          </a:xfrm>
-          <a:prstGeom prst="ellipse">
+            <a:off x="9244584" y="292608"/>
+            <a:ext cx="7315" cy="5897880"/>
+          </a:xfrm>
+          <a:prstGeom prst="rect">
             <a:avLst/>
           </a:prstGeom>
           <a:solidFill>
@@ -4165,20 +4165,20 @@
       </p:sp>
       <p:sp>
         <p:nvSpPr>
-          <p:cNvPr id="27" name="Oval 26"/>
+          <p:cNvPr id="27" name="Rectangle 26"/>
           <p:cNvSpPr/>
           <p:nvPr/>
         </p:nvSpPr>
         <p:spPr>
           <a:xfrm>
-            <a:off x="9738360" y="1234440"/>
-            <a:ext cx="1417320" cy="1417320"/>
-          </a:xfrm>
-          <a:prstGeom prst="ellipse">
-            <a:avLst/>
-          </a:prstGeom>
-          <a:solidFill>
-            <a:srgbClr val="0B1F3A"/>
+            <a:off x="9628632" y="292608"/>
+            <a:ext cx="7315" cy="5897880"/>
+          </a:xfrm>
+          <a:prstGeom prst="rect">
+            <a:avLst/>
+          </a:prstGeom>
+          <a:solidFill>
+            <a:srgbClr val="061C38"/>
           </a:solidFill>
           <a:ln>
             <a:noFill/>
@@ -4208,20 +4208,20 @@
       </p:sp>
       <p:sp>
         <p:nvSpPr>
-          <p:cNvPr id="28" name="Oval 27"/>
+          <p:cNvPr id="28" name="Rectangle 27"/>
           <p:cNvSpPr/>
           <p:nvPr/>
         </p:nvSpPr>
         <p:spPr>
           <a:xfrm>
-            <a:off x="10076688" y="1572768"/>
-            <a:ext cx="749808" cy="749808"/>
-          </a:xfrm>
-          <a:prstGeom prst="ellipse">
-            <a:avLst/>
-          </a:prstGeom>
-          <a:solidFill>
-            <a:srgbClr val="05142E"/>
+            <a:off x="10012680" y="292608"/>
+            <a:ext cx="7315" cy="5897880"/>
+          </a:xfrm>
+          <a:prstGeom prst="rect">
+            <a:avLst/>
+          </a:prstGeom>
+          <a:solidFill>
+            <a:srgbClr val="061C38"/>
           </a:solidFill>
           <a:ln>
             <a:noFill/>
@@ -4251,7 +4251,351 @@
       </p:sp>
       <p:sp>
         <p:nvSpPr>
-          <p:cNvPr id="29" name="TextBox 28"/>
+          <p:cNvPr id="29" name="Rectangle 28"/>
+          <p:cNvSpPr/>
+          <p:nvPr/>
+        </p:nvSpPr>
+        <p:spPr>
+          <a:xfrm>
+            <a:off x="10396728" y="292608"/>
+            <a:ext cx="7315" cy="5897880"/>
+          </a:xfrm>
+          <a:prstGeom prst="rect">
+            <a:avLst/>
+          </a:prstGeom>
+          <a:solidFill>
+            <a:srgbClr val="061C38"/>
+          </a:solidFill>
+          <a:ln>
+            <a:noFill/>
+          </a:ln>
+        </p:spPr>
+        <p:style>
+          <a:lnRef idx="1">
+            <a:schemeClr val="accent1"/>
+          </a:lnRef>
+          <a:fillRef idx="3">
+            <a:schemeClr val="accent1"/>
+          </a:fillRef>
+          <a:effectRef idx="2">
+            <a:schemeClr val="accent1"/>
+          </a:effectRef>
+          <a:fontRef idx="minor">
+            <a:schemeClr val="lt1"/>
+          </a:fontRef>
+        </p:style>
+        <p:txBody>
+          <a:bodyPr rtlCol="0" anchor="ctr"/>
+          <a:lstStyle/>
+          <a:p>
+            <a:pPr algn="ctr"/>
+          </a:p>
+        </p:txBody>
+      </p:sp>
+      <p:sp>
+        <p:nvSpPr>
+          <p:cNvPr id="30" name="Rectangle 29"/>
+          <p:cNvSpPr/>
+          <p:nvPr/>
+        </p:nvSpPr>
+        <p:spPr>
+          <a:xfrm>
+            <a:off x="10780776" y="292608"/>
+            <a:ext cx="7315" cy="5897880"/>
+          </a:xfrm>
+          <a:prstGeom prst="rect">
+            <a:avLst/>
+          </a:prstGeom>
+          <a:solidFill>
+            <a:srgbClr val="061C38"/>
+          </a:solidFill>
+          <a:ln>
+            <a:noFill/>
+          </a:ln>
+        </p:spPr>
+        <p:style>
+          <a:lnRef idx="1">
+            <a:schemeClr val="accent1"/>
+          </a:lnRef>
+          <a:fillRef idx="3">
+            <a:schemeClr val="accent1"/>
+          </a:fillRef>
+          <a:effectRef idx="2">
+            <a:schemeClr val="accent1"/>
+          </a:effectRef>
+          <a:fontRef idx="minor">
+            <a:schemeClr val="lt1"/>
+          </a:fontRef>
+        </p:style>
+        <p:txBody>
+          <a:bodyPr rtlCol="0" anchor="ctr"/>
+          <a:lstStyle/>
+          <a:p>
+            <a:pPr algn="ctr"/>
+          </a:p>
+        </p:txBody>
+      </p:sp>
+      <p:sp>
+        <p:nvSpPr>
+          <p:cNvPr id="31" name="Rectangle 30"/>
+          <p:cNvSpPr/>
+          <p:nvPr/>
+        </p:nvSpPr>
+        <p:spPr>
+          <a:xfrm>
+            <a:off x="11164824" y="292608"/>
+            <a:ext cx="7315" cy="5897880"/>
+          </a:xfrm>
+          <a:prstGeom prst="rect">
+            <a:avLst/>
+          </a:prstGeom>
+          <a:solidFill>
+            <a:srgbClr val="061C38"/>
+          </a:solidFill>
+          <a:ln>
+            <a:noFill/>
+          </a:ln>
+        </p:spPr>
+        <p:style>
+          <a:lnRef idx="1">
+            <a:schemeClr val="accent1"/>
+          </a:lnRef>
+          <a:fillRef idx="3">
+            <a:schemeClr val="accent1"/>
+          </a:fillRef>
+          <a:effectRef idx="2">
+            <a:schemeClr val="accent1"/>
+          </a:effectRef>
+          <a:fontRef idx="minor">
+            <a:schemeClr val="lt1"/>
+          </a:fontRef>
+        </p:style>
+        <p:txBody>
+          <a:bodyPr rtlCol="0" anchor="ctr"/>
+          <a:lstStyle/>
+          <a:p>
+            <a:pPr algn="ctr"/>
+          </a:p>
+        </p:txBody>
+      </p:sp>
+      <p:sp>
+        <p:nvSpPr>
+          <p:cNvPr id="32" name="Rectangle 31"/>
+          <p:cNvSpPr/>
+          <p:nvPr/>
+        </p:nvSpPr>
+        <p:spPr>
+          <a:xfrm>
+            <a:off x="11548872" y="292608"/>
+            <a:ext cx="7315" cy="5897880"/>
+          </a:xfrm>
+          <a:prstGeom prst="rect">
+            <a:avLst/>
+          </a:prstGeom>
+          <a:solidFill>
+            <a:srgbClr val="061C38"/>
+          </a:solidFill>
+          <a:ln>
+            <a:noFill/>
+          </a:ln>
+        </p:spPr>
+        <p:style>
+          <a:lnRef idx="1">
+            <a:schemeClr val="accent1"/>
+          </a:lnRef>
+          <a:fillRef idx="3">
+            <a:schemeClr val="accent1"/>
+          </a:fillRef>
+          <a:effectRef idx="2">
+            <a:schemeClr val="accent1"/>
+          </a:effectRef>
+          <a:fontRef idx="minor">
+            <a:schemeClr val="lt1"/>
+          </a:fontRef>
+        </p:style>
+        <p:txBody>
+          <a:bodyPr rtlCol="0" anchor="ctr"/>
+          <a:lstStyle/>
+          <a:p>
+            <a:pPr algn="ctr"/>
+          </a:p>
+        </p:txBody>
+      </p:sp>
+      <p:sp>
+        <p:nvSpPr>
+          <p:cNvPr id="33" name="Rectangle 32"/>
+          <p:cNvSpPr/>
+          <p:nvPr/>
+        </p:nvSpPr>
+        <p:spPr>
+          <a:xfrm>
+            <a:off x="11932920" y="292608"/>
+            <a:ext cx="7315" cy="5897880"/>
+          </a:xfrm>
+          <a:prstGeom prst="rect">
+            <a:avLst/>
+          </a:prstGeom>
+          <a:solidFill>
+            <a:srgbClr val="061C38"/>
+          </a:solidFill>
+          <a:ln>
+            <a:noFill/>
+          </a:ln>
+        </p:spPr>
+        <p:style>
+          <a:lnRef idx="1">
+            <a:schemeClr val="accent1"/>
+          </a:lnRef>
+          <a:fillRef idx="3">
+            <a:schemeClr val="accent1"/>
+          </a:fillRef>
+          <a:effectRef idx="2">
+            <a:schemeClr val="accent1"/>
+          </a:effectRef>
+          <a:fontRef idx="minor">
+            <a:schemeClr val="lt1"/>
+          </a:fontRef>
+        </p:style>
+        <p:txBody>
+          <a:bodyPr rtlCol="0" anchor="ctr"/>
+          <a:lstStyle/>
+          <a:p>
+            <a:pPr algn="ctr"/>
+          </a:p>
+        </p:txBody>
+      </p:sp>
+      <p:sp>
+        <p:nvSpPr>
+          <p:cNvPr id="34" name="Oval 33"/>
+          <p:cNvSpPr/>
+          <p:nvPr/>
+        </p:nvSpPr>
+        <p:spPr>
+          <a:xfrm>
+            <a:off x="9921240" y="713232"/>
+            <a:ext cx="1737360" cy="1737360"/>
+          </a:xfrm>
+          <a:prstGeom prst="ellipse">
+            <a:avLst/>
+          </a:prstGeom>
+          <a:solidFill>
+            <a:srgbClr val="061C38"/>
+          </a:solidFill>
+          <a:ln>
+            <a:noFill/>
+          </a:ln>
+        </p:spPr>
+        <p:style>
+          <a:lnRef idx="1">
+            <a:schemeClr val="accent1"/>
+          </a:lnRef>
+          <a:fillRef idx="3">
+            <a:schemeClr val="accent1"/>
+          </a:fillRef>
+          <a:effectRef idx="2">
+            <a:schemeClr val="accent1"/>
+          </a:effectRef>
+          <a:fontRef idx="minor">
+            <a:schemeClr val="lt1"/>
+          </a:fontRef>
+        </p:style>
+        <p:txBody>
+          <a:bodyPr rtlCol="0" anchor="ctr"/>
+          <a:lstStyle/>
+          <a:p>
+            <a:pPr algn="ctr"/>
+          </a:p>
+        </p:txBody>
+      </p:sp>
+      <p:sp>
+        <p:nvSpPr>
+          <p:cNvPr id="35" name="Oval 34"/>
+          <p:cNvSpPr/>
+          <p:nvPr/>
+        </p:nvSpPr>
+        <p:spPr>
+          <a:xfrm>
+            <a:off x="10195560" y="987552"/>
+            <a:ext cx="1188720" cy="1188720"/>
+          </a:xfrm>
+          <a:prstGeom prst="ellipse">
+            <a:avLst/>
+          </a:prstGeom>
+          <a:solidFill>
+            <a:srgbClr val="0B1F3A"/>
+          </a:solidFill>
+          <a:ln>
+            <a:noFill/>
+          </a:ln>
+        </p:spPr>
+        <p:style>
+          <a:lnRef idx="1">
+            <a:schemeClr val="accent1"/>
+          </a:lnRef>
+          <a:fillRef idx="3">
+            <a:schemeClr val="accent1"/>
+          </a:fillRef>
+          <a:effectRef idx="2">
+            <a:schemeClr val="accent1"/>
+          </a:effectRef>
+          <a:fontRef idx="minor">
+            <a:schemeClr val="lt1"/>
+          </a:fontRef>
+        </p:style>
+        <p:txBody>
+          <a:bodyPr rtlCol="0" anchor="ctr"/>
+          <a:lstStyle/>
+          <a:p>
+            <a:pPr algn="ctr"/>
+          </a:p>
+        </p:txBody>
+      </p:sp>
+      <p:sp>
+        <p:nvSpPr>
+          <p:cNvPr id="36" name="Oval 35"/>
+          <p:cNvSpPr/>
+          <p:nvPr/>
+        </p:nvSpPr>
+        <p:spPr>
+          <a:xfrm>
+            <a:off x="10497312" y="1289304"/>
+            <a:ext cx="585216" cy="585216"/>
+          </a:xfrm>
+          <a:prstGeom prst="ellipse">
+            <a:avLst/>
+          </a:prstGeom>
+          <a:solidFill>
+            <a:srgbClr val="05142E"/>
+          </a:solidFill>
+          <a:ln>
+            <a:noFill/>
+          </a:ln>
+        </p:spPr>
+        <p:style>
+          <a:lnRef idx="1">
+            <a:schemeClr val="accent1"/>
+          </a:lnRef>
+          <a:fillRef idx="3">
+            <a:schemeClr val="accent1"/>
+          </a:fillRef>
+          <a:effectRef idx="2">
+            <a:schemeClr val="accent1"/>
+          </a:effectRef>
+          <a:fontRef idx="minor">
+            <a:schemeClr val="lt1"/>
+          </a:fontRef>
+        </p:style>
+        <p:txBody>
+          <a:bodyPr rtlCol="0" anchor="ctr"/>
+          <a:lstStyle/>
+          <a:p>
+            <a:pPr algn="ctr"/>
+          </a:p>
+        </p:txBody>
+      </p:sp>
+      <p:sp>
+        <p:nvSpPr>
+          <p:cNvPr id="37" name="TextBox 36"/>
           <p:cNvSpPr txBox="1"/>
           <p:nvPr/>
         </p:nvSpPr>
@@ -4286,14 +4630,14 @@
       </p:sp>
       <p:sp>
         <p:nvSpPr>
-          <p:cNvPr id="30" name="TextBox 29"/>
+          <p:cNvPr id="38" name="TextBox 37"/>
           <p:cNvSpPr txBox="1"/>
           <p:nvPr/>
         </p:nvSpPr>
         <p:spPr>
           <a:xfrm>
             <a:off x="320040" y="621792"/>
-            <a:ext cx="7955279" cy="530352"/>
+            <a:ext cx="8183879" cy="530352"/>
           </a:xfrm>
           <a:prstGeom prst="rect">
             <a:avLst/>
@@ -4308,27 +4652,27 @@
           <a:p>
             <a:pPr algn="l"/>
             <a:r>
-              <a:rPr sz="2800" b="1" i="0">
+              <a:rPr sz="2700" b="1" i="0">
                 <a:solidFill>
                   <a:srgbClr val="FFFFFF"/>
                 </a:solidFill>
                 <a:latin typeface="Segoe UI"/>
               </a:rPr>
-              <a:t>Common Idea: Agentic Firmware Debug-to-Fix Copilot</a:t>
-            </a:r>
-          </a:p>
-        </p:txBody>
-      </p:sp>
-      <p:sp>
-        <p:nvSpPr>
-          <p:cNvPr id="31" name="TextBox 30"/>
+              <a:t>AEPLO JTAG Accelerator for Embedded PDLC AI Optimisation</a:t>
+            </a:r>
+          </a:p>
+        </p:txBody>
+      </p:sp>
+      <p:sp>
+        <p:nvSpPr>
+          <p:cNvPr id="39" name="TextBox 38"/>
           <p:cNvSpPr txBox="1"/>
           <p:nvPr/>
         </p:nvSpPr>
         <p:spPr>
           <a:xfrm>
             <a:off x="347472" y="1161288"/>
-            <a:ext cx="7818120" cy="438912"/>
+            <a:ext cx="7955279" cy="438912"/>
           </a:xfrm>
           <a:prstGeom prst="rect">
             <a:avLst/>
@@ -4343,27 +4687,27 @@
           <a:p>
             <a:pPr algn="l"/>
             <a:r>
-              <a:rPr sz="1250" b="0" i="1">
+              <a:rPr sz="1230" b="0" i="1">
                 <a:solidFill>
                   <a:srgbClr val="B8D0EC"/>
                 </a:solidFill>
                 <a:latin typeface="Segoe UI"/>
               </a:rPr>
-              <a:t>A unified AEPLO + JTAG/SWD workflow that turns embedded coding defects into traceable hardware-backed root cause, patch, PR and release evidence.</a:t>
-            </a:r>
-          </a:p>
-        </p:txBody>
-      </p:sp>
-      <p:sp>
-        <p:nvSpPr>
-          <p:cNvPr id="32" name="Rounded Rectangle 31"/>
+              <a:t>Common idea: make JTAG/SWD hardware evidence a native AEPLO capability, optimising the embedded product development lifecycle from discovery to launch.</a:t>
+            </a:r>
+          </a:p>
+        </p:txBody>
+      </p:sp>
+      <p:sp>
+        <p:nvSpPr>
+          <p:cNvPr id="40" name="Rounded Rectangle 39"/>
           <p:cNvSpPr/>
           <p:nvPr/>
         </p:nvSpPr>
         <p:spPr>
           <a:xfrm>
-            <a:off x="8732520" y="530352"/>
-            <a:ext cx="3063240" cy="658368"/>
+            <a:off x="8732520" y="493776"/>
+            <a:ext cx="3063240" cy="749808"/>
           </a:xfrm>
           <a:prstGeom prst="roundRect">
             <a:avLst/>
@@ -4399,14 +4743,14 @@
       </p:sp>
       <p:sp>
         <p:nvSpPr>
-          <p:cNvPr id="33" name="TextBox 32"/>
+          <p:cNvPr id="41" name="TextBox 40"/>
           <p:cNvSpPr txBox="1"/>
           <p:nvPr/>
         </p:nvSpPr>
         <p:spPr>
           <a:xfrm>
-            <a:off x="8732520" y="603504"/>
-            <a:ext cx="3063240" cy="219456"/>
+            <a:off x="8732520" y="566928"/>
+            <a:ext cx="3063240" cy="228600"/>
           </a:xfrm>
           <a:prstGeom prst="rect">
             <a:avLst/>
@@ -4427,21 +4771,21 @@
                 </a:solidFill>
                 <a:latin typeface="Segoe UI"/>
               </a:rPr>
-              <a:t>POSTER CANDIDATE</a:t>
-            </a:r>
-          </a:p>
-        </p:txBody>
-      </p:sp>
-      <p:sp>
-        <p:nvSpPr>
-          <p:cNvPr id="34" name="TextBox 33"/>
+              <a:t>NPI GATE DEMO PLAN</a:t>
+            </a:r>
+          </a:p>
+        </p:txBody>
+      </p:sp>
+      <p:sp>
+        <p:nvSpPr>
+          <p:cNvPr id="42" name="TextBox 41"/>
           <p:cNvSpPr txBox="1"/>
           <p:nvPr/>
         </p:nvSpPr>
         <p:spPr>
           <a:xfrm>
             <a:off x="8732520" y="859536"/>
-            <a:ext cx="3063240" cy="201168"/>
+            <a:ext cx="3063240" cy="228600"/>
           </a:xfrm>
           <a:prstGeom prst="rect">
             <a:avLst/>
@@ -4456,33 +4800,33 @@
           <a:p>
             <a:pPr algn="ctr"/>
             <a:r>
-              <a:rPr sz="950" b="0" i="0">
+              <a:rPr sz="860" b="0" i="0">
                 <a:solidFill>
                   <a:srgbClr val="00C8F0"/>
                 </a:solidFill>
                 <a:latin typeface="Segoe UI"/>
               </a:rPr>
-              <a:t>BuildAThon | Embedded Coding</a:t>
-            </a:r>
-          </a:p>
-        </p:txBody>
-      </p:sp>
-      <p:sp>
-        <p:nvSpPr>
-          <p:cNvPr id="35" name="Rounded Rectangle 34"/>
+              <a:t>PG1 Discovery  -&gt;  PG3 Development  -&gt;  PG5 Validation &amp; Launch Prep</a:t>
+            </a:r>
+          </a:p>
+        </p:txBody>
+      </p:sp>
+      <p:sp>
+        <p:nvSpPr>
+          <p:cNvPr id="43" name="Rounded Rectangle 42"/>
           <p:cNvSpPr/>
           <p:nvPr/>
         </p:nvSpPr>
         <p:spPr>
           <a:xfrm>
-            <a:off x="320040" y="1783080"/>
-            <a:ext cx="3566160" cy="1417320"/>
+            <a:off x="320040" y="1755648"/>
+            <a:ext cx="3520440" cy="749808"/>
           </a:xfrm>
           <a:prstGeom prst="roundRect">
             <a:avLst/>
           </a:prstGeom>
           <a:solidFill>
-            <a:srgbClr val="0F2845"/>
+            <a:srgbClr val="0B1F3A"/>
           </a:solidFill>
           <a:ln>
             <a:noFill/>
@@ -4512,20 +4856,20 @@
       </p:sp>
       <p:sp>
         <p:nvSpPr>
-          <p:cNvPr id="36" name="Rectangle 35"/>
+          <p:cNvPr id="44" name="Rectangle 43"/>
           <p:cNvSpPr/>
           <p:nvPr/>
         </p:nvSpPr>
         <p:spPr>
           <a:xfrm>
-            <a:off x="320040" y="1783080"/>
-            <a:ext cx="54864" cy="1417320"/>
-          </a:xfrm>
-          <a:prstGeom prst="rect">
-            <a:avLst/>
-          </a:prstGeom>
-          <a:solidFill>
-            <a:srgbClr val="FF3A3A"/>
+            <a:off x="320040" y="1755648"/>
+            <a:ext cx="54864" cy="749808"/>
+          </a:xfrm>
+          <a:prstGeom prst="rect">
+            <a:avLst/>
+          </a:prstGeom>
+          <a:solidFill>
+            <a:srgbClr val="0072C6"/>
           </a:solidFill>
           <a:ln>
             <a:noFill/>
@@ -4555,14 +4899,14 @@
       </p:sp>
       <p:sp>
         <p:nvSpPr>
-          <p:cNvPr id="37" name="TextBox 36"/>
+          <p:cNvPr id="45" name="TextBox 44"/>
           <p:cNvSpPr txBox="1"/>
           <p:nvPr/>
         </p:nvSpPr>
         <p:spPr>
           <a:xfrm>
-            <a:off x="502920" y="1901952"/>
-            <a:ext cx="3154680" cy="256032"/>
+            <a:off x="484632" y="1847088"/>
+            <a:ext cx="1417320" cy="228600"/>
           </a:xfrm>
           <a:prstGeom prst="rect">
             <a:avLst/>
@@ -4577,27 +4921,27 @@
           <a:p>
             <a:pPr algn="l"/>
             <a:r>
-              <a:rPr sz="1200" b="1" i="0">
+              <a:rPr sz="1150" b="1" i="0">
                 <a:solidFill>
-                  <a:srgbClr val="FF3A3A"/>
+                  <a:srgbClr val="0072C6"/>
                 </a:solidFill>
                 <a:latin typeface="Segoe UI"/>
               </a:rPr>
-              <a:t>WHY IT MATTERS</a:t>
-            </a:r>
-          </a:p>
-        </p:txBody>
-      </p:sp>
-      <p:sp>
-        <p:nvSpPr>
-          <p:cNvPr id="38" name="TextBox 37"/>
+              <a:t>EMBEDDED</a:t>
+            </a:r>
+          </a:p>
+        </p:txBody>
+      </p:sp>
+      <p:sp>
+        <p:nvSpPr>
+          <p:cNvPr id="46" name="TextBox 45"/>
           <p:cNvSpPr txBox="1"/>
           <p:nvPr/>
         </p:nvSpPr>
         <p:spPr>
           <a:xfrm>
-            <a:off x="502920" y="2221992"/>
-            <a:ext cx="3154680" cy="786384"/>
+            <a:off x="1737360" y="1810512"/>
+            <a:ext cx="1938528" cy="384048"/>
           </a:xfrm>
           <a:prstGeom prst="rect">
             <a:avLst/>
@@ -4610,53 +4954,341 @@
           </a:bodyPr>
           <a:lstStyle/>
           <a:p>
-            <a:pPr/>
-            <a:r>
-              <a:rPr sz="880">
+            <a:pPr algn="l"/>
+            <a:r>
+              <a:rPr sz="880" b="0" i="0">
                 <a:solidFill>
                   <a:srgbClr val="B8D0EC"/>
                 </a:solidFill>
                 <a:latin typeface="Segoe UI"/>
               </a:rPr>
-              <a:t>- MCU bugs require manual JTAG setup, register decoding and memory inspection.</a:t>
-            </a:r>
-          </a:p>
-          <a:p>
-            <a:pPr/>
-            <a:r>
-              <a:rPr sz="880">
+              <a:t>MCU / RTOS / JTAG-SWD / peripherals / board evidence</a:t>
+            </a:r>
+          </a:p>
+        </p:txBody>
+      </p:sp>
+      <p:sp>
+        <p:nvSpPr>
+          <p:cNvPr id="47" name="Rounded Rectangle 46"/>
+          <p:cNvSpPr/>
+          <p:nvPr/>
+        </p:nvSpPr>
+        <p:spPr>
+          <a:xfrm>
+            <a:off x="4069079" y="1755648"/>
+            <a:ext cx="3520440" cy="749808"/>
+          </a:xfrm>
+          <a:prstGeom prst="roundRect">
+            <a:avLst/>
+          </a:prstGeom>
+          <a:solidFill>
+            <a:srgbClr val="0B1F3A"/>
+          </a:solidFill>
+          <a:ln>
+            <a:noFill/>
+          </a:ln>
+        </p:spPr>
+        <p:style>
+          <a:lnRef idx="1">
+            <a:schemeClr val="accent1"/>
+          </a:lnRef>
+          <a:fillRef idx="3">
+            <a:schemeClr val="accent1"/>
+          </a:fillRef>
+          <a:effectRef idx="2">
+            <a:schemeClr val="accent1"/>
+          </a:effectRef>
+          <a:fontRef idx="minor">
+            <a:schemeClr val="lt1"/>
+          </a:fontRef>
+        </p:style>
+        <p:txBody>
+          <a:bodyPr rtlCol="0" anchor="ctr"/>
+          <a:lstStyle/>
+          <a:p>
+            <a:pPr algn="ctr"/>
+          </a:p>
+        </p:txBody>
+      </p:sp>
+      <p:sp>
+        <p:nvSpPr>
+          <p:cNvPr id="48" name="Rectangle 47"/>
+          <p:cNvSpPr/>
+          <p:nvPr/>
+        </p:nvSpPr>
+        <p:spPr>
+          <a:xfrm>
+            <a:off x="4069079" y="1755648"/>
+            <a:ext cx="54864" cy="749808"/>
+          </a:xfrm>
+          <a:prstGeom prst="rect">
+            <a:avLst/>
+          </a:prstGeom>
+          <a:solidFill>
+            <a:srgbClr val="8B5CF6"/>
+          </a:solidFill>
+          <a:ln>
+            <a:noFill/>
+          </a:ln>
+        </p:spPr>
+        <p:style>
+          <a:lnRef idx="1">
+            <a:schemeClr val="accent1"/>
+          </a:lnRef>
+          <a:fillRef idx="3">
+            <a:schemeClr val="accent1"/>
+          </a:fillRef>
+          <a:effectRef idx="2">
+            <a:schemeClr val="accent1"/>
+          </a:effectRef>
+          <a:fontRef idx="minor">
+            <a:schemeClr val="lt1"/>
+          </a:fontRef>
+        </p:style>
+        <p:txBody>
+          <a:bodyPr rtlCol="0" anchor="ctr"/>
+          <a:lstStyle/>
+          <a:p>
+            <a:pPr algn="ctr"/>
+          </a:p>
+        </p:txBody>
+      </p:sp>
+      <p:sp>
+        <p:nvSpPr>
+          <p:cNvPr id="49" name="TextBox 48"/>
+          <p:cNvSpPr txBox="1"/>
+          <p:nvPr/>
+        </p:nvSpPr>
+        <p:spPr>
+          <a:xfrm>
+            <a:off x="4233671" y="1847088"/>
+            <a:ext cx="1417320" cy="228600"/>
+          </a:xfrm>
+          <a:prstGeom prst="rect">
+            <a:avLst/>
+          </a:prstGeom>
+          <a:noFill/>
+        </p:spPr>
+        <p:txBody>
+          <a:bodyPr wrap="square">
+            <a:spAutoFit/>
+          </a:bodyPr>
+          <a:lstStyle/>
+          <a:p>
+            <a:pPr algn="l"/>
+            <a:r>
+              <a:rPr sz="1150" b="1" i="0">
+                <a:solidFill>
+                  <a:srgbClr val="8B5CF6"/>
+                </a:solidFill>
+                <a:latin typeface="Segoe UI"/>
+              </a:rPr>
+              <a:t>PDLC</a:t>
+            </a:r>
+          </a:p>
+        </p:txBody>
+      </p:sp>
+      <p:sp>
+        <p:nvSpPr>
+          <p:cNvPr id="50" name="TextBox 49"/>
+          <p:cNvSpPr txBox="1"/>
+          <p:nvPr/>
+        </p:nvSpPr>
+        <p:spPr>
+          <a:xfrm>
+            <a:off x="5486399" y="1810512"/>
+            <a:ext cx="1938528" cy="384048"/>
+          </a:xfrm>
+          <a:prstGeom prst="rect">
+            <a:avLst/>
+          </a:prstGeom>
+          <a:noFill/>
+        </p:spPr>
+        <p:txBody>
+          <a:bodyPr wrap="square">
+            <a:spAutoFit/>
+          </a:bodyPr>
+          <a:lstStyle/>
+          <a:p>
+            <a:pPr algn="l"/>
+            <a:r>
+              <a:rPr sz="880" b="0" i="0">
                 <a:solidFill>
                   <a:srgbClr val="B8D0EC"/>
                 </a:solidFill>
                 <a:latin typeface="Segoe UI"/>
               </a:rPr>
-              <a:t>- Engineers switch between IDE, probe tools, datasheets, Jira and Git.</a:t>
-            </a:r>
-          </a:p>
-          <a:p>
-            <a:pPr/>
-            <a:r>
-              <a:rPr sz="880">
+              <a:t>Requirements -&gt; code -&gt; debug -&gt; validate -&gt; launch</a:t>
+            </a:r>
+          </a:p>
+        </p:txBody>
+      </p:sp>
+      <p:sp>
+        <p:nvSpPr>
+          <p:cNvPr id="51" name="Rounded Rectangle 50"/>
+          <p:cNvSpPr/>
+          <p:nvPr/>
+        </p:nvSpPr>
+        <p:spPr>
+          <a:xfrm>
+            <a:off x="7818119" y="1755648"/>
+            <a:ext cx="3520440" cy="749808"/>
+          </a:xfrm>
+          <a:prstGeom prst="roundRect">
+            <a:avLst/>
+          </a:prstGeom>
+          <a:solidFill>
+            <a:srgbClr val="0B1F3A"/>
+          </a:solidFill>
+          <a:ln>
+            <a:noFill/>
+          </a:ln>
+        </p:spPr>
+        <p:style>
+          <a:lnRef idx="1">
+            <a:schemeClr val="accent1"/>
+          </a:lnRef>
+          <a:fillRef idx="3">
+            <a:schemeClr val="accent1"/>
+          </a:fillRef>
+          <a:effectRef idx="2">
+            <a:schemeClr val="accent1"/>
+          </a:effectRef>
+          <a:fontRef idx="minor">
+            <a:schemeClr val="lt1"/>
+          </a:fontRef>
+        </p:style>
+        <p:txBody>
+          <a:bodyPr rtlCol="0" anchor="ctr"/>
+          <a:lstStyle/>
+          <a:p>
+            <a:pPr algn="ctr"/>
+          </a:p>
+        </p:txBody>
+      </p:sp>
+      <p:sp>
+        <p:nvSpPr>
+          <p:cNvPr id="52" name="Rectangle 51"/>
+          <p:cNvSpPr/>
+          <p:nvPr/>
+        </p:nvSpPr>
+        <p:spPr>
+          <a:xfrm>
+            <a:off x="7818119" y="1755648"/>
+            <a:ext cx="54864" cy="749808"/>
+          </a:xfrm>
+          <a:prstGeom prst="rect">
+            <a:avLst/>
+          </a:prstGeom>
+          <a:solidFill>
+            <a:srgbClr val="00D48A"/>
+          </a:solidFill>
+          <a:ln>
+            <a:noFill/>
+          </a:ln>
+        </p:spPr>
+        <p:style>
+          <a:lnRef idx="1">
+            <a:schemeClr val="accent1"/>
+          </a:lnRef>
+          <a:fillRef idx="3">
+            <a:schemeClr val="accent1"/>
+          </a:fillRef>
+          <a:effectRef idx="2">
+            <a:schemeClr val="accent1"/>
+          </a:effectRef>
+          <a:fontRef idx="minor">
+            <a:schemeClr val="lt1"/>
+          </a:fontRef>
+        </p:style>
+        <p:txBody>
+          <a:bodyPr rtlCol="0" anchor="ctr"/>
+          <a:lstStyle/>
+          <a:p>
+            <a:pPr algn="ctr"/>
+          </a:p>
+        </p:txBody>
+      </p:sp>
+      <p:sp>
+        <p:nvSpPr>
+          <p:cNvPr id="53" name="TextBox 52"/>
+          <p:cNvSpPr txBox="1"/>
+          <p:nvPr/>
+        </p:nvSpPr>
+        <p:spPr>
+          <a:xfrm>
+            <a:off x="7982711" y="1847088"/>
+            <a:ext cx="1417320" cy="228600"/>
+          </a:xfrm>
+          <a:prstGeom prst="rect">
+            <a:avLst/>
+          </a:prstGeom>
+          <a:noFill/>
+        </p:spPr>
+        <p:txBody>
+          <a:bodyPr wrap="square">
+            <a:spAutoFit/>
+          </a:bodyPr>
+          <a:lstStyle/>
+          <a:p>
+            <a:pPr algn="l"/>
+            <a:r>
+              <a:rPr sz="1150" b="1" i="0">
+                <a:solidFill>
+                  <a:srgbClr val="00D48A"/>
+                </a:solidFill>
+                <a:latin typeface="Segoe UI"/>
+              </a:rPr>
+              <a:t>AI OPTIMISATION</a:t>
+            </a:r>
+          </a:p>
+        </p:txBody>
+      </p:sp>
+      <p:sp>
+        <p:nvSpPr>
+          <p:cNvPr id="54" name="TextBox 53"/>
+          <p:cNvSpPr txBox="1"/>
+          <p:nvPr/>
+        </p:nvSpPr>
+        <p:spPr>
+          <a:xfrm>
+            <a:off x="9235439" y="1810512"/>
+            <a:ext cx="1938528" cy="384048"/>
+          </a:xfrm>
+          <a:prstGeom prst="rect">
+            <a:avLst/>
+          </a:prstGeom>
+          <a:noFill/>
+        </p:spPr>
+        <p:txBody>
+          <a:bodyPr wrap="square">
+            <a:spAutoFit/>
+          </a:bodyPr>
+          <a:lstStyle/>
+          <a:p>
+            <a:pPr algn="l"/>
+            <a:r>
+              <a:rPr sz="880" b="0" i="0">
                 <a:solidFill>
                   <a:srgbClr val="B8D0EC"/>
                 </a:solidFill>
                 <a:latin typeface="Segoe UI"/>
               </a:rPr>
-              <a:t>- HardFault knowledge is tribal, so fixes take days and release risk grows.</a:t>
-            </a:r>
-          </a:p>
-        </p:txBody>
-      </p:sp>
-      <p:sp>
-        <p:nvSpPr>
-          <p:cNvPr id="39" name="Rounded Rectangle 38"/>
+              <a:t>Risk scoring, RCA, test focus, controlled fixes</a:t>
+            </a:r>
+          </a:p>
+        </p:txBody>
+      </p:sp>
+      <p:sp>
+        <p:nvSpPr>
+          <p:cNvPr id="55" name="Rounded Rectangle 54"/>
           <p:cNvSpPr/>
           <p:nvPr/>
         </p:nvSpPr>
         <p:spPr>
           <a:xfrm>
-            <a:off x="4160520" y="1783080"/>
-            <a:ext cx="3886200" cy="1417320"/>
+            <a:off x="320040" y="2697480"/>
+            <a:ext cx="11521440" cy="566928"/>
           </a:xfrm>
           <a:prstGeom prst="roundRect">
             <a:avLst/>
@@ -4692,20 +5324,20 @@
       </p:sp>
       <p:sp>
         <p:nvSpPr>
-          <p:cNvPr id="40" name="Rectangle 39"/>
+          <p:cNvPr id="56" name="Rectangle 55"/>
           <p:cNvSpPr/>
           <p:nvPr/>
         </p:nvSpPr>
         <p:spPr>
           <a:xfrm>
-            <a:off x="4160520" y="1783080"/>
-            <a:ext cx="54864" cy="1417320"/>
-          </a:xfrm>
-          <a:prstGeom prst="rect">
-            <a:avLst/>
-          </a:prstGeom>
-          <a:solidFill>
-            <a:srgbClr val="00D48A"/>
+            <a:off x="320040" y="2697480"/>
+            <a:ext cx="54864" cy="566928"/>
+          </a:xfrm>
+          <a:prstGeom prst="rect">
+            <a:avLst/>
+          </a:prstGeom>
+          <a:solidFill>
+            <a:srgbClr val="00C8F0"/>
           </a:solidFill>
           <a:ln>
             <a:noFill/>
@@ -4735,1590 +5367,14 @@
       </p:sp>
       <p:sp>
         <p:nvSpPr>
-          <p:cNvPr id="41" name="TextBox 40"/>
-          <p:cNvSpPr txBox="1"/>
-          <p:nvPr/>
-        </p:nvSpPr>
-        <p:spPr>
-          <a:xfrm>
-            <a:off x="4343400" y="1901952"/>
-            <a:ext cx="3474720" cy="256032"/>
-          </a:xfrm>
-          <a:prstGeom prst="rect">
-            <a:avLst/>
-          </a:prstGeom>
-          <a:noFill/>
-        </p:spPr>
-        <p:txBody>
-          <a:bodyPr wrap="square">
-            <a:spAutoFit/>
-          </a:bodyPr>
-          <a:lstStyle/>
-          <a:p>
-            <a:pPr algn="l"/>
-            <a:r>
-              <a:rPr sz="1200" b="1" i="0">
-                <a:solidFill>
-                  <a:srgbClr val="00D48A"/>
-                </a:solidFill>
-                <a:latin typeface="Segoe UI"/>
-              </a:rPr>
-              <a:t>COMMON IDEA</a:t>
-            </a:r>
-          </a:p>
-        </p:txBody>
-      </p:sp>
-      <p:sp>
-        <p:nvSpPr>
-          <p:cNvPr id="42" name="TextBox 41"/>
-          <p:cNvSpPr txBox="1"/>
-          <p:nvPr/>
-        </p:nvSpPr>
-        <p:spPr>
-          <a:xfrm>
-            <a:off x="4343400" y="2221992"/>
-            <a:ext cx="3429000" cy="786384"/>
-          </a:xfrm>
-          <a:prstGeom prst="rect">
-            <a:avLst/>
-          </a:prstGeom>
-          <a:noFill/>
-        </p:spPr>
-        <p:txBody>
-          <a:bodyPr wrap="square">
-            <a:spAutoFit/>
-          </a:bodyPr>
-          <a:lstStyle/>
-          <a:p>
-            <a:pPr/>
-            <a:r>
-              <a:rPr sz="880">
-                <a:solidFill>
-                  <a:srgbClr val="B8D0EC"/>
-                </a:solidFill>
-                <a:latin typeface="Segoe UI"/>
-              </a:rPr>
-              <a:t>- Attach multi-agent AI to the coding workflow and target hardware.</a:t>
-            </a:r>
-          </a:p>
-          <a:p>
-            <a:pPr/>
-            <a:r>
-              <a:rPr sz="880">
-                <a:solidFill>
-                  <a:srgbClr val="B8D0EC"/>
-                </a:solidFill>
-                <a:latin typeface="Segoe UI"/>
-              </a:rPr>
-              <a:t>- Use JTAG/SWD evidence as first-class lifecycle data in AEPLO.</a:t>
-            </a:r>
-          </a:p>
-          <a:p>
-            <a:pPr/>
-            <a:r>
-              <a:rPr sz="880">
-                <a:solidFill>
-                  <a:srgbClr val="B8D0EC"/>
-                </a:solidFill>
-                <a:latin typeface="Segoe UI"/>
-              </a:rPr>
-              <a:t>- Move from bug ticket to diagnosis, controlled fix, PR and release gate.</a:t>
-            </a:r>
-          </a:p>
-        </p:txBody>
-      </p:sp>
-      <p:sp>
-        <p:nvSpPr>
-          <p:cNvPr id="43" name="TextBox 42"/>
-          <p:cNvSpPr txBox="1"/>
-          <p:nvPr/>
-        </p:nvSpPr>
-        <p:spPr>
-          <a:xfrm>
-            <a:off x="320040" y="3456432"/>
-            <a:ext cx="1828800" cy="274320"/>
-          </a:xfrm>
-          <a:prstGeom prst="rect">
-            <a:avLst/>
-          </a:prstGeom>
-          <a:noFill/>
-        </p:spPr>
-        <p:txBody>
-          <a:bodyPr wrap="square">
-            <a:spAutoFit/>
-          </a:bodyPr>
-          <a:lstStyle/>
-          <a:p>
-            <a:pPr algn="l"/>
-            <a:r>
-              <a:rPr sz="1200" b="1" i="0">
-                <a:solidFill>
-                  <a:srgbClr val="00C8F0"/>
-                </a:solidFill>
-                <a:latin typeface="Segoe UI"/>
-              </a:rPr>
-              <a:t>WORKFLOW</a:t>
-            </a:r>
-          </a:p>
-        </p:txBody>
-      </p:sp>
-      <p:sp>
-        <p:nvSpPr>
-          <p:cNvPr id="44" name="Oval 43"/>
-          <p:cNvSpPr/>
-          <p:nvPr/>
-        </p:nvSpPr>
-        <p:spPr>
-          <a:xfrm>
-            <a:off x="502920" y="3803904"/>
-            <a:ext cx="493776" cy="493776"/>
-          </a:xfrm>
-          <a:prstGeom prst="ellipse">
-            <a:avLst/>
-          </a:prstGeom>
-          <a:solidFill>
-            <a:srgbClr val="0072C6"/>
-          </a:solidFill>
-          <a:ln>
-            <a:noFill/>
-          </a:ln>
-        </p:spPr>
-        <p:style>
-          <a:lnRef idx="1">
-            <a:schemeClr val="accent1"/>
-          </a:lnRef>
-          <a:fillRef idx="3">
-            <a:schemeClr val="accent1"/>
-          </a:fillRef>
-          <a:effectRef idx="2">
-            <a:schemeClr val="accent1"/>
-          </a:effectRef>
-          <a:fontRef idx="minor">
-            <a:schemeClr val="lt1"/>
-          </a:fontRef>
-        </p:style>
-        <p:txBody>
-          <a:bodyPr rtlCol="0" anchor="ctr"/>
-          <a:lstStyle/>
-          <a:p>
-            <a:pPr algn="ctr"/>
-          </a:p>
-        </p:txBody>
-      </p:sp>
-      <p:sp>
-        <p:nvSpPr>
-          <p:cNvPr id="45" name="TextBox 44"/>
-          <p:cNvSpPr txBox="1"/>
-          <p:nvPr/>
-        </p:nvSpPr>
-        <p:spPr>
-          <a:xfrm>
-            <a:off x="502920" y="3831336"/>
-            <a:ext cx="493776" cy="201168"/>
-          </a:xfrm>
-          <a:prstGeom prst="rect">
-            <a:avLst/>
-          </a:prstGeom>
-          <a:noFill/>
-        </p:spPr>
-        <p:txBody>
-          <a:bodyPr wrap="square">
-            <a:spAutoFit/>
-          </a:bodyPr>
-          <a:lstStyle/>
-          <a:p>
-            <a:pPr algn="ctr"/>
-            <a:r>
-              <a:rPr sz="1100" b="1" i="0">
-                <a:solidFill>
-                  <a:srgbClr val="FFFFFF"/>
-                </a:solidFill>
-                <a:latin typeface="Segoe UI"/>
-              </a:rPr>
-              <a:t>1</a:t>
-            </a:r>
-          </a:p>
-        </p:txBody>
-      </p:sp>
-      <p:sp>
-        <p:nvSpPr>
-          <p:cNvPr id="46" name="Rounded Rectangle 45"/>
-          <p:cNvSpPr/>
-          <p:nvPr/>
-        </p:nvSpPr>
-        <p:spPr>
-          <a:xfrm>
-            <a:off x="210312" y="4407408"/>
-            <a:ext cx="1078992" cy="676656"/>
-          </a:xfrm>
-          <a:prstGeom prst="roundRect">
-            <a:avLst/>
-          </a:prstGeom>
-          <a:solidFill>
-            <a:srgbClr val="0B1F3A"/>
-          </a:solidFill>
-          <a:ln>
-            <a:noFill/>
-          </a:ln>
-        </p:spPr>
-        <p:style>
-          <a:lnRef idx="1">
-            <a:schemeClr val="accent1"/>
-          </a:lnRef>
-          <a:fillRef idx="3">
-            <a:schemeClr val="accent1"/>
-          </a:fillRef>
-          <a:effectRef idx="2">
-            <a:schemeClr val="accent1"/>
-          </a:effectRef>
-          <a:fontRef idx="minor">
-            <a:schemeClr val="lt1"/>
-          </a:fontRef>
-        </p:style>
-        <p:txBody>
-          <a:bodyPr rtlCol="0" anchor="ctr"/>
-          <a:lstStyle/>
-          <a:p>
-            <a:pPr algn="ctr"/>
-          </a:p>
-        </p:txBody>
-      </p:sp>
-      <p:sp>
-        <p:nvSpPr>
-          <p:cNvPr id="47" name="TextBox 46"/>
-          <p:cNvSpPr txBox="1"/>
-          <p:nvPr/>
-        </p:nvSpPr>
-        <p:spPr>
-          <a:xfrm>
-            <a:off x="283464" y="4498848"/>
-            <a:ext cx="932688" cy="347472"/>
-          </a:xfrm>
-          <a:prstGeom prst="rect">
-            <a:avLst/>
-          </a:prstGeom>
-          <a:noFill/>
-        </p:spPr>
-        <p:txBody>
-          <a:bodyPr wrap="square">
-            <a:spAutoFit/>
-          </a:bodyPr>
-          <a:lstStyle/>
-          <a:p>
-            <a:pPr algn="ctr"/>
-            <a:r>
-              <a:rPr sz="880" b="1" i="0">
-                <a:solidFill>
-                  <a:srgbClr val="B8D0EC"/>
-                </a:solidFill>
-                <a:latin typeface="Segoe UI"/>
-              </a:rPr>
-              <a:t>Jira Bug
-Ticket</a:t>
-            </a:r>
-          </a:p>
-        </p:txBody>
-      </p:sp>
-      <p:sp>
-        <p:nvSpPr>
-          <p:cNvPr id="48" name="Right Arrow 47"/>
-          <p:cNvSpPr/>
-          <p:nvPr/>
-        </p:nvSpPr>
-        <p:spPr>
-          <a:xfrm>
-            <a:off x="1188720" y="3959352"/>
-            <a:ext cx="960120" cy="182880"/>
-          </a:xfrm>
-          <a:prstGeom prst="rightArrow">
-            <a:avLst/>
-          </a:prstGeom>
-          <a:solidFill>
-            <a:srgbClr val="00C8F0"/>
-          </a:solidFill>
-          <a:ln>
-            <a:noFill/>
-          </a:ln>
-        </p:spPr>
-        <p:style>
-          <a:lnRef idx="1">
-            <a:schemeClr val="accent1"/>
-          </a:lnRef>
-          <a:fillRef idx="3">
-            <a:schemeClr val="accent1"/>
-          </a:fillRef>
-          <a:effectRef idx="2">
-            <a:schemeClr val="accent1"/>
-          </a:effectRef>
-          <a:fontRef idx="minor">
-            <a:schemeClr val="lt1"/>
-          </a:fontRef>
-        </p:style>
-        <p:txBody>
-          <a:bodyPr rtlCol="0" anchor="ctr"/>
-          <a:lstStyle/>
-          <a:p>
-            <a:pPr algn="ctr"/>
-          </a:p>
-        </p:txBody>
-      </p:sp>
-      <p:sp>
-        <p:nvSpPr>
-          <p:cNvPr id="49" name="Oval 48"/>
-          <p:cNvSpPr/>
-          <p:nvPr/>
-        </p:nvSpPr>
-        <p:spPr>
-          <a:xfrm>
-            <a:off x="2377439" y="3803904"/>
-            <a:ext cx="493776" cy="493776"/>
-          </a:xfrm>
-          <a:prstGeom prst="ellipse">
-            <a:avLst/>
-          </a:prstGeom>
-          <a:solidFill>
-            <a:srgbClr val="FF8C00"/>
-          </a:solidFill>
-          <a:ln>
-            <a:noFill/>
-          </a:ln>
-        </p:spPr>
-        <p:style>
-          <a:lnRef idx="1">
-            <a:schemeClr val="accent1"/>
-          </a:lnRef>
-          <a:fillRef idx="3">
-            <a:schemeClr val="accent1"/>
-          </a:fillRef>
-          <a:effectRef idx="2">
-            <a:schemeClr val="accent1"/>
-          </a:effectRef>
-          <a:fontRef idx="minor">
-            <a:schemeClr val="lt1"/>
-          </a:fontRef>
-        </p:style>
-        <p:txBody>
-          <a:bodyPr rtlCol="0" anchor="ctr"/>
-          <a:lstStyle/>
-          <a:p>
-            <a:pPr algn="ctr"/>
-          </a:p>
-        </p:txBody>
-      </p:sp>
-      <p:sp>
-        <p:nvSpPr>
-          <p:cNvPr id="50" name="TextBox 49"/>
-          <p:cNvSpPr txBox="1"/>
-          <p:nvPr/>
-        </p:nvSpPr>
-        <p:spPr>
-          <a:xfrm>
-            <a:off x="2377439" y="3831336"/>
-            <a:ext cx="493776" cy="201168"/>
-          </a:xfrm>
-          <a:prstGeom prst="rect">
-            <a:avLst/>
-          </a:prstGeom>
-          <a:noFill/>
-        </p:spPr>
-        <p:txBody>
-          <a:bodyPr wrap="square">
-            <a:spAutoFit/>
-          </a:bodyPr>
-          <a:lstStyle/>
-          <a:p>
-            <a:pPr algn="ctr"/>
-            <a:r>
-              <a:rPr sz="1100" b="1" i="0">
-                <a:solidFill>
-                  <a:srgbClr val="FFFFFF"/>
-                </a:solidFill>
-                <a:latin typeface="Segoe UI"/>
-              </a:rPr>
-              <a:t>2</a:t>
-            </a:r>
-          </a:p>
-        </p:txBody>
-      </p:sp>
-      <p:sp>
-        <p:nvSpPr>
-          <p:cNvPr id="51" name="Rounded Rectangle 50"/>
-          <p:cNvSpPr/>
-          <p:nvPr/>
-        </p:nvSpPr>
-        <p:spPr>
-          <a:xfrm>
-            <a:off x="2084831" y="4407408"/>
-            <a:ext cx="1078992" cy="676656"/>
-          </a:xfrm>
-          <a:prstGeom prst="roundRect">
-            <a:avLst/>
-          </a:prstGeom>
-          <a:solidFill>
-            <a:srgbClr val="0B1F3A"/>
-          </a:solidFill>
-          <a:ln>
-            <a:noFill/>
-          </a:ln>
-        </p:spPr>
-        <p:style>
-          <a:lnRef idx="1">
-            <a:schemeClr val="accent1"/>
-          </a:lnRef>
-          <a:fillRef idx="3">
-            <a:schemeClr val="accent1"/>
-          </a:fillRef>
-          <a:effectRef idx="2">
-            <a:schemeClr val="accent1"/>
-          </a:effectRef>
-          <a:fontRef idx="minor">
-            <a:schemeClr val="lt1"/>
-          </a:fontRef>
-        </p:style>
-        <p:txBody>
-          <a:bodyPr rtlCol="0" anchor="ctr"/>
-          <a:lstStyle/>
-          <a:p>
-            <a:pPr algn="ctr"/>
-          </a:p>
-        </p:txBody>
-      </p:sp>
-      <p:sp>
-        <p:nvSpPr>
-          <p:cNvPr id="52" name="TextBox 51"/>
-          <p:cNvSpPr txBox="1"/>
-          <p:nvPr/>
-        </p:nvSpPr>
-        <p:spPr>
-          <a:xfrm>
-            <a:off x="2157983" y="4498848"/>
-            <a:ext cx="932688" cy="347472"/>
-          </a:xfrm>
-          <a:prstGeom prst="rect">
-            <a:avLst/>
-          </a:prstGeom>
-          <a:noFill/>
-        </p:spPr>
-        <p:txBody>
-          <a:bodyPr wrap="square">
-            <a:spAutoFit/>
-          </a:bodyPr>
-          <a:lstStyle/>
-          <a:p>
-            <a:pPr algn="ctr"/>
-            <a:r>
-              <a:rPr sz="880" b="1" i="0">
-                <a:solidFill>
-                  <a:srgbClr val="B8D0EC"/>
-                </a:solidFill>
-                <a:latin typeface="Segoe UI"/>
-              </a:rPr>
-              <a:t>JTAG
-Orchestrator</a:t>
-            </a:r>
-          </a:p>
-        </p:txBody>
-      </p:sp>
-      <p:sp>
-        <p:nvSpPr>
-          <p:cNvPr id="53" name="Right Arrow 52"/>
-          <p:cNvSpPr/>
-          <p:nvPr/>
-        </p:nvSpPr>
-        <p:spPr>
-          <a:xfrm>
-            <a:off x="3063239" y="3959352"/>
-            <a:ext cx="960120" cy="182880"/>
-          </a:xfrm>
-          <a:prstGeom prst="rightArrow">
-            <a:avLst/>
-          </a:prstGeom>
-          <a:solidFill>
-            <a:srgbClr val="00C8F0"/>
-          </a:solidFill>
-          <a:ln>
-            <a:noFill/>
-          </a:ln>
-        </p:spPr>
-        <p:style>
-          <a:lnRef idx="1">
-            <a:schemeClr val="accent1"/>
-          </a:lnRef>
-          <a:fillRef idx="3">
-            <a:schemeClr val="accent1"/>
-          </a:fillRef>
-          <a:effectRef idx="2">
-            <a:schemeClr val="accent1"/>
-          </a:effectRef>
-          <a:fontRef idx="minor">
-            <a:schemeClr val="lt1"/>
-          </a:fontRef>
-        </p:style>
-        <p:txBody>
-          <a:bodyPr rtlCol="0" anchor="ctr"/>
-          <a:lstStyle/>
-          <a:p>
-            <a:pPr algn="ctr"/>
-          </a:p>
-        </p:txBody>
-      </p:sp>
-      <p:sp>
-        <p:nvSpPr>
-          <p:cNvPr id="54" name="Oval 53"/>
-          <p:cNvSpPr/>
-          <p:nvPr/>
-        </p:nvSpPr>
-        <p:spPr>
-          <a:xfrm>
-            <a:off x="4251959" y="3803904"/>
-            <a:ext cx="493776" cy="493776"/>
-          </a:xfrm>
-          <a:prstGeom prst="ellipse">
-            <a:avLst/>
-          </a:prstGeom>
-          <a:solidFill>
-            <a:srgbClr val="8B5CF6"/>
-          </a:solidFill>
-          <a:ln>
-            <a:noFill/>
-          </a:ln>
-        </p:spPr>
-        <p:style>
-          <a:lnRef idx="1">
-            <a:schemeClr val="accent1"/>
-          </a:lnRef>
-          <a:fillRef idx="3">
-            <a:schemeClr val="accent1"/>
-          </a:fillRef>
-          <a:effectRef idx="2">
-            <a:schemeClr val="accent1"/>
-          </a:effectRef>
-          <a:fontRef idx="minor">
-            <a:schemeClr val="lt1"/>
-          </a:fontRef>
-        </p:style>
-        <p:txBody>
-          <a:bodyPr rtlCol="0" anchor="ctr"/>
-          <a:lstStyle/>
-          <a:p>
-            <a:pPr algn="ctr"/>
-          </a:p>
-        </p:txBody>
-      </p:sp>
-      <p:sp>
-        <p:nvSpPr>
-          <p:cNvPr id="55" name="TextBox 54"/>
-          <p:cNvSpPr txBox="1"/>
-          <p:nvPr/>
-        </p:nvSpPr>
-        <p:spPr>
-          <a:xfrm>
-            <a:off x="4251959" y="3831336"/>
-            <a:ext cx="493776" cy="201168"/>
-          </a:xfrm>
-          <a:prstGeom prst="rect">
-            <a:avLst/>
-          </a:prstGeom>
-          <a:noFill/>
-        </p:spPr>
-        <p:txBody>
-          <a:bodyPr wrap="square">
-            <a:spAutoFit/>
-          </a:bodyPr>
-          <a:lstStyle/>
-          <a:p>
-            <a:pPr algn="ctr"/>
-            <a:r>
-              <a:rPr sz="1100" b="1" i="0">
-                <a:solidFill>
-                  <a:srgbClr val="FFFFFF"/>
-                </a:solidFill>
-                <a:latin typeface="Segoe UI"/>
-              </a:rPr>
-              <a:t>3</a:t>
-            </a:r>
-          </a:p>
-        </p:txBody>
-      </p:sp>
-      <p:sp>
-        <p:nvSpPr>
-          <p:cNvPr id="56" name="Rounded Rectangle 55"/>
-          <p:cNvSpPr/>
-          <p:nvPr/>
-        </p:nvSpPr>
-        <p:spPr>
-          <a:xfrm>
-            <a:off x="3959351" y="4407408"/>
-            <a:ext cx="1078992" cy="676656"/>
-          </a:xfrm>
-          <a:prstGeom prst="roundRect">
-            <a:avLst/>
-          </a:prstGeom>
-          <a:solidFill>
-            <a:srgbClr val="0B1F3A"/>
-          </a:solidFill>
-          <a:ln>
-            <a:noFill/>
-          </a:ln>
-        </p:spPr>
-        <p:style>
-          <a:lnRef idx="1">
-            <a:schemeClr val="accent1"/>
-          </a:lnRef>
-          <a:fillRef idx="3">
-            <a:schemeClr val="accent1"/>
-          </a:fillRef>
-          <a:effectRef idx="2">
-            <a:schemeClr val="accent1"/>
-          </a:effectRef>
-          <a:fontRef idx="minor">
-            <a:schemeClr val="lt1"/>
-          </a:fontRef>
-        </p:style>
-        <p:txBody>
-          <a:bodyPr rtlCol="0" anchor="ctr"/>
-          <a:lstStyle/>
-          <a:p>
-            <a:pPr algn="ctr"/>
-          </a:p>
-        </p:txBody>
-      </p:sp>
-      <p:sp>
-        <p:nvSpPr>
           <p:cNvPr id="57" name="TextBox 56"/>
           <p:cNvSpPr txBox="1"/>
           <p:nvPr/>
         </p:nvSpPr>
         <p:spPr>
           <a:xfrm>
-            <a:off x="4032503" y="4498848"/>
-            <a:ext cx="932688" cy="347472"/>
-          </a:xfrm>
-          <a:prstGeom prst="rect">
-            <a:avLst/>
-          </a:prstGeom>
-          <a:noFill/>
-        </p:spPr>
-        <p:txBody>
-          <a:bodyPr wrap="square">
-            <a:spAutoFit/>
-          </a:bodyPr>
-          <a:lstStyle/>
-          <a:p>
-            <a:pPr algn="ctr"/>
-            <a:r>
-              <a:rPr sz="880" b="1" i="0">
-                <a:solidFill>
-                  <a:srgbClr val="B8D0EC"/>
-                </a:solidFill>
-                <a:latin typeface="Segoe UI"/>
-              </a:rPr>
-              <a:t>Debug
-Agents</a:t>
-            </a:r>
-          </a:p>
-        </p:txBody>
-      </p:sp>
-      <p:sp>
-        <p:nvSpPr>
-          <p:cNvPr id="58" name="Right Arrow 57"/>
-          <p:cNvSpPr/>
-          <p:nvPr/>
-        </p:nvSpPr>
-        <p:spPr>
-          <a:xfrm>
-            <a:off x="4937759" y="3959352"/>
-            <a:ext cx="960120" cy="182880"/>
-          </a:xfrm>
-          <a:prstGeom prst="rightArrow">
-            <a:avLst/>
-          </a:prstGeom>
-          <a:solidFill>
-            <a:srgbClr val="00C8F0"/>
-          </a:solidFill>
-          <a:ln>
-            <a:noFill/>
-          </a:ln>
-        </p:spPr>
-        <p:style>
-          <a:lnRef idx="1">
-            <a:schemeClr val="accent1"/>
-          </a:lnRef>
-          <a:fillRef idx="3">
-            <a:schemeClr val="accent1"/>
-          </a:fillRef>
-          <a:effectRef idx="2">
-            <a:schemeClr val="accent1"/>
-          </a:effectRef>
-          <a:fontRef idx="minor">
-            <a:schemeClr val="lt1"/>
-          </a:fontRef>
-        </p:style>
-        <p:txBody>
-          <a:bodyPr rtlCol="0" anchor="ctr"/>
-          <a:lstStyle/>
-          <a:p>
-            <a:pPr algn="ctr"/>
-          </a:p>
-        </p:txBody>
-      </p:sp>
-      <p:sp>
-        <p:nvSpPr>
-          <p:cNvPr id="59" name="Oval 58"/>
-          <p:cNvSpPr/>
-          <p:nvPr/>
-        </p:nvSpPr>
-        <p:spPr>
-          <a:xfrm>
-            <a:off x="6126479" y="3803904"/>
-            <a:ext cx="493776" cy="493776"/>
-          </a:xfrm>
-          <a:prstGeom prst="ellipse">
-            <a:avLst/>
-          </a:prstGeom>
-          <a:solidFill>
-            <a:srgbClr val="00A89A"/>
-          </a:solidFill>
-          <a:ln>
-            <a:noFill/>
-          </a:ln>
-        </p:spPr>
-        <p:style>
-          <a:lnRef idx="1">
-            <a:schemeClr val="accent1"/>
-          </a:lnRef>
-          <a:fillRef idx="3">
-            <a:schemeClr val="accent1"/>
-          </a:fillRef>
-          <a:effectRef idx="2">
-            <a:schemeClr val="accent1"/>
-          </a:effectRef>
-          <a:fontRef idx="minor">
-            <a:schemeClr val="lt1"/>
-          </a:fontRef>
-        </p:style>
-        <p:txBody>
-          <a:bodyPr rtlCol="0" anchor="ctr"/>
-          <a:lstStyle/>
-          <a:p>
-            <a:pPr algn="ctr"/>
-          </a:p>
-        </p:txBody>
-      </p:sp>
-      <p:sp>
-        <p:nvSpPr>
-          <p:cNvPr id="60" name="TextBox 59"/>
-          <p:cNvSpPr txBox="1"/>
-          <p:nvPr/>
-        </p:nvSpPr>
-        <p:spPr>
-          <a:xfrm>
-            <a:off x="6126479" y="3831336"/>
-            <a:ext cx="493776" cy="201168"/>
-          </a:xfrm>
-          <a:prstGeom prst="rect">
-            <a:avLst/>
-          </a:prstGeom>
-          <a:noFill/>
-        </p:spPr>
-        <p:txBody>
-          <a:bodyPr wrap="square">
-            <a:spAutoFit/>
-          </a:bodyPr>
-          <a:lstStyle/>
-          <a:p>
-            <a:pPr algn="ctr"/>
-            <a:r>
-              <a:rPr sz="1100" b="1" i="0">
-                <a:solidFill>
-                  <a:srgbClr val="FFFFFF"/>
-                </a:solidFill>
-                <a:latin typeface="Segoe UI"/>
-              </a:rPr>
-              <a:t>4</a:t>
-            </a:r>
-          </a:p>
-        </p:txBody>
-      </p:sp>
-      <p:sp>
-        <p:nvSpPr>
-          <p:cNvPr id="61" name="Rounded Rectangle 60"/>
-          <p:cNvSpPr/>
-          <p:nvPr/>
-        </p:nvSpPr>
-        <p:spPr>
-          <a:xfrm>
-            <a:off x="5833871" y="4407408"/>
-            <a:ext cx="1078992" cy="676656"/>
-          </a:xfrm>
-          <a:prstGeom prst="roundRect">
-            <a:avLst/>
-          </a:prstGeom>
-          <a:solidFill>
-            <a:srgbClr val="0B1F3A"/>
-          </a:solidFill>
-          <a:ln>
-            <a:noFill/>
-          </a:ln>
-        </p:spPr>
-        <p:style>
-          <a:lnRef idx="1">
-            <a:schemeClr val="accent1"/>
-          </a:lnRef>
-          <a:fillRef idx="3">
-            <a:schemeClr val="accent1"/>
-          </a:fillRef>
-          <a:effectRef idx="2">
-            <a:schemeClr val="accent1"/>
-          </a:effectRef>
-          <a:fontRef idx="minor">
-            <a:schemeClr val="lt1"/>
-          </a:fontRef>
-        </p:style>
-        <p:txBody>
-          <a:bodyPr rtlCol="0" anchor="ctr"/>
-          <a:lstStyle/>
-          <a:p>
-            <a:pPr algn="ctr"/>
-          </a:p>
-        </p:txBody>
-      </p:sp>
-      <p:sp>
-        <p:nvSpPr>
-          <p:cNvPr id="62" name="TextBox 61"/>
-          <p:cNvSpPr txBox="1"/>
-          <p:nvPr/>
-        </p:nvSpPr>
-        <p:spPr>
-          <a:xfrm>
-            <a:off x="5907023" y="4498848"/>
-            <a:ext cx="932688" cy="347472"/>
-          </a:xfrm>
-          <a:prstGeom prst="rect">
-            <a:avLst/>
-          </a:prstGeom>
-          <a:noFill/>
-        </p:spPr>
-        <p:txBody>
-          <a:bodyPr wrap="square">
-            <a:spAutoFit/>
-          </a:bodyPr>
-          <a:lstStyle/>
-          <a:p>
-            <a:pPr algn="ctr"/>
-            <a:r>
-              <a:rPr sz="880" b="1" i="0">
-                <a:solidFill>
-                  <a:srgbClr val="B8D0EC"/>
-                </a:solidFill>
-                <a:latin typeface="Segoe UI"/>
-              </a:rPr>
-              <a:t>RCA +
-Evidence</a:t>
-            </a:r>
-          </a:p>
-        </p:txBody>
-      </p:sp>
-      <p:sp>
-        <p:nvSpPr>
-          <p:cNvPr id="63" name="Right Arrow 62"/>
-          <p:cNvSpPr/>
-          <p:nvPr/>
-        </p:nvSpPr>
-        <p:spPr>
-          <a:xfrm>
-            <a:off x="6812279" y="3959352"/>
-            <a:ext cx="960120" cy="182880"/>
-          </a:xfrm>
-          <a:prstGeom prst="rightArrow">
-            <a:avLst/>
-          </a:prstGeom>
-          <a:solidFill>
-            <a:srgbClr val="00C8F0"/>
-          </a:solidFill>
-          <a:ln>
-            <a:noFill/>
-          </a:ln>
-        </p:spPr>
-        <p:style>
-          <a:lnRef idx="1">
-            <a:schemeClr val="accent1"/>
-          </a:lnRef>
-          <a:fillRef idx="3">
-            <a:schemeClr val="accent1"/>
-          </a:fillRef>
-          <a:effectRef idx="2">
-            <a:schemeClr val="accent1"/>
-          </a:effectRef>
-          <a:fontRef idx="minor">
-            <a:schemeClr val="lt1"/>
-          </a:fontRef>
-        </p:style>
-        <p:txBody>
-          <a:bodyPr rtlCol="0" anchor="ctr"/>
-          <a:lstStyle/>
-          <a:p>
-            <a:pPr algn="ctr"/>
-          </a:p>
-        </p:txBody>
-      </p:sp>
-      <p:sp>
-        <p:nvSpPr>
-          <p:cNvPr id="64" name="Oval 63"/>
-          <p:cNvSpPr/>
-          <p:nvPr/>
-        </p:nvSpPr>
-        <p:spPr>
-          <a:xfrm>
-            <a:off x="8001000" y="3803904"/>
-            <a:ext cx="493776" cy="493776"/>
-          </a:xfrm>
-          <a:prstGeom prst="ellipse">
-            <a:avLst/>
-          </a:prstGeom>
-          <a:solidFill>
-            <a:srgbClr val="00D48A"/>
-          </a:solidFill>
-          <a:ln>
-            <a:noFill/>
-          </a:ln>
-        </p:spPr>
-        <p:style>
-          <a:lnRef idx="1">
-            <a:schemeClr val="accent1"/>
-          </a:lnRef>
-          <a:fillRef idx="3">
-            <a:schemeClr val="accent1"/>
-          </a:fillRef>
-          <a:effectRef idx="2">
-            <a:schemeClr val="accent1"/>
-          </a:effectRef>
-          <a:fontRef idx="minor">
-            <a:schemeClr val="lt1"/>
-          </a:fontRef>
-        </p:style>
-        <p:txBody>
-          <a:bodyPr rtlCol="0" anchor="ctr"/>
-          <a:lstStyle/>
-          <a:p>
-            <a:pPr algn="ctr"/>
-          </a:p>
-        </p:txBody>
-      </p:sp>
-      <p:sp>
-        <p:nvSpPr>
-          <p:cNvPr id="65" name="TextBox 64"/>
-          <p:cNvSpPr txBox="1"/>
-          <p:nvPr/>
-        </p:nvSpPr>
-        <p:spPr>
-          <a:xfrm>
-            <a:off x="8001000" y="3831336"/>
-            <a:ext cx="493776" cy="201168"/>
-          </a:xfrm>
-          <a:prstGeom prst="rect">
-            <a:avLst/>
-          </a:prstGeom>
-          <a:noFill/>
-        </p:spPr>
-        <p:txBody>
-          <a:bodyPr wrap="square">
-            <a:spAutoFit/>
-          </a:bodyPr>
-          <a:lstStyle/>
-          <a:p>
-            <a:pPr algn="ctr"/>
-            <a:r>
-              <a:rPr sz="1100" b="1" i="0">
-                <a:solidFill>
-                  <a:srgbClr val="FFFFFF"/>
-                </a:solidFill>
-                <a:latin typeface="Segoe UI"/>
-              </a:rPr>
-              <a:t>5</a:t>
-            </a:r>
-          </a:p>
-        </p:txBody>
-      </p:sp>
-      <p:sp>
-        <p:nvSpPr>
-          <p:cNvPr id="66" name="Rounded Rectangle 65"/>
-          <p:cNvSpPr/>
-          <p:nvPr/>
-        </p:nvSpPr>
-        <p:spPr>
-          <a:xfrm>
-            <a:off x="7708392" y="4407408"/>
-            <a:ext cx="1078992" cy="676656"/>
-          </a:xfrm>
-          <a:prstGeom prst="roundRect">
-            <a:avLst/>
-          </a:prstGeom>
-          <a:solidFill>
-            <a:srgbClr val="0B1F3A"/>
-          </a:solidFill>
-          <a:ln>
-            <a:noFill/>
-          </a:ln>
-        </p:spPr>
-        <p:style>
-          <a:lnRef idx="1">
-            <a:schemeClr val="accent1"/>
-          </a:lnRef>
-          <a:fillRef idx="3">
-            <a:schemeClr val="accent1"/>
-          </a:fillRef>
-          <a:effectRef idx="2">
-            <a:schemeClr val="accent1"/>
-          </a:effectRef>
-          <a:fontRef idx="minor">
-            <a:schemeClr val="lt1"/>
-          </a:fontRef>
-        </p:style>
-        <p:txBody>
-          <a:bodyPr rtlCol="0" anchor="ctr"/>
-          <a:lstStyle/>
-          <a:p>
-            <a:pPr algn="ctr"/>
-          </a:p>
-        </p:txBody>
-      </p:sp>
-      <p:sp>
-        <p:nvSpPr>
-          <p:cNvPr id="67" name="TextBox 66"/>
-          <p:cNvSpPr txBox="1"/>
-          <p:nvPr/>
-        </p:nvSpPr>
-        <p:spPr>
-          <a:xfrm>
-            <a:off x="7781544" y="4498848"/>
-            <a:ext cx="932688" cy="347472"/>
-          </a:xfrm>
-          <a:prstGeom prst="rect">
-            <a:avLst/>
-          </a:prstGeom>
-          <a:noFill/>
-        </p:spPr>
-        <p:txBody>
-          <a:bodyPr wrap="square">
-            <a:spAutoFit/>
-          </a:bodyPr>
-          <a:lstStyle/>
-          <a:p>
-            <a:pPr algn="ctr"/>
-            <a:r>
-              <a:rPr sz="880" b="1" i="0">
-                <a:solidFill>
-                  <a:srgbClr val="B8D0EC"/>
-                </a:solidFill>
-                <a:latin typeface="Segoe UI"/>
-              </a:rPr>
-              <a:t>Patch +
-PR</a:t>
-            </a:r>
-          </a:p>
-        </p:txBody>
-      </p:sp>
-      <p:sp>
-        <p:nvSpPr>
-          <p:cNvPr id="68" name="Right Arrow 67"/>
-          <p:cNvSpPr/>
-          <p:nvPr/>
-        </p:nvSpPr>
-        <p:spPr>
-          <a:xfrm>
-            <a:off x="8686800" y="3959352"/>
-            <a:ext cx="960120" cy="182880"/>
-          </a:xfrm>
-          <a:prstGeom prst="rightArrow">
-            <a:avLst/>
-          </a:prstGeom>
-          <a:solidFill>
-            <a:srgbClr val="00C8F0"/>
-          </a:solidFill>
-          <a:ln>
-            <a:noFill/>
-          </a:ln>
-        </p:spPr>
-        <p:style>
-          <a:lnRef idx="1">
-            <a:schemeClr val="accent1"/>
-          </a:lnRef>
-          <a:fillRef idx="3">
-            <a:schemeClr val="accent1"/>
-          </a:fillRef>
-          <a:effectRef idx="2">
-            <a:schemeClr val="accent1"/>
-          </a:effectRef>
-          <a:fontRef idx="minor">
-            <a:schemeClr val="lt1"/>
-          </a:fontRef>
-        </p:style>
-        <p:txBody>
-          <a:bodyPr rtlCol="0" anchor="ctr"/>
-          <a:lstStyle/>
-          <a:p>
-            <a:pPr algn="ctr"/>
-          </a:p>
-        </p:txBody>
-      </p:sp>
-      <p:sp>
-        <p:nvSpPr>
-          <p:cNvPr id="69" name="Oval 68"/>
-          <p:cNvSpPr/>
-          <p:nvPr/>
-        </p:nvSpPr>
-        <p:spPr>
-          <a:xfrm>
-            <a:off x="9875520" y="3803904"/>
-            <a:ext cx="493776" cy="493776"/>
-          </a:xfrm>
-          <a:prstGeom prst="ellipse">
-            <a:avLst/>
-          </a:prstGeom>
-          <a:solidFill>
-            <a:srgbClr val="00C8F0"/>
-          </a:solidFill>
-          <a:ln>
-            <a:noFill/>
-          </a:ln>
-        </p:spPr>
-        <p:style>
-          <a:lnRef idx="1">
-            <a:schemeClr val="accent1"/>
-          </a:lnRef>
-          <a:fillRef idx="3">
-            <a:schemeClr val="accent1"/>
-          </a:fillRef>
-          <a:effectRef idx="2">
-            <a:schemeClr val="accent1"/>
-          </a:effectRef>
-          <a:fontRef idx="minor">
-            <a:schemeClr val="lt1"/>
-          </a:fontRef>
-        </p:style>
-        <p:txBody>
-          <a:bodyPr rtlCol="0" anchor="ctr"/>
-          <a:lstStyle/>
-          <a:p>
-            <a:pPr algn="ctr"/>
-          </a:p>
-        </p:txBody>
-      </p:sp>
-      <p:sp>
-        <p:nvSpPr>
-          <p:cNvPr id="70" name="TextBox 69"/>
-          <p:cNvSpPr txBox="1"/>
-          <p:nvPr/>
-        </p:nvSpPr>
-        <p:spPr>
-          <a:xfrm>
-            <a:off x="9875520" y="3831336"/>
-            <a:ext cx="493776" cy="201168"/>
-          </a:xfrm>
-          <a:prstGeom prst="rect">
-            <a:avLst/>
-          </a:prstGeom>
-          <a:noFill/>
-        </p:spPr>
-        <p:txBody>
-          <a:bodyPr wrap="square">
-            <a:spAutoFit/>
-          </a:bodyPr>
-          <a:lstStyle/>
-          <a:p>
-            <a:pPr algn="ctr"/>
-            <a:r>
-              <a:rPr sz="1100" b="1" i="0">
-                <a:solidFill>
-                  <a:srgbClr val="FFFFFF"/>
-                </a:solidFill>
-                <a:latin typeface="Segoe UI"/>
-              </a:rPr>
-              <a:t>6</a:t>
-            </a:r>
-          </a:p>
-        </p:txBody>
-      </p:sp>
-      <p:sp>
-        <p:nvSpPr>
-          <p:cNvPr id="71" name="Rounded Rectangle 70"/>
-          <p:cNvSpPr/>
-          <p:nvPr/>
-        </p:nvSpPr>
-        <p:spPr>
-          <a:xfrm>
-            <a:off x="9582912" y="4407408"/>
-            <a:ext cx="1078992" cy="676656"/>
-          </a:xfrm>
-          <a:prstGeom prst="roundRect">
-            <a:avLst/>
-          </a:prstGeom>
-          <a:solidFill>
-            <a:srgbClr val="0B1F3A"/>
-          </a:solidFill>
-          <a:ln>
-            <a:noFill/>
-          </a:ln>
-        </p:spPr>
-        <p:style>
-          <a:lnRef idx="1">
-            <a:schemeClr val="accent1"/>
-          </a:lnRef>
-          <a:fillRef idx="3">
-            <a:schemeClr val="accent1"/>
-          </a:fillRef>
-          <a:effectRef idx="2">
-            <a:schemeClr val="accent1"/>
-          </a:effectRef>
-          <a:fontRef idx="minor">
-            <a:schemeClr val="lt1"/>
-          </a:fontRef>
-        </p:style>
-        <p:txBody>
-          <a:bodyPr rtlCol="0" anchor="ctr"/>
-          <a:lstStyle/>
-          <a:p>
-            <a:pPr algn="ctr"/>
-          </a:p>
-        </p:txBody>
-      </p:sp>
-      <p:sp>
-        <p:nvSpPr>
-          <p:cNvPr id="72" name="TextBox 71"/>
-          <p:cNvSpPr txBox="1"/>
-          <p:nvPr/>
-        </p:nvSpPr>
-        <p:spPr>
-          <a:xfrm>
-            <a:off x="9656064" y="4498848"/>
-            <a:ext cx="932688" cy="347472"/>
-          </a:xfrm>
-          <a:prstGeom prst="rect">
-            <a:avLst/>
-          </a:prstGeom>
-          <a:noFill/>
-        </p:spPr>
-        <p:txBody>
-          <a:bodyPr wrap="square">
-            <a:spAutoFit/>
-          </a:bodyPr>
-          <a:lstStyle/>
-          <a:p>
-            <a:pPr algn="ctr"/>
-            <a:r>
-              <a:rPr sz="880" b="1" i="0">
-                <a:solidFill>
-                  <a:srgbClr val="B8D0EC"/>
-                </a:solidFill>
-                <a:latin typeface="Segoe UI"/>
-              </a:rPr>
-              <a:t>Release
-Gate</a:t>
-            </a:r>
-          </a:p>
-        </p:txBody>
-      </p:sp>
-      <p:sp>
-        <p:nvSpPr>
-          <p:cNvPr id="73" name="Rounded Rectangle 72"/>
-          <p:cNvSpPr/>
-          <p:nvPr/>
-        </p:nvSpPr>
-        <p:spPr>
-          <a:xfrm>
-            <a:off x="8458200" y="1508760"/>
-            <a:ext cx="3337560" cy="2011680"/>
-          </a:xfrm>
-          <a:prstGeom prst="roundRect">
-            <a:avLst/>
-          </a:prstGeom>
-          <a:solidFill>
-            <a:srgbClr val="0F2845"/>
-          </a:solidFill>
-          <a:ln>
-            <a:noFill/>
-          </a:ln>
-        </p:spPr>
-        <p:style>
-          <a:lnRef idx="1">
-            <a:schemeClr val="accent1"/>
-          </a:lnRef>
-          <a:fillRef idx="3">
-            <a:schemeClr val="accent1"/>
-          </a:fillRef>
-          <a:effectRef idx="2">
-            <a:schemeClr val="accent1"/>
-          </a:effectRef>
-          <a:fontRef idx="minor">
-            <a:schemeClr val="lt1"/>
-          </a:fontRef>
-        </p:style>
-        <p:txBody>
-          <a:bodyPr rtlCol="0" anchor="ctr"/>
-          <a:lstStyle/>
-          <a:p>
-            <a:pPr algn="ctr"/>
-          </a:p>
-        </p:txBody>
-      </p:sp>
-      <p:sp>
-        <p:nvSpPr>
-          <p:cNvPr id="74" name="Rectangle 73"/>
-          <p:cNvSpPr/>
-          <p:nvPr/>
-        </p:nvSpPr>
-        <p:spPr>
-          <a:xfrm>
-            <a:off x="8458200" y="1508760"/>
-            <a:ext cx="54864" cy="2011680"/>
-          </a:xfrm>
-          <a:prstGeom prst="rect">
-            <a:avLst/>
-          </a:prstGeom>
-          <a:solidFill>
-            <a:srgbClr val="FF8C00"/>
-          </a:solidFill>
-          <a:ln>
-            <a:noFill/>
-          </a:ln>
-        </p:spPr>
-        <p:style>
-          <a:lnRef idx="1">
-            <a:schemeClr val="accent1"/>
-          </a:lnRef>
-          <a:fillRef idx="3">
-            <a:schemeClr val="accent1"/>
-          </a:fillRef>
-          <a:effectRef idx="2">
-            <a:schemeClr val="accent1"/>
-          </a:effectRef>
-          <a:fontRef idx="minor">
-            <a:schemeClr val="lt1"/>
-          </a:fontRef>
-        </p:style>
-        <p:txBody>
-          <a:bodyPr rtlCol="0" anchor="ctr"/>
-          <a:lstStyle/>
-          <a:p>
-            <a:pPr algn="ctr"/>
-          </a:p>
-        </p:txBody>
-      </p:sp>
-      <p:sp>
-        <p:nvSpPr>
-          <p:cNvPr id="75" name="TextBox 74"/>
-          <p:cNvSpPr txBox="1"/>
-          <p:nvPr/>
-        </p:nvSpPr>
-        <p:spPr>
-          <a:xfrm>
-            <a:off x="8641080" y="1645920"/>
-            <a:ext cx="2926080" cy="256032"/>
-          </a:xfrm>
-          <a:prstGeom prst="rect">
-            <a:avLst/>
-          </a:prstGeom>
-          <a:noFill/>
-        </p:spPr>
-        <p:txBody>
-          <a:bodyPr wrap="square">
-            <a:spAutoFit/>
-          </a:bodyPr>
-          <a:lstStyle/>
-          <a:p>
-            <a:pPr algn="l"/>
-            <a:r>
-              <a:rPr sz="1200" b="1" i="0">
-                <a:solidFill>
-                  <a:srgbClr val="FF8C00"/>
-                </a:solidFill>
-                <a:latin typeface="Segoe UI"/>
-              </a:rPr>
-              <a:t>SPECIALIST AGENTS</a:t>
-            </a:r>
-          </a:p>
-        </p:txBody>
-      </p:sp>
-      <p:sp>
-        <p:nvSpPr>
-          <p:cNvPr id="76" name="TextBox 75"/>
-          <p:cNvSpPr txBox="1"/>
-          <p:nvPr/>
-        </p:nvSpPr>
-        <p:spPr>
-          <a:xfrm>
-            <a:off x="8641080" y="1993392"/>
-            <a:ext cx="2926080" cy="1188720"/>
-          </a:xfrm>
-          <a:prstGeom prst="rect">
-            <a:avLst/>
-          </a:prstGeom>
-          <a:noFill/>
-        </p:spPr>
-        <p:txBody>
-          <a:bodyPr wrap="square">
-            <a:spAutoFit/>
-          </a:bodyPr>
-          <a:lstStyle/>
-          <a:p>
-            <a:pPr/>
-            <a:r>
-              <a:rPr sz="850">
-                <a:solidFill>
-                  <a:srgbClr val="B8D0EC"/>
-                </a:solidFill>
-                <a:latin typeface="Segoe UI"/>
-              </a:rPr>
-              <a:t>- Fault Analyzer: HardFault, stack and register RCA</a:t>
-            </a:r>
-          </a:p>
-          <a:p>
-            <a:pPr/>
-            <a:r>
-              <a:rPr sz="850">
-                <a:solidFill>
-                  <a:srgbClr val="B8D0EC"/>
-                </a:solidFill>
-                <a:latin typeface="Segoe UI"/>
-              </a:rPr>
-              <a:t>- Variable Tracer: watchpoints and value history</a:t>
-            </a:r>
-          </a:p>
-          <a:p>
-            <a:pPr/>
-            <a:r>
-              <a:rPr sz="850">
-                <a:solidFill>
-                  <a:srgbClr val="B8D0EC"/>
-                </a:solidFill>
-                <a:latin typeface="Segoe UI"/>
-              </a:rPr>
-              <a:t>- Peripheral Inspector: GPIO, timers, buses, clocks</a:t>
-            </a:r>
-          </a:p>
-          <a:p>
-            <a:pPr/>
-            <a:r>
-              <a:rPr sz="850">
-                <a:solidFill>
-                  <a:srgbClr val="B8D0EC"/>
-                </a:solidFill>
-                <a:latin typeface="Segoe UI"/>
-              </a:rPr>
-              <a:t>- Hex/Memory Parser: dumps, maps and symbol context</a:t>
-            </a:r>
-          </a:p>
-          <a:p>
-            <a:pPr/>
-            <a:r>
-              <a:rPr sz="850">
-                <a:solidFill>
-                  <a:srgbClr val="B8D0EC"/>
-                </a:solidFill>
-                <a:latin typeface="Segoe UI"/>
-              </a:rPr>
-              <a:t>- Probing Agent: J-Link, target MCU and lab evidence</a:t>
-            </a:r>
-          </a:p>
-        </p:txBody>
-      </p:sp>
-      <p:sp>
-        <p:nvSpPr>
-          <p:cNvPr id="77" name="Rounded Rectangle 76"/>
-          <p:cNvSpPr/>
-          <p:nvPr/>
-        </p:nvSpPr>
-        <p:spPr>
-          <a:xfrm>
-            <a:off x="320040" y="5440680"/>
-            <a:ext cx="5715000" cy="960120"/>
-          </a:xfrm>
-          <a:prstGeom prst="roundRect">
-            <a:avLst/>
-          </a:prstGeom>
-          <a:solidFill>
-            <a:srgbClr val="0F2845"/>
-          </a:solidFill>
-          <a:ln>
-            <a:noFill/>
-          </a:ln>
-        </p:spPr>
-        <p:style>
-          <a:lnRef idx="1">
-            <a:schemeClr val="accent1"/>
-          </a:lnRef>
-          <a:fillRef idx="3">
-            <a:schemeClr val="accent1"/>
-          </a:fillRef>
-          <a:effectRef idx="2">
-            <a:schemeClr val="accent1"/>
-          </a:effectRef>
-          <a:fontRef idx="minor">
-            <a:schemeClr val="lt1"/>
-          </a:fontRef>
-        </p:style>
-        <p:txBody>
-          <a:bodyPr rtlCol="0" anchor="ctr"/>
-          <a:lstStyle/>
-          <a:p>
-            <a:pPr algn="ctr"/>
-          </a:p>
-        </p:txBody>
-      </p:sp>
-      <p:sp>
-        <p:nvSpPr>
-          <p:cNvPr id="78" name="Rectangle 77"/>
-          <p:cNvSpPr/>
-          <p:nvPr/>
-        </p:nvSpPr>
-        <p:spPr>
-          <a:xfrm>
-            <a:off x="320040" y="5440680"/>
-            <a:ext cx="54864" cy="960120"/>
-          </a:xfrm>
-          <a:prstGeom prst="rect">
-            <a:avLst/>
-          </a:prstGeom>
-          <a:solidFill>
-            <a:srgbClr val="00C8F0"/>
-          </a:solidFill>
-          <a:ln>
-            <a:noFill/>
-          </a:ln>
-        </p:spPr>
-        <p:style>
-          <a:lnRef idx="1">
-            <a:schemeClr val="accent1"/>
-          </a:lnRef>
-          <a:fillRef idx="3">
-            <a:schemeClr val="accent1"/>
-          </a:fillRef>
-          <a:effectRef idx="2">
-            <a:schemeClr val="accent1"/>
-          </a:effectRef>
-          <a:fontRef idx="minor">
-            <a:schemeClr val="lt1"/>
-          </a:fontRef>
-        </p:style>
-        <p:txBody>
-          <a:bodyPr rtlCol="0" anchor="ctr"/>
-          <a:lstStyle/>
-          <a:p>
-            <a:pPr algn="ctr"/>
-          </a:p>
-        </p:txBody>
-      </p:sp>
-      <p:sp>
-        <p:nvSpPr>
-          <p:cNvPr id="79" name="TextBox 78"/>
-          <p:cNvSpPr txBox="1"/>
-          <p:nvPr/>
-        </p:nvSpPr>
-        <p:spPr>
-          <a:xfrm>
-            <a:off x="502920" y="5532120"/>
-            <a:ext cx="1371600" cy="228600"/>
+            <a:off x="502920" y="2816352"/>
+            <a:ext cx="1737360" cy="228600"/>
           </a:xfrm>
           <a:prstGeom prst="rect">
             <a:avLst/>
@@ -6339,21 +5395,1072 @@
                 </a:solidFill>
                 <a:latin typeface="Segoe UI"/>
               </a:rPr>
-              <a:t>DEMO STORY</a:t>
-            </a:r>
-          </a:p>
-        </p:txBody>
-      </p:sp>
-      <p:sp>
-        <p:nvSpPr>
-          <p:cNvPr id="80" name="TextBox 79"/>
+              <a:t>AEPLO CAPABILITY</a:t>
+            </a:r>
+          </a:p>
+        </p:txBody>
+      </p:sp>
+      <p:sp>
+        <p:nvSpPr>
+          <p:cNvPr id="58" name="TextBox 57"/>
           <p:cNvSpPr txBox="1"/>
           <p:nvPr/>
         </p:nvSpPr>
         <p:spPr>
           <a:xfrm>
-            <a:off x="502920" y="5806440"/>
-            <a:ext cx="5303520" cy="347472"/>
+            <a:off x="2121408" y="2798064"/>
+            <a:ext cx="9464040" cy="256032"/>
+          </a:xfrm>
+          <a:prstGeom prst="rect">
+            <a:avLst/>
+          </a:prstGeom>
+          <a:noFill/>
+        </p:spPr>
+        <p:txBody>
+          <a:bodyPr wrap="square">
+            <a:spAutoFit/>
+          </a:bodyPr>
+          <a:lstStyle/>
+          <a:p>
+            <a:pPr algn="l"/>
+            <a:r>
+              <a:rPr sz="969" b="0" i="0">
+                <a:solidFill>
+                  <a:srgbClr val="B8D0EC"/>
+                </a:solidFill>
+                <a:latin typeface="Segoe UI"/>
+              </a:rPr>
+              <a:t>JTAG Accelerator is part of AEPLO: a multi-agent embedded coding accelerator that links Jira, IDE, Git, J-Link/JTAG, target MCU evidence, AI root-cause analysis, controlled PRs and release gates.</a:t>
+            </a:r>
+          </a:p>
+        </p:txBody>
+      </p:sp>
+      <p:sp>
+        <p:nvSpPr>
+          <p:cNvPr id="59" name="TextBox 58"/>
+          <p:cNvSpPr txBox="1"/>
+          <p:nvPr/>
+        </p:nvSpPr>
+        <p:spPr>
+          <a:xfrm>
+            <a:off x="320040" y="3456432"/>
+            <a:ext cx="2560320" cy="256032"/>
+          </a:xfrm>
+          <a:prstGeom prst="rect">
+            <a:avLst/>
+          </a:prstGeom>
+          <a:noFill/>
+        </p:spPr>
+        <p:txBody>
+          <a:bodyPr wrap="square">
+            <a:spAutoFit/>
+          </a:bodyPr>
+          <a:lstStyle/>
+          <a:p>
+            <a:pPr algn="l"/>
+            <a:r>
+              <a:rPr sz="1250" b="1" i="0">
+                <a:solidFill>
+                  <a:srgbClr val="FFFFFF"/>
+                </a:solidFill>
+                <a:latin typeface="Segoe UI"/>
+              </a:rPr>
+              <a:t>DEMO BY NPI GATES</a:t>
+            </a:r>
+          </a:p>
+        </p:txBody>
+      </p:sp>
+      <p:sp>
+        <p:nvSpPr>
+          <p:cNvPr id="60" name="Rounded Rectangle 59"/>
+          <p:cNvSpPr/>
+          <p:nvPr/>
+        </p:nvSpPr>
+        <p:spPr>
+          <a:xfrm>
+            <a:off x="320040" y="3767328"/>
+            <a:ext cx="3566160" cy="1572768"/>
+          </a:xfrm>
+          <a:prstGeom prst="roundRect">
+            <a:avLst/>
+          </a:prstGeom>
+          <a:solidFill>
+            <a:srgbClr val="0F2845"/>
+          </a:solidFill>
+          <a:ln>
+            <a:noFill/>
+          </a:ln>
+        </p:spPr>
+        <p:style>
+          <a:lnRef idx="1">
+            <a:schemeClr val="accent1"/>
+          </a:lnRef>
+          <a:fillRef idx="3">
+            <a:schemeClr val="accent1"/>
+          </a:fillRef>
+          <a:effectRef idx="2">
+            <a:schemeClr val="accent1"/>
+          </a:effectRef>
+          <a:fontRef idx="minor">
+            <a:schemeClr val="lt1"/>
+          </a:fontRef>
+        </p:style>
+        <p:txBody>
+          <a:bodyPr rtlCol="0" anchor="ctr"/>
+          <a:lstStyle/>
+          <a:p>
+            <a:pPr algn="ctr"/>
+          </a:p>
+        </p:txBody>
+      </p:sp>
+      <p:sp>
+        <p:nvSpPr>
+          <p:cNvPr id="61" name="Rectangle 60"/>
+          <p:cNvSpPr/>
+          <p:nvPr/>
+        </p:nvSpPr>
+        <p:spPr>
+          <a:xfrm>
+            <a:off x="320040" y="3767328"/>
+            <a:ext cx="3566160" cy="54864"/>
+          </a:xfrm>
+          <a:prstGeom prst="rect">
+            <a:avLst/>
+          </a:prstGeom>
+          <a:solidFill>
+            <a:srgbClr val="0072C6"/>
+          </a:solidFill>
+          <a:ln>
+            <a:noFill/>
+          </a:ln>
+        </p:spPr>
+        <p:style>
+          <a:lnRef idx="1">
+            <a:schemeClr val="accent1"/>
+          </a:lnRef>
+          <a:fillRef idx="3">
+            <a:schemeClr val="accent1"/>
+          </a:fillRef>
+          <a:effectRef idx="2">
+            <a:schemeClr val="accent1"/>
+          </a:effectRef>
+          <a:fontRef idx="minor">
+            <a:schemeClr val="lt1"/>
+          </a:fontRef>
+        </p:style>
+        <p:txBody>
+          <a:bodyPr rtlCol="0" anchor="ctr"/>
+          <a:lstStyle/>
+          <a:p>
+            <a:pPr algn="ctr"/>
+          </a:p>
+        </p:txBody>
+      </p:sp>
+      <p:sp>
+        <p:nvSpPr>
+          <p:cNvPr id="62" name="Oval 61"/>
+          <p:cNvSpPr/>
+          <p:nvPr/>
+        </p:nvSpPr>
+        <p:spPr>
+          <a:xfrm>
+            <a:off x="484632" y="3968496"/>
+            <a:ext cx="548640" cy="548640"/>
+          </a:xfrm>
+          <a:prstGeom prst="ellipse">
+            <a:avLst/>
+          </a:prstGeom>
+          <a:solidFill>
+            <a:srgbClr val="0072C6"/>
+          </a:solidFill>
+          <a:ln>
+            <a:noFill/>
+          </a:ln>
+        </p:spPr>
+        <p:style>
+          <a:lnRef idx="1">
+            <a:schemeClr val="accent1"/>
+          </a:lnRef>
+          <a:fillRef idx="3">
+            <a:schemeClr val="accent1"/>
+          </a:fillRef>
+          <a:effectRef idx="2">
+            <a:schemeClr val="accent1"/>
+          </a:effectRef>
+          <a:fontRef idx="minor">
+            <a:schemeClr val="lt1"/>
+          </a:fontRef>
+        </p:style>
+        <p:txBody>
+          <a:bodyPr rtlCol="0" anchor="ctr"/>
+          <a:lstStyle/>
+          <a:p>
+            <a:pPr algn="ctr"/>
+          </a:p>
+        </p:txBody>
+      </p:sp>
+      <p:sp>
+        <p:nvSpPr>
+          <p:cNvPr id="63" name="TextBox 62"/>
+          <p:cNvSpPr txBox="1"/>
+          <p:nvPr/>
+        </p:nvSpPr>
+        <p:spPr>
+          <a:xfrm>
+            <a:off x="484632" y="4105656"/>
+            <a:ext cx="548640" cy="164592"/>
+          </a:xfrm>
+          <a:prstGeom prst="rect">
+            <a:avLst/>
+          </a:prstGeom>
+          <a:noFill/>
+        </p:spPr>
+        <p:txBody>
+          <a:bodyPr wrap="square">
+            <a:spAutoFit/>
+          </a:bodyPr>
+          <a:lstStyle/>
+          <a:p>
+            <a:pPr algn="ctr"/>
+            <a:r>
+              <a:rPr sz="1200" b="1" i="0">
+                <a:solidFill>
+                  <a:srgbClr val="FFFFFF"/>
+                </a:solidFill>
+                <a:latin typeface="Segoe UI"/>
+              </a:rPr>
+              <a:t>PG1</a:t>
+            </a:r>
+          </a:p>
+        </p:txBody>
+      </p:sp>
+      <p:sp>
+        <p:nvSpPr>
+          <p:cNvPr id="64" name="TextBox 63"/>
+          <p:cNvSpPr txBox="1"/>
+          <p:nvPr/>
+        </p:nvSpPr>
+        <p:spPr>
+          <a:xfrm>
+            <a:off x="1161288" y="3941063"/>
+            <a:ext cx="2514600" cy="256032"/>
+          </a:xfrm>
+          <a:prstGeom prst="rect">
+            <a:avLst/>
+          </a:prstGeom>
+          <a:noFill/>
+        </p:spPr>
+        <p:txBody>
+          <a:bodyPr wrap="square">
+            <a:spAutoFit/>
+          </a:bodyPr>
+          <a:lstStyle/>
+          <a:p>
+            <a:pPr algn="l"/>
+            <a:r>
+              <a:rPr sz="1250" b="1" i="0">
+                <a:solidFill>
+                  <a:srgbClr val="0072C6"/>
+                </a:solidFill>
+                <a:latin typeface="Segoe UI"/>
+              </a:rPr>
+              <a:t>DISCOVERY</a:t>
+            </a:r>
+          </a:p>
+        </p:txBody>
+      </p:sp>
+      <p:sp>
+        <p:nvSpPr>
+          <p:cNvPr id="65" name="TextBox 64"/>
+          <p:cNvSpPr txBox="1"/>
+          <p:nvPr/>
+        </p:nvSpPr>
+        <p:spPr>
+          <a:xfrm>
+            <a:off x="521208" y="4407408"/>
+            <a:ext cx="3154680" cy="713232"/>
+          </a:xfrm>
+          <a:prstGeom prst="rect">
+            <a:avLst/>
+          </a:prstGeom>
+          <a:noFill/>
+        </p:spPr>
+        <p:txBody>
+          <a:bodyPr wrap="square">
+            <a:spAutoFit/>
+          </a:bodyPr>
+          <a:lstStyle/>
+          <a:p>
+            <a:pPr/>
+            <a:r>
+              <a:rPr sz="780">
+                <a:solidFill>
+                  <a:srgbClr val="B8D0EC"/>
+                </a:solidFill>
+                <a:latin typeface="Segoe UI"/>
+              </a:rPr>
+              <a:t>- Ingest PRD, Jira themes, defect history and target board context.</a:t>
+            </a:r>
+          </a:p>
+          <a:p>
+            <a:pPr/>
+            <a:r>
+              <a:rPr sz="780">
+                <a:solidFill>
+                  <a:srgbClr val="B8D0EC"/>
+                </a:solidFill>
+                <a:latin typeface="Segoe UI"/>
+              </a:rPr>
+              <a:t>- AI maps PDLC risks, trace gaps and embedded debug hotspots.</a:t>
+            </a:r>
+          </a:p>
+          <a:p>
+            <a:pPr/>
+            <a:r>
+              <a:rPr sz="780">
+                <a:solidFill>
+                  <a:srgbClr val="B8D0EC"/>
+                </a:solidFill>
+                <a:latin typeface="Segoe UI"/>
+              </a:rPr>
+              <a:t>- Demo output: risk-backed scope, board setup and validation plan.</a:t>
+            </a:r>
+          </a:p>
+        </p:txBody>
+      </p:sp>
+      <p:sp>
+        <p:nvSpPr>
+          <p:cNvPr id="66" name="Right Arrow 65"/>
+          <p:cNvSpPr/>
+          <p:nvPr/>
+        </p:nvSpPr>
+        <p:spPr>
+          <a:xfrm>
+            <a:off x="3931920" y="4443984"/>
+            <a:ext cx="530352" cy="182880"/>
+          </a:xfrm>
+          <a:prstGeom prst="rightArrow">
+            <a:avLst/>
+          </a:prstGeom>
+          <a:solidFill>
+            <a:srgbClr val="00C8F0"/>
+          </a:solidFill>
+          <a:ln>
+            <a:noFill/>
+          </a:ln>
+        </p:spPr>
+        <p:style>
+          <a:lnRef idx="1">
+            <a:schemeClr val="accent1"/>
+          </a:lnRef>
+          <a:fillRef idx="3">
+            <a:schemeClr val="accent1"/>
+          </a:fillRef>
+          <a:effectRef idx="2">
+            <a:schemeClr val="accent1"/>
+          </a:effectRef>
+          <a:fontRef idx="minor">
+            <a:schemeClr val="lt1"/>
+          </a:fontRef>
+        </p:style>
+        <p:txBody>
+          <a:bodyPr rtlCol="0" anchor="ctr"/>
+          <a:lstStyle/>
+          <a:p>
+            <a:pPr algn="ctr"/>
+          </a:p>
+        </p:txBody>
+      </p:sp>
+      <p:sp>
+        <p:nvSpPr>
+          <p:cNvPr id="67" name="Rounded Rectangle 66"/>
+          <p:cNvSpPr/>
+          <p:nvPr/>
+        </p:nvSpPr>
+        <p:spPr>
+          <a:xfrm>
+            <a:off x="4224527" y="3767328"/>
+            <a:ext cx="3566160" cy="1572768"/>
+          </a:xfrm>
+          <a:prstGeom prst="roundRect">
+            <a:avLst/>
+          </a:prstGeom>
+          <a:solidFill>
+            <a:srgbClr val="0F2845"/>
+          </a:solidFill>
+          <a:ln>
+            <a:noFill/>
+          </a:ln>
+        </p:spPr>
+        <p:style>
+          <a:lnRef idx="1">
+            <a:schemeClr val="accent1"/>
+          </a:lnRef>
+          <a:fillRef idx="3">
+            <a:schemeClr val="accent1"/>
+          </a:fillRef>
+          <a:effectRef idx="2">
+            <a:schemeClr val="accent1"/>
+          </a:effectRef>
+          <a:fontRef idx="minor">
+            <a:schemeClr val="lt1"/>
+          </a:fontRef>
+        </p:style>
+        <p:txBody>
+          <a:bodyPr rtlCol="0" anchor="ctr"/>
+          <a:lstStyle/>
+          <a:p>
+            <a:pPr algn="ctr"/>
+          </a:p>
+        </p:txBody>
+      </p:sp>
+      <p:sp>
+        <p:nvSpPr>
+          <p:cNvPr id="68" name="Rectangle 67"/>
+          <p:cNvSpPr/>
+          <p:nvPr/>
+        </p:nvSpPr>
+        <p:spPr>
+          <a:xfrm>
+            <a:off x="4224527" y="3767328"/>
+            <a:ext cx="3566160" cy="54864"/>
+          </a:xfrm>
+          <a:prstGeom prst="rect">
+            <a:avLst/>
+          </a:prstGeom>
+          <a:solidFill>
+            <a:srgbClr val="FF8C00"/>
+          </a:solidFill>
+          <a:ln>
+            <a:noFill/>
+          </a:ln>
+        </p:spPr>
+        <p:style>
+          <a:lnRef idx="1">
+            <a:schemeClr val="accent1"/>
+          </a:lnRef>
+          <a:fillRef idx="3">
+            <a:schemeClr val="accent1"/>
+          </a:fillRef>
+          <a:effectRef idx="2">
+            <a:schemeClr val="accent1"/>
+          </a:effectRef>
+          <a:fontRef idx="minor">
+            <a:schemeClr val="lt1"/>
+          </a:fontRef>
+        </p:style>
+        <p:txBody>
+          <a:bodyPr rtlCol="0" anchor="ctr"/>
+          <a:lstStyle/>
+          <a:p>
+            <a:pPr algn="ctr"/>
+          </a:p>
+        </p:txBody>
+      </p:sp>
+      <p:sp>
+        <p:nvSpPr>
+          <p:cNvPr id="69" name="Oval 68"/>
+          <p:cNvSpPr/>
+          <p:nvPr/>
+        </p:nvSpPr>
+        <p:spPr>
+          <a:xfrm>
+            <a:off x="4389119" y="3968496"/>
+            <a:ext cx="548640" cy="548640"/>
+          </a:xfrm>
+          <a:prstGeom prst="ellipse">
+            <a:avLst/>
+          </a:prstGeom>
+          <a:solidFill>
+            <a:srgbClr val="FF8C00"/>
+          </a:solidFill>
+          <a:ln>
+            <a:noFill/>
+          </a:ln>
+        </p:spPr>
+        <p:style>
+          <a:lnRef idx="1">
+            <a:schemeClr val="accent1"/>
+          </a:lnRef>
+          <a:fillRef idx="3">
+            <a:schemeClr val="accent1"/>
+          </a:fillRef>
+          <a:effectRef idx="2">
+            <a:schemeClr val="accent1"/>
+          </a:effectRef>
+          <a:fontRef idx="minor">
+            <a:schemeClr val="lt1"/>
+          </a:fontRef>
+        </p:style>
+        <p:txBody>
+          <a:bodyPr rtlCol="0" anchor="ctr"/>
+          <a:lstStyle/>
+          <a:p>
+            <a:pPr algn="ctr"/>
+          </a:p>
+        </p:txBody>
+      </p:sp>
+      <p:sp>
+        <p:nvSpPr>
+          <p:cNvPr id="70" name="TextBox 69"/>
+          <p:cNvSpPr txBox="1"/>
+          <p:nvPr/>
+        </p:nvSpPr>
+        <p:spPr>
+          <a:xfrm>
+            <a:off x="4389119" y="4105656"/>
+            <a:ext cx="548640" cy="164592"/>
+          </a:xfrm>
+          <a:prstGeom prst="rect">
+            <a:avLst/>
+          </a:prstGeom>
+          <a:noFill/>
+        </p:spPr>
+        <p:txBody>
+          <a:bodyPr wrap="square">
+            <a:spAutoFit/>
+          </a:bodyPr>
+          <a:lstStyle/>
+          <a:p>
+            <a:pPr algn="ctr"/>
+            <a:r>
+              <a:rPr sz="1200" b="1" i="0">
+                <a:solidFill>
+                  <a:srgbClr val="FFFFFF"/>
+                </a:solidFill>
+                <a:latin typeface="Segoe UI"/>
+              </a:rPr>
+              <a:t>PG3</a:t>
+            </a:r>
+          </a:p>
+        </p:txBody>
+      </p:sp>
+      <p:sp>
+        <p:nvSpPr>
+          <p:cNvPr id="71" name="TextBox 70"/>
+          <p:cNvSpPr txBox="1"/>
+          <p:nvPr/>
+        </p:nvSpPr>
+        <p:spPr>
+          <a:xfrm>
+            <a:off x="5065775" y="3941063"/>
+            <a:ext cx="2514600" cy="256032"/>
+          </a:xfrm>
+          <a:prstGeom prst="rect">
+            <a:avLst/>
+          </a:prstGeom>
+          <a:noFill/>
+        </p:spPr>
+        <p:txBody>
+          <a:bodyPr wrap="square">
+            <a:spAutoFit/>
+          </a:bodyPr>
+          <a:lstStyle/>
+          <a:p>
+            <a:pPr algn="l"/>
+            <a:r>
+              <a:rPr sz="1250" b="1" i="0">
+                <a:solidFill>
+                  <a:srgbClr val="FF8C00"/>
+                </a:solidFill>
+                <a:latin typeface="Segoe UI"/>
+              </a:rPr>
+              <a:t>DEVELOPMENT</a:t>
+            </a:r>
+          </a:p>
+        </p:txBody>
+      </p:sp>
+      <p:sp>
+        <p:nvSpPr>
+          <p:cNvPr id="72" name="TextBox 71"/>
+          <p:cNvSpPr txBox="1"/>
+          <p:nvPr/>
+        </p:nvSpPr>
+        <p:spPr>
+          <a:xfrm>
+            <a:off x="4425695" y="4407408"/>
+            <a:ext cx="3154680" cy="713232"/>
+          </a:xfrm>
+          <a:prstGeom prst="rect">
+            <a:avLst/>
+          </a:prstGeom>
+          <a:noFill/>
+        </p:spPr>
+        <p:txBody>
+          <a:bodyPr wrap="square">
+            <a:spAutoFit/>
+          </a:bodyPr>
+          <a:lstStyle/>
+          <a:p>
+            <a:pPr/>
+            <a:r>
+              <a:rPr sz="780">
+                <a:solidFill>
+                  <a:srgbClr val="B8D0EC"/>
+                </a:solidFill>
+                <a:latin typeface="Segoe UI"/>
+              </a:rPr>
+              <a:t>- JTAG Accelerator attaches to IDE, J-Link and target MCU.</a:t>
+            </a:r>
+          </a:p>
+          <a:p>
+            <a:pPr/>
+            <a:r>
+              <a:rPr sz="780">
+                <a:solidFill>
+                  <a:srgbClr val="B8D0EC"/>
+                </a:solidFill>
+                <a:latin typeface="Segoe UI"/>
+              </a:rPr>
+              <a:t>- Fault Analyzer, Variable Tracer and Peripheral Inspector diagnose coding defects.</a:t>
+            </a:r>
+          </a:p>
+          <a:p>
+            <a:pPr/>
+            <a:r>
+              <a:rPr sz="780">
+                <a:solidFill>
+                  <a:srgbClr val="B8D0EC"/>
+                </a:solidFill>
+                <a:latin typeface="Segoe UI"/>
+              </a:rPr>
+              <a:t>- Demo output: RCA, guarded patch, PR and register/memory evidence.</a:t>
+            </a:r>
+          </a:p>
+        </p:txBody>
+      </p:sp>
+      <p:sp>
+        <p:nvSpPr>
+          <p:cNvPr id="73" name="Right Arrow 72"/>
+          <p:cNvSpPr/>
+          <p:nvPr/>
+        </p:nvSpPr>
+        <p:spPr>
+          <a:xfrm>
+            <a:off x="7836407" y="4443984"/>
+            <a:ext cx="530352" cy="182880"/>
+          </a:xfrm>
+          <a:prstGeom prst="rightArrow">
+            <a:avLst/>
+          </a:prstGeom>
+          <a:solidFill>
+            <a:srgbClr val="00C8F0"/>
+          </a:solidFill>
+          <a:ln>
+            <a:noFill/>
+          </a:ln>
+        </p:spPr>
+        <p:style>
+          <a:lnRef idx="1">
+            <a:schemeClr val="accent1"/>
+          </a:lnRef>
+          <a:fillRef idx="3">
+            <a:schemeClr val="accent1"/>
+          </a:fillRef>
+          <a:effectRef idx="2">
+            <a:schemeClr val="accent1"/>
+          </a:effectRef>
+          <a:fontRef idx="minor">
+            <a:schemeClr val="lt1"/>
+          </a:fontRef>
+        </p:style>
+        <p:txBody>
+          <a:bodyPr rtlCol="0" anchor="ctr"/>
+          <a:lstStyle/>
+          <a:p>
+            <a:pPr algn="ctr"/>
+          </a:p>
+        </p:txBody>
+      </p:sp>
+      <p:sp>
+        <p:nvSpPr>
+          <p:cNvPr id="74" name="Rounded Rectangle 73"/>
+          <p:cNvSpPr/>
+          <p:nvPr/>
+        </p:nvSpPr>
+        <p:spPr>
+          <a:xfrm>
+            <a:off x="8129015" y="3767328"/>
+            <a:ext cx="3566160" cy="1572768"/>
+          </a:xfrm>
+          <a:prstGeom prst="roundRect">
+            <a:avLst/>
+          </a:prstGeom>
+          <a:solidFill>
+            <a:srgbClr val="0F2845"/>
+          </a:solidFill>
+          <a:ln>
+            <a:noFill/>
+          </a:ln>
+        </p:spPr>
+        <p:style>
+          <a:lnRef idx="1">
+            <a:schemeClr val="accent1"/>
+          </a:lnRef>
+          <a:fillRef idx="3">
+            <a:schemeClr val="accent1"/>
+          </a:fillRef>
+          <a:effectRef idx="2">
+            <a:schemeClr val="accent1"/>
+          </a:effectRef>
+          <a:fontRef idx="minor">
+            <a:schemeClr val="lt1"/>
+          </a:fontRef>
+        </p:style>
+        <p:txBody>
+          <a:bodyPr rtlCol="0" anchor="ctr"/>
+          <a:lstStyle/>
+          <a:p>
+            <a:pPr algn="ctr"/>
+          </a:p>
+        </p:txBody>
+      </p:sp>
+      <p:sp>
+        <p:nvSpPr>
+          <p:cNvPr id="75" name="Rectangle 74"/>
+          <p:cNvSpPr/>
+          <p:nvPr/>
+        </p:nvSpPr>
+        <p:spPr>
+          <a:xfrm>
+            <a:off x="8129015" y="3767328"/>
+            <a:ext cx="3566160" cy="54864"/>
+          </a:xfrm>
+          <a:prstGeom prst="rect">
+            <a:avLst/>
+          </a:prstGeom>
+          <a:solidFill>
+            <a:srgbClr val="00D48A"/>
+          </a:solidFill>
+          <a:ln>
+            <a:noFill/>
+          </a:ln>
+        </p:spPr>
+        <p:style>
+          <a:lnRef idx="1">
+            <a:schemeClr val="accent1"/>
+          </a:lnRef>
+          <a:fillRef idx="3">
+            <a:schemeClr val="accent1"/>
+          </a:fillRef>
+          <a:effectRef idx="2">
+            <a:schemeClr val="accent1"/>
+          </a:effectRef>
+          <a:fontRef idx="minor">
+            <a:schemeClr val="lt1"/>
+          </a:fontRef>
+        </p:style>
+        <p:txBody>
+          <a:bodyPr rtlCol="0" anchor="ctr"/>
+          <a:lstStyle/>
+          <a:p>
+            <a:pPr algn="ctr"/>
+          </a:p>
+        </p:txBody>
+      </p:sp>
+      <p:sp>
+        <p:nvSpPr>
+          <p:cNvPr id="76" name="Oval 75"/>
+          <p:cNvSpPr/>
+          <p:nvPr/>
+        </p:nvSpPr>
+        <p:spPr>
+          <a:xfrm>
+            <a:off x="8293607" y="3968496"/>
+            <a:ext cx="548640" cy="548640"/>
+          </a:xfrm>
+          <a:prstGeom prst="ellipse">
+            <a:avLst/>
+          </a:prstGeom>
+          <a:solidFill>
+            <a:srgbClr val="00D48A"/>
+          </a:solidFill>
+          <a:ln>
+            <a:noFill/>
+          </a:ln>
+        </p:spPr>
+        <p:style>
+          <a:lnRef idx="1">
+            <a:schemeClr val="accent1"/>
+          </a:lnRef>
+          <a:fillRef idx="3">
+            <a:schemeClr val="accent1"/>
+          </a:fillRef>
+          <a:effectRef idx="2">
+            <a:schemeClr val="accent1"/>
+          </a:effectRef>
+          <a:fontRef idx="minor">
+            <a:schemeClr val="lt1"/>
+          </a:fontRef>
+        </p:style>
+        <p:txBody>
+          <a:bodyPr rtlCol="0" anchor="ctr"/>
+          <a:lstStyle/>
+          <a:p>
+            <a:pPr algn="ctr"/>
+          </a:p>
+        </p:txBody>
+      </p:sp>
+      <p:sp>
+        <p:nvSpPr>
+          <p:cNvPr id="77" name="TextBox 76"/>
+          <p:cNvSpPr txBox="1"/>
+          <p:nvPr/>
+        </p:nvSpPr>
+        <p:spPr>
+          <a:xfrm>
+            <a:off x="8293607" y="4105656"/>
+            <a:ext cx="548640" cy="164592"/>
+          </a:xfrm>
+          <a:prstGeom prst="rect">
+            <a:avLst/>
+          </a:prstGeom>
+          <a:noFill/>
+        </p:spPr>
+        <p:txBody>
+          <a:bodyPr wrap="square">
+            <a:spAutoFit/>
+          </a:bodyPr>
+          <a:lstStyle/>
+          <a:p>
+            <a:pPr algn="ctr"/>
+            <a:r>
+              <a:rPr sz="1200" b="1" i="0">
+                <a:solidFill>
+                  <a:srgbClr val="FFFFFF"/>
+                </a:solidFill>
+                <a:latin typeface="Segoe UI"/>
+              </a:rPr>
+              <a:t>PG5</a:t>
+            </a:r>
+          </a:p>
+        </p:txBody>
+      </p:sp>
+      <p:sp>
+        <p:nvSpPr>
+          <p:cNvPr id="78" name="TextBox 77"/>
+          <p:cNvSpPr txBox="1"/>
+          <p:nvPr/>
+        </p:nvSpPr>
+        <p:spPr>
+          <a:xfrm>
+            <a:off x="8970263" y="3941063"/>
+            <a:ext cx="2514600" cy="256032"/>
+          </a:xfrm>
+          <a:prstGeom prst="rect">
+            <a:avLst/>
+          </a:prstGeom>
+          <a:noFill/>
+        </p:spPr>
+        <p:txBody>
+          <a:bodyPr wrap="square">
+            <a:spAutoFit/>
+          </a:bodyPr>
+          <a:lstStyle/>
+          <a:p>
+            <a:pPr algn="l"/>
+            <a:r>
+              <a:rPr sz="1250" b="1" i="0">
+                <a:solidFill>
+                  <a:srgbClr val="00D48A"/>
+                </a:solidFill>
+                <a:latin typeface="Segoe UI"/>
+              </a:rPr>
+              <a:t>VALIDATION &amp; LAUNCH PREP</a:t>
+            </a:r>
+          </a:p>
+        </p:txBody>
+      </p:sp>
+      <p:sp>
+        <p:nvSpPr>
+          <p:cNvPr id="79" name="TextBox 78"/>
+          <p:cNvSpPr txBox="1"/>
+          <p:nvPr/>
+        </p:nvSpPr>
+        <p:spPr>
+          <a:xfrm>
+            <a:off x="8330183" y="4407408"/>
+            <a:ext cx="3154680" cy="713232"/>
+          </a:xfrm>
+          <a:prstGeom prst="rect">
+            <a:avLst/>
+          </a:prstGeom>
+          <a:noFill/>
+        </p:spPr>
+        <p:txBody>
+          <a:bodyPr wrap="square">
+            <a:spAutoFit/>
+          </a:bodyPr>
+          <a:lstStyle/>
+          <a:p>
+            <a:pPr/>
+            <a:r>
+              <a:rPr sz="780">
+                <a:solidFill>
+                  <a:srgbClr val="B8D0EC"/>
+                </a:solidFill>
+                <a:latin typeface="Segoe UI"/>
+              </a:rPr>
+              <a:t>- AEPLO prioritises tests, checks fix evidence and updates traceability.</a:t>
+            </a:r>
+          </a:p>
+          <a:p>
+            <a:pPr/>
+            <a:r>
+              <a:rPr sz="780">
+                <a:solidFill>
+                  <a:srgbClr val="B8D0EC"/>
+                </a:solidFill>
+                <a:latin typeface="Segoe UI"/>
+              </a:rPr>
+              <a:t>- Release Gate evaluates code, QA, hardware proof and launch readiness.</a:t>
+            </a:r>
+          </a:p>
+          <a:p>
+            <a:pPr/>
+            <a:r>
+              <a:rPr sz="780">
+                <a:solidFill>
+                  <a:srgbClr val="B8D0EC"/>
+                </a:solidFill>
+                <a:latin typeface="Segoe UI"/>
+              </a:rPr>
+              <a:t>- Demo output: READY / NOT_READY verdict with action list.</a:t>
+            </a:r>
+          </a:p>
+        </p:txBody>
+      </p:sp>
+      <p:sp>
+        <p:nvSpPr>
+          <p:cNvPr id="80" name="Rounded Rectangle 79"/>
+          <p:cNvSpPr/>
+          <p:nvPr/>
+        </p:nvSpPr>
+        <p:spPr>
+          <a:xfrm>
+            <a:off x="320040" y="5596128"/>
+            <a:ext cx="5897880" cy="822960"/>
+          </a:xfrm>
+          <a:prstGeom prst="roundRect">
+            <a:avLst/>
+          </a:prstGeom>
+          <a:solidFill>
+            <a:srgbClr val="0B1F3A"/>
+          </a:solidFill>
+          <a:ln>
+            <a:noFill/>
+          </a:ln>
+        </p:spPr>
+        <p:style>
+          <a:lnRef idx="1">
+            <a:schemeClr val="accent1"/>
+          </a:lnRef>
+          <a:fillRef idx="3">
+            <a:schemeClr val="accent1"/>
+          </a:fillRef>
+          <a:effectRef idx="2">
+            <a:schemeClr val="accent1"/>
+          </a:effectRef>
+          <a:fontRef idx="minor">
+            <a:schemeClr val="lt1"/>
+          </a:fontRef>
+        </p:style>
+        <p:txBody>
+          <a:bodyPr rtlCol="0" anchor="ctr"/>
+          <a:lstStyle/>
+          <a:p>
+            <a:pPr algn="ctr"/>
+          </a:p>
+        </p:txBody>
+      </p:sp>
+      <p:sp>
+        <p:nvSpPr>
+          <p:cNvPr id="81" name="Rectangle 80"/>
+          <p:cNvSpPr/>
+          <p:nvPr/>
+        </p:nvSpPr>
+        <p:spPr>
+          <a:xfrm>
+            <a:off x="320040" y="5596128"/>
+            <a:ext cx="54864" cy="822960"/>
+          </a:xfrm>
+          <a:prstGeom prst="rect">
+            <a:avLst/>
+          </a:prstGeom>
+          <a:solidFill>
+            <a:srgbClr val="8B5CF6"/>
+          </a:solidFill>
+          <a:ln>
+            <a:noFill/>
+          </a:ln>
+        </p:spPr>
+        <p:style>
+          <a:lnRef idx="1">
+            <a:schemeClr val="accent1"/>
+          </a:lnRef>
+          <a:fillRef idx="3">
+            <a:schemeClr val="accent1"/>
+          </a:fillRef>
+          <a:effectRef idx="2">
+            <a:schemeClr val="accent1"/>
+          </a:effectRef>
+          <a:fontRef idx="minor">
+            <a:schemeClr val="lt1"/>
+          </a:fontRef>
+        </p:style>
+        <p:txBody>
+          <a:bodyPr rtlCol="0" anchor="ctr"/>
+          <a:lstStyle/>
+          <a:p>
+            <a:pPr algn="ctr"/>
+          </a:p>
+        </p:txBody>
+      </p:sp>
+      <p:sp>
+        <p:nvSpPr>
+          <p:cNvPr id="82" name="TextBox 81"/>
+          <p:cNvSpPr txBox="1"/>
+          <p:nvPr/>
+        </p:nvSpPr>
+        <p:spPr>
+          <a:xfrm>
+            <a:off x="502920" y="5687568"/>
+            <a:ext cx="1600200" cy="219456"/>
+          </a:xfrm>
+          <a:prstGeom prst="rect">
+            <a:avLst/>
+          </a:prstGeom>
+          <a:noFill/>
+        </p:spPr>
+        <p:txBody>
+          <a:bodyPr wrap="square">
+            <a:spAutoFit/>
+          </a:bodyPr>
+          <a:lstStyle/>
+          <a:p>
+            <a:pPr algn="l"/>
+            <a:r>
+              <a:rPr sz="1120" b="1" i="0">
+                <a:solidFill>
+                  <a:srgbClr val="8B5CF6"/>
+                </a:solidFill>
+                <a:latin typeface="Segoe UI"/>
+              </a:rPr>
+              <a:t>POSTER MESSAGE</a:t>
+            </a:r>
+          </a:p>
+        </p:txBody>
+      </p:sp>
+      <p:sp>
+        <p:nvSpPr>
+          <p:cNvPr id="83" name="TextBox 82"/>
+          <p:cNvSpPr txBox="1"/>
+          <p:nvPr/>
+        </p:nvSpPr>
+        <p:spPr>
+          <a:xfrm>
+            <a:off x="502920" y="5943600"/>
+            <a:ext cx="5440680" cy="256032"/>
           </a:xfrm>
           <a:prstGeom prst="rect">
             <a:avLst/>
@@ -6374,21 +6481,21 @@
                 </a:solidFill>
                 <a:latin typeface="Segoe UI"/>
               </a:rPr>
-              <a:t>A Cortex-M HardFault ticket opens in Jira. The copilot attaches through J-Link, captures fault registers and stack frames, explains root cause, generates a guarded patch, opens a PR and feeds evidence into the release gate.</a:t>
-            </a:r>
-          </a:p>
-        </p:txBody>
-      </p:sp>
-      <p:sp>
-        <p:nvSpPr>
-          <p:cNvPr id="81" name="TextBox 80"/>
+              <a:t>AEPLO optimises embedded PDLC decisions at each NPI gate: discover risk early, accelerate coding/debug with JTAG evidence, and validate launch readiness with AI gates.</a:t>
+            </a:r>
+          </a:p>
+        </p:txBody>
+      </p:sp>
+      <p:sp>
+        <p:nvSpPr>
+          <p:cNvPr id="84" name="TextBox 83"/>
           <p:cNvSpPr txBox="1"/>
           <p:nvPr/>
         </p:nvSpPr>
         <p:spPr>
           <a:xfrm>
-            <a:off x="6355080" y="5394960"/>
-            <a:ext cx="2011680" cy="228600"/>
+            <a:off x="6510528" y="5541264"/>
+            <a:ext cx="1828800" cy="219456"/>
           </a:xfrm>
           <a:prstGeom prst="rect">
             <a:avLst/>
@@ -6403,27 +6510,27 @@
           <a:p>
             <a:pPr algn="l"/>
             <a:r>
-              <a:rPr sz="1150" b="1" i="0">
+              <a:rPr sz="1120" b="1" i="0">
                 <a:solidFill>
                   <a:srgbClr val="00D48A"/>
                 </a:solidFill>
                 <a:latin typeface="Segoe UI"/>
               </a:rPr>
-              <a:t>EXPECTED OUTCOMES</a:t>
-            </a:r>
-          </a:p>
-        </p:txBody>
-      </p:sp>
-      <p:sp>
-        <p:nvSpPr>
-          <p:cNvPr id="82" name="Rounded Rectangle 81"/>
+              <a:t>SUCCESS SIGNALS</a:t>
+            </a:r>
+          </a:p>
+        </p:txBody>
+      </p:sp>
+      <p:sp>
+        <p:nvSpPr>
+          <p:cNvPr id="85" name="Rounded Rectangle 84"/>
           <p:cNvSpPr/>
           <p:nvPr/>
         </p:nvSpPr>
         <p:spPr>
           <a:xfrm>
-            <a:off x="6355080" y="5687568"/>
-            <a:ext cx="1298448" cy="749808"/>
+            <a:off x="6510528" y="5815584"/>
+            <a:ext cx="1261872" cy="749808"/>
           </a:xfrm>
           <a:prstGeom prst="roundRect">
             <a:avLst/>
@@ -6459,20 +6566,20 @@
       </p:sp>
       <p:sp>
         <p:nvSpPr>
-          <p:cNvPr id="83" name="Rectangle 82"/>
+          <p:cNvPr id="86" name="Rectangle 85"/>
           <p:cNvSpPr/>
           <p:nvPr/>
         </p:nvSpPr>
         <p:spPr>
           <a:xfrm>
-            <a:off x="6355080" y="5687568"/>
+            <a:off x="6510528" y="5815584"/>
             <a:ext cx="54864" cy="749808"/>
           </a:xfrm>
           <a:prstGeom prst="rect">
             <a:avLst/>
           </a:prstGeom>
           <a:solidFill>
-            <a:srgbClr val="00D48A"/>
+            <a:srgbClr val="0072C6"/>
           </a:solidFill>
           <a:ln>
             <a:noFill/>
@@ -6502,14 +6609,14 @@
       </p:sp>
       <p:sp>
         <p:nvSpPr>
-          <p:cNvPr id="84" name="TextBox 83"/>
+          <p:cNvPr id="87" name="TextBox 86"/>
           <p:cNvSpPr txBox="1"/>
           <p:nvPr/>
         </p:nvSpPr>
         <p:spPr>
           <a:xfrm>
-            <a:off x="6483096" y="5760720"/>
-            <a:ext cx="1042416" cy="256032"/>
+            <a:off x="6638544" y="5888736"/>
+            <a:ext cx="1005840" cy="256032"/>
           </a:xfrm>
           <a:prstGeom prst="rect">
             <a:avLst/>
@@ -6526,25 +6633,25 @@
             <a:r>
               <a:rPr sz="1900" b="1" i="0">
                 <a:solidFill>
-                  <a:srgbClr val="00D48A"/>
+                  <a:srgbClr val="0072C6"/>
                 </a:solidFill>
                 <a:latin typeface="Segoe UI"/>
               </a:rPr>
-              <a:t>&lt;30m</a:t>
-            </a:r>
-          </a:p>
-        </p:txBody>
-      </p:sp>
-      <p:sp>
-        <p:nvSpPr>
-          <p:cNvPr id="85" name="TextBox 84"/>
+              <a:t>PG1</a:t>
+            </a:r>
+          </a:p>
+        </p:txBody>
+      </p:sp>
+      <p:sp>
+        <p:nvSpPr>
+          <p:cNvPr id="88" name="TextBox 87"/>
           <p:cNvSpPr txBox="1"/>
           <p:nvPr/>
         </p:nvSpPr>
         <p:spPr>
           <a:xfrm>
-            <a:off x="6483096" y="6071616"/>
-            <a:ext cx="1042416" cy="256032"/>
+            <a:off x="6638544" y="6199632"/>
+            <a:ext cx="1005840" cy="256032"/>
           </a:xfrm>
           <a:prstGeom prst="rect">
             <a:avLst/>
@@ -6565,21 +6672,21 @@
                 </a:solidFill>
                 <a:latin typeface="Segoe UI"/>
               </a:rPr>
-              <a:t>ticket to RCA</a:t>
-            </a:r>
-          </a:p>
-        </p:txBody>
-      </p:sp>
-      <p:sp>
-        <p:nvSpPr>
-          <p:cNvPr id="86" name="Rounded Rectangle 85"/>
+              <a:t>risk clarity</a:t>
+            </a:r>
+          </a:p>
+        </p:txBody>
+      </p:sp>
+      <p:sp>
+        <p:nvSpPr>
+          <p:cNvPr id="89" name="Rounded Rectangle 88"/>
           <p:cNvSpPr/>
           <p:nvPr/>
         </p:nvSpPr>
         <p:spPr>
           <a:xfrm>
-            <a:off x="7818120" y="5687568"/>
-            <a:ext cx="1298448" cy="749808"/>
+            <a:off x="7918704" y="5815584"/>
+            <a:ext cx="1261872" cy="749808"/>
           </a:xfrm>
           <a:prstGeom prst="roundRect">
             <a:avLst/>
@@ -6615,20 +6722,20 @@
       </p:sp>
       <p:sp>
         <p:nvSpPr>
-          <p:cNvPr id="87" name="Rectangle 86"/>
+          <p:cNvPr id="90" name="Rectangle 89"/>
           <p:cNvSpPr/>
           <p:nvPr/>
         </p:nvSpPr>
         <p:spPr>
           <a:xfrm>
-            <a:off x="7818120" y="5687568"/>
+            <a:off x="7918704" y="5815584"/>
             <a:ext cx="54864" cy="749808"/>
           </a:xfrm>
           <a:prstGeom prst="rect">
             <a:avLst/>
           </a:prstGeom>
           <a:solidFill>
-            <a:srgbClr val="0072C6"/>
+            <a:srgbClr val="FF8C00"/>
           </a:solidFill>
           <a:ln>
             <a:noFill/>
@@ -6658,14 +6765,14 @@
       </p:sp>
       <p:sp>
         <p:nvSpPr>
-          <p:cNvPr id="88" name="TextBox 87"/>
+          <p:cNvPr id="91" name="TextBox 90"/>
           <p:cNvSpPr txBox="1"/>
           <p:nvPr/>
         </p:nvSpPr>
         <p:spPr>
           <a:xfrm>
-            <a:off x="7946136" y="5760720"/>
-            <a:ext cx="1042416" cy="256032"/>
+            <a:off x="8046720" y="5888736"/>
+            <a:ext cx="1005840" cy="256032"/>
           </a:xfrm>
           <a:prstGeom prst="rect">
             <a:avLst/>
@@ -6682,25 +6789,25 @@
             <a:r>
               <a:rPr sz="1900" b="1" i="0">
                 <a:solidFill>
-                  <a:srgbClr val="0072C6"/>
+                  <a:srgbClr val="FF8C00"/>
                 </a:solidFill>
                 <a:latin typeface="Segoe UI"/>
               </a:rPr>
-              <a:t>1 PR</a:t>
-            </a:r>
-          </a:p>
-        </p:txBody>
-      </p:sp>
-      <p:sp>
-        <p:nvSpPr>
-          <p:cNvPr id="89" name="TextBox 88"/>
+              <a:t>&lt;30m</a:t>
+            </a:r>
+          </a:p>
+        </p:txBody>
+      </p:sp>
+      <p:sp>
+        <p:nvSpPr>
+          <p:cNvPr id="92" name="TextBox 91"/>
           <p:cNvSpPr txBox="1"/>
           <p:nvPr/>
         </p:nvSpPr>
         <p:spPr>
           <a:xfrm>
-            <a:off x="7946136" y="6071616"/>
-            <a:ext cx="1042416" cy="256032"/>
+            <a:off x="8046720" y="6199632"/>
+            <a:ext cx="1005840" cy="256032"/>
           </a:xfrm>
           <a:prstGeom prst="rect">
             <a:avLst/>
@@ -6721,21 +6828,21 @@
                 </a:solidFill>
                 <a:latin typeface="Segoe UI"/>
               </a:rPr>
-              <a:t>controlled fix</a:t>
-            </a:r>
-          </a:p>
-        </p:txBody>
-      </p:sp>
-      <p:sp>
-        <p:nvSpPr>
-          <p:cNvPr id="90" name="Rounded Rectangle 89"/>
+              <a:t>RCA target</a:t>
+            </a:r>
+          </a:p>
+        </p:txBody>
+      </p:sp>
+      <p:sp>
+        <p:nvSpPr>
+          <p:cNvPr id="93" name="Rounded Rectangle 92"/>
           <p:cNvSpPr/>
           <p:nvPr/>
         </p:nvSpPr>
         <p:spPr>
           <a:xfrm>
-            <a:off x="9281160" y="5687568"/>
-            <a:ext cx="1298448" cy="749808"/>
+            <a:off x="9326880" y="5815584"/>
+            <a:ext cx="1261872" cy="749808"/>
           </a:xfrm>
           <a:prstGeom prst="roundRect">
             <a:avLst/>
@@ -6771,20 +6878,20 @@
       </p:sp>
       <p:sp>
         <p:nvSpPr>
-          <p:cNvPr id="91" name="Rectangle 90"/>
+          <p:cNvPr id="94" name="Rectangle 93"/>
           <p:cNvSpPr/>
           <p:nvPr/>
         </p:nvSpPr>
         <p:spPr>
           <a:xfrm>
-            <a:off x="9281160" y="5687568"/>
+            <a:off x="9326880" y="5815584"/>
             <a:ext cx="54864" cy="749808"/>
           </a:xfrm>
           <a:prstGeom prst="rect">
             <a:avLst/>
           </a:prstGeom>
           <a:solidFill>
-            <a:srgbClr val="FF8C00"/>
+            <a:srgbClr val="8B5CF6"/>
           </a:solidFill>
           <a:ln>
             <a:noFill/>
@@ -6814,14 +6921,14 @@
       </p:sp>
       <p:sp>
         <p:nvSpPr>
-          <p:cNvPr id="92" name="TextBox 91"/>
+          <p:cNvPr id="95" name="TextBox 94"/>
           <p:cNvSpPr txBox="1"/>
           <p:nvPr/>
         </p:nvSpPr>
         <p:spPr>
           <a:xfrm>
-            <a:off x="9409176" y="5760720"/>
-            <a:ext cx="1042416" cy="256032"/>
+            <a:off x="9454896" y="5888736"/>
+            <a:ext cx="1005840" cy="256032"/>
           </a:xfrm>
           <a:prstGeom prst="rect">
             <a:avLst/>
@@ -6838,7 +6945,7 @@
             <a:r>
               <a:rPr sz="1900" b="1" i="0">
                 <a:solidFill>
-                  <a:srgbClr val="FF8C00"/>
+                  <a:srgbClr val="8B5CF6"/>
                 </a:solidFill>
                 <a:latin typeface="Segoe UI"/>
               </a:rPr>
@@ -6849,14 +6956,14 @@
       </p:sp>
       <p:sp>
         <p:nvSpPr>
-          <p:cNvPr id="93" name="TextBox 92"/>
+          <p:cNvPr id="96" name="TextBox 95"/>
           <p:cNvSpPr txBox="1"/>
           <p:nvPr/>
         </p:nvSpPr>
         <p:spPr>
           <a:xfrm>
-            <a:off x="9409176" y="6071616"/>
-            <a:ext cx="1042416" cy="256032"/>
+            <a:off x="9454896" y="6199632"/>
+            <a:ext cx="1005840" cy="256032"/>
           </a:xfrm>
           <a:prstGeom prst="rect">
             <a:avLst/>
@@ -6884,14 +6991,14 @@
       </p:sp>
       <p:sp>
         <p:nvSpPr>
-          <p:cNvPr id="94" name="Rounded Rectangle 93"/>
+          <p:cNvPr id="97" name="Rounded Rectangle 96"/>
           <p:cNvSpPr/>
           <p:nvPr/>
         </p:nvSpPr>
         <p:spPr>
           <a:xfrm>
-            <a:off x="10744200" y="5687568"/>
-            <a:ext cx="1051560" cy="749808"/>
+            <a:off x="10735056" y="5815584"/>
+            <a:ext cx="1097280" cy="749808"/>
           </a:xfrm>
           <a:prstGeom prst="roundRect">
             <a:avLst/>
@@ -6927,20 +7034,20 @@
       </p:sp>
       <p:sp>
         <p:nvSpPr>
-          <p:cNvPr id="95" name="Rectangle 94"/>
+          <p:cNvPr id="98" name="Rectangle 97"/>
           <p:cNvSpPr/>
           <p:nvPr/>
         </p:nvSpPr>
         <p:spPr>
           <a:xfrm>
-            <a:off x="10744200" y="5687568"/>
+            <a:off x="10735056" y="5815584"/>
             <a:ext cx="54864" cy="749808"/>
           </a:xfrm>
           <a:prstGeom prst="rect">
             <a:avLst/>
           </a:prstGeom>
           <a:solidFill>
-            <a:srgbClr val="00C8F0"/>
+            <a:srgbClr val="00D48A"/>
           </a:solidFill>
           <a:ln>
             <a:noFill/>
@@ -6970,14 +7077,14 @@
       </p:sp>
       <p:sp>
         <p:nvSpPr>
-          <p:cNvPr id="96" name="TextBox 95"/>
+          <p:cNvPr id="99" name="TextBox 98"/>
           <p:cNvSpPr txBox="1"/>
           <p:nvPr/>
         </p:nvSpPr>
         <p:spPr>
           <a:xfrm>
-            <a:off x="10872216" y="5760720"/>
-            <a:ext cx="795528" cy="256032"/>
+            <a:off x="10863072" y="5888736"/>
+            <a:ext cx="841248" cy="256032"/>
           </a:xfrm>
           <a:prstGeom prst="rect">
             <a:avLst/>
@@ -6994,25 +7101,25 @@
             <a:r>
               <a:rPr sz="1900" b="1" i="0">
                 <a:solidFill>
-                  <a:srgbClr val="00C8F0"/>
+                  <a:srgbClr val="00D48A"/>
                 </a:solidFill>
                 <a:latin typeface="Segoe UI"/>
               </a:rPr>
-              <a:t>Ready</a:t>
-            </a:r>
-          </a:p>
-        </p:txBody>
-      </p:sp>
-      <p:sp>
-        <p:nvSpPr>
-          <p:cNvPr id="97" name="TextBox 96"/>
+              <a:t>PG5</a:t>
+            </a:r>
+          </a:p>
+        </p:txBody>
+      </p:sp>
+      <p:sp>
+        <p:nvSpPr>
+          <p:cNvPr id="100" name="TextBox 99"/>
           <p:cNvSpPr txBox="1"/>
           <p:nvPr/>
         </p:nvSpPr>
         <p:spPr>
           <a:xfrm>
-            <a:off x="10872216" y="6071616"/>
-            <a:ext cx="795528" cy="256032"/>
+            <a:off x="10863072" y="6199632"/>
+            <a:ext cx="841248" cy="256032"/>
           </a:xfrm>
           <a:prstGeom prst="rect">
             <a:avLst/>
@@ -7033,14 +7140,14 @@
                 </a:solidFill>
                 <a:latin typeface="Segoe UI"/>
               </a:rPr>
-              <a:t>gate input</a:t>
-            </a:r>
-          </a:p>
-        </p:txBody>
-      </p:sp>
-      <p:sp>
-        <p:nvSpPr>
-          <p:cNvPr id="98" name="TextBox 97"/>
+              <a:t>launch gate</a:t>
+            </a:r>
+          </a:p>
+        </p:txBody>
+      </p:sp>
+      <p:sp>
+        <p:nvSpPr>
+          <p:cNvPr id="101" name="TextBox 100"/>
           <p:cNvSpPr txBox="1"/>
           <p:nvPr/>
         </p:nvSpPr>
@@ -7068,14 +7175,14 @@
                 </a:solidFill>
                 <a:latin typeface="Segoe UI"/>
               </a:rPr>
-              <a:t>Team addition: Sheraaz | Common scheme: AEPLO V3 lifecycle orchestration</a:t>
-            </a:r>
-          </a:p>
-        </p:txBody>
-      </p:sp>
-      <p:sp>
-        <p:nvSpPr>
-          <p:cNvPr id="99" name="TextBox 98"/>
+              <a:t>Common Idea | AEPLO + JTAG Accelerator | Embedded PDLC AI Optimisation</a:t>
+            </a:r>
+          </a:p>
+        </p:txBody>
+      </p:sp>
+      <p:sp>
+        <p:nvSpPr>
+          <p:cNvPr id="102" name="TextBox 101"/>
           <p:cNvSpPr txBox="1"/>
           <p:nvPr/>
         </p:nvSpPr>
@@ -7103,7 +7210,7 @@
                 </a:solidFill>
                 <a:latin typeface="Segoe UI"/>
               </a:rPr>
-              <a:t>One-page candidate for Coding Embedded Workstream</a:t>
+              <a:t>One-page poster candidate for Coding Embedded Workstream</a:t>
             </a:r>
           </a:p>
         </p:txBody>

</xml_diff>

<commit_message>
Apply Honeywell theme to V5 deck and poster
Co-authored-by: Shyam <shyam.nexus@gmail.com>
</commit_message>
<xml_diff>
--- a/Coding Embedded Workstream - Common Idea Poster.pptx
+++ b/Coding Embedded Workstream - Common Idea Poster.pptx
@@ -3604,7 +3604,7 @@
             <a:avLst/>
           </a:prstGeom>
           <a:solidFill>
-            <a:srgbClr val="020A1A"/>
+            <a:srgbClr val="111111"/>
           </a:solidFill>
           <a:ln>
             <a:noFill/>
@@ -3677,7 +3677,7 @@
             <a:avLst/>
           </a:prstGeom>
           <a:solidFill>
-            <a:srgbClr val="00C8F0"/>
+            <a:srgbClr val="D71920"/>
           </a:solidFill>
           <a:ln>
             <a:noFill/>
@@ -3750,7 +3750,7 @@
             <a:avLst/>
           </a:prstGeom>
           <a:solidFill>
-            <a:srgbClr val="00D48A"/>
+            <a:srgbClr val="2E7D32"/>
           </a:solidFill>
           <a:ln>
             <a:noFill/>
@@ -3823,7 +3823,7 @@
             <a:avLst/>
           </a:prstGeom>
           <a:solidFill>
-            <a:srgbClr val="0072C6"/>
+            <a:srgbClr val="D71920"/>
           </a:solidFill>
           <a:ln>
             <a:noFill/>
@@ -3896,7 +3896,7 @@
             <a:avLst/>
           </a:prstGeom>
           <a:solidFill>
-            <a:srgbClr val="113A66"/>
+            <a:srgbClr val="3D3D3D"/>
           </a:solidFill>
           <a:ln>
             <a:noFill/>
@@ -3969,7 +3969,7 @@
             <a:avLst/>
           </a:prstGeom>
           <a:solidFill>
-            <a:srgbClr val="061C38"/>
+            <a:srgbClr val="1F1F1F"/>
           </a:solidFill>
           <a:ln>
             <a:noFill/>
@@ -4042,7 +4042,7 @@
             <a:avLst/>
           </a:prstGeom>
           <a:solidFill>
-            <a:srgbClr val="061C38"/>
+            <a:srgbClr val="1F1F1F"/>
           </a:solidFill>
           <a:ln>
             <a:noFill/>
@@ -4115,7 +4115,7 @@
             <a:avLst/>
           </a:prstGeom>
           <a:solidFill>
-            <a:srgbClr val="061C38"/>
+            <a:srgbClr val="1F1F1F"/>
           </a:solidFill>
           <a:ln>
             <a:noFill/>
@@ -4188,7 +4188,7 @@
             <a:avLst/>
           </a:prstGeom>
           <a:solidFill>
-            <a:srgbClr val="061C38"/>
+            <a:srgbClr val="1F1F1F"/>
           </a:solidFill>
           <a:ln>
             <a:noFill/>
@@ -4261,7 +4261,7 @@
             <a:avLst/>
           </a:prstGeom>
           <a:solidFill>
-            <a:srgbClr val="061C38"/>
+            <a:srgbClr val="1F1F1F"/>
           </a:solidFill>
           <a:ln>
             <a:noFill/>
@@ -4334,7 +4334,7 @@
             <a:avLst/>
           </a:prstGeom>
           <a:solidFill>
-            <a:srgbClr val="061C38"/>
+            <a:srgbClr val="1F1F1F"/>
           </a:solidFill>
           <a:ln>
             <a:noFill/>
@@ -4407,7 +4407,7 @@
             <a:avLst/>
           </a:prstGeom>
           <a:solidFill>
-            <a:srgbClr val="061C38"/>
+            <a:srgbClr val="1F1F1F"/>
           </a:solidFill>
           <a:ln>
             <a:noFill/>
@@ -4480,7 +4480,7 @@
             <a:avLst/>
           </a:prstGeom>
           <a:solidFill>
-            <a:srgbClr val="061C38"/>
+            <a:srgbClr val="1F1F1F"/>
           </a:solidFill>
           <a:ln>
             <a:noFill/>
@@ -4553,7 +4553,7 @@
             <a:avLst/>
           </a:prstGeom>
           <a:solidFill>
-            <a:srgbClr val="061C38"/>
+            <a:srgbClr val="1F1F1F"/>
           </a:solidFill>
           <a:ln>
             <a:noFill/>
@@ -4626,7 +4626,7 @@
             <a:avLst/>
           </a:prstGeom>
           <a:solidFill>
-            <a:srgbClr val="061C38"/>
+            <a:srgbClr val="1F1F1F"/>
           </a:solidFill>
           <a:ln>
             <a:noFill/>
@@ -4699,7 +4699,7 @@
             <a:avLst/>
           </a:prstGeom>
           <a:solidFill>
-            <a:srgbClr val="061C38"/>
+            <a:srgbClr val="1F1F1F"/>
           </a:solidFill>
           <a:ln>
             <a:noFill/>
@@ -4772,7 +4772,7 @@
             <a:avLst/>
           </a:prstGeom>
           <a:solidFill>
-            <a:srgbClr val="061C38"/>
+            <a:srgbClr val="1F1F1F"/>
           </a:solidFill>
           <a:ln>
             <a:noFill/>
@@ -4845,7 +4845,7 @@
             <a:avLst/>
           </a:prstGeom>
           <a:solidFill>
-            <a:srgbClr val="061C38"/>
+            <a:srgbClr val="1F1F1F"/>
           </a:solidFill>
           <a:ln>
             <a:noFill/>
@@ -4918,7 +4918,7 @@
             <a:avLst/>
           </a:prstGeom>
           <a:solidFill>
-            <a:srgbClr val="061C38"/>
+            <a:srgbClr val="1F1F1F"/>
           </a:solidFill>
           <a:ln>
             <a:noFill/>
@@ -4991,7 +4991,7 @@
             <a:avLst/>
           </a:prstGeom>
           <a:solidFill>
-            <a:srgbClr val="061C38"/>
+            <a:srgbClr val="1F1F1F"/>
           </a:solidFill>
           <a:ln>
             <a:noFill/>
@@ -5064,7 +5064,7 @@
             <a:avLst/>
           </a:prstGeom>
           <a:solidFill>
-            <a:srgbClr val="061C38"/>
+            <a:srgbClr val="1F1F1F"/>
           </a:solidFill>
           <a:ln>
             <a:noFill/>
@@ -5137,7 +5137,7 @@
             <a:avLst/>
           </a:prstGeom>
           <a:solidFill>
-            <a:srgbClr val="061C38"/>
+            <a:srgbClr val="1F1F1F"/>
           </a:solidFill>
           <a:ln>
             <a:noFill/>
@@ -5210,7 +5210,7 @@
             <a:avLst/>
           </a:prstGeom>
           <a:solidFill>
-            <a:srgbClr val="061C38"/>
+            <a:srgbClr val="1F1F1F"/>
           </a:solidFill>
           <a:ln>
             <a:noFill/>
@@ -5283,7 +5283,7 @@
             <a:avLst/>
           </a:prstGeom>
           <a:solidFill>
-            <a:srgbClr val="061C38"/>
+            <a:srgbClr val="1F1F1F"/>
           </a:solidFill>
           <a:ln>
             <a:noFill/>
@@ -5356,7 +5356,7 @@
             <a:avLst/>
           </a:prstGeom>
           <a:solidFill>
-            <a:srgbClr val="061C38"/>
+            <a:srgbClr val="1F1F1F"/>
           </a:solidFill>
           <a:ln>
             <a:noFill/>
@@ -5429,7 +5429,7 @@
             <a:avLst/>
           </a:prstGeom>
           <a:solidFill>
-            <a:srgbClr val="061C38"/>
+            <a:srgbClr val="1F1F1F"/>
           </a:solidFill>
           <a:ln>
             <a:noFill/>
@@ -5502,7 +5502,7 @@
             <a:avLst/>
           </a:prstGeom>
           <a:solidFill>
-            <a:srgbClr val="061C38"/>
+            <a:srgbClr val="1F1F1F"/>
           </a:solidFill>
           <a:ln>
             <a:noFill/>
@@ -5575,7 +5575,7 @@
             <a:avLst/>
           </a:prstGeom>
           <a:solidFill>
-            <a:srgbClr val="061C38"/>
+            <a:srgbClr val="1F1F1F"/>
           </a:solidFill>
           <a:ln>
             <a:noFill/>
@@ -5648,7 +5648,7 @@
             <a:avLst/>
           </a:prstGeom>
           <a:solidFill>
-            <a:srgbClr val="061C38"/>
+            <a:srgbClr val="1F1F1F"/>
           </a:solidFill>
           <a:ln>
             <a:noFill/>
@@ -5721,7 +5721,7 @@
             <a:avLst/>
           </a:prstGeom>
           <a:solidFill>
-            <a:srgbClr val="061C38"/>
+            <a:srgbClr val="1F1F1F"/>
           </a:solidFill>
           <a:ln>
             <a:noFill/>
@@ -5794,7 +5794,7 @@
             <a:avLst/>
           </a:prstGeom>
           <a:solidFill>
-            <a:srgbClr val="061C38"/>
+            <a:srgbClr val="1F1F1F"/>
           </a:solidFill>
           <a:ln>
             <a:noFill/>
@@ -5867,7 +5867,7 @@
             <a:avLst/>
           </a:prstGeom>
           <a:solidFill>
-            <a:srgbClr val="061C38"/>
+            <a:srgbClr val="1F1F1F"/>
           </a:solidFill>
           <a:ln>
             <a:noFill/>
@@ -5940,7 +5940,7 @@
             <a:avLst/>
           </a:prstGeom>
           <a:solidFill>
-            <a:srgbClr val="061C38"/>
+            <a:srgbClr val="1F1F1F"/>
           </a:solidFill>
           <a:ln>
             <a:noFill/>
@@ -6013,7 +6013,7 @@
             <a:avLst/>
           </a:prstGeom>
           <a:solidFill>
-            <a:srgbClr val="061C38"/>
+            <a:srgbClr val="1F1F1F"/>
           </a:solidFill>
           <a:ln>
             <a:noFill/>
@@ -6086,7 +6086,7 @@
             <a:avLst/>
           </a:prstGeom>
           <a:solidFill>
-            <a:srgbClr val="061C38"/>
+            <a:srgbClr val="1F1F1F"/>
           </a:solidFill>
           <a:ln>
             <a:noFill/>
@@ -6159,7 +6159,7 @@
             <a:avLst/>
           </a:prstGeom>
           <a:solidFill>
-            <a:srgbClr val="061C38"/>
+            <a:srgbClr val="1F1F1F"/>
           </a:solidFill>
           <a:ln>
             <a:noFill/>
@@ -6232,7 +6232,7 @@
             <a:avLst/>
           </a:prstGeom>
           <a:solidFill>
-            <a:srgbClr val="00C8F0"/>
+            <a:srgbClr val="D71920"/>
           </a:solidFill>
           <a:ln>
             <a:noFill/>
@@ -6378,6 +6378,7 @@
             <a:avLst/>
           </a:prstGeom>
           <a:noFill/>
+          <a:ln/>
         </p:spPr>
         <p:txBody>
           <a:bodyPr wrap="square">
@@ -6413,7 +6414,7 @@
                 <a:effectLst/>
                 <a:uLnTx/>
                 <a:uFillTx/>
-                <a:latin typeface="Segoe UI"/>
+                <a:latin typeface="Arial"/>
                 <a:ea typeface="+mn-ea"/>
                 <a:cs typeface="+mn-cs"/>
               </a:rPr>
@@ -6451,6 +6452,7 @@
             <a:avLst/>
           </a:prstGeom>
           <a:noFill/>
+          <a:ln/>
         </p:spPr>
         <p:txBody>
           <a:bodyPr wrap="square">
@@ -6481,12 +6483,12 @@
                   <a:noFill/>
                 </a:ln>
                 <a:solidFill>
-                  <a:srgbClr val="00C8F0"/>
+                  <a:srgbClr val="D71920"/>
                 </a:solidFill>
                 <a:effectLst/>
                 <a:uLnTx/>
                 <a:uFillTx/>
-                <a:latin typeface="Segoe UI"/>
+                <a:latin typeface="Arial"/>
                 <a:ea typeface="+mn-ea"/>
                 <a:cs typeface="+mn-cs"/>
               </a:rPr>
@@ -6510,6 +6512,7 @@
             <a:avLst/>
           </a:prstGeom>
           <a:noFill/>
+          <a:ln/>
         </p:spPr>
         <p:txBody>
           <a:bodyPr wrap="square">
@@ -6540,12 +6543,12 @@
                   <a:noFill/>
                 </a:ln>
                 <a:solidFill>
-                  <a:srgbClr val="B8D0EC"/>
+                  <a:srgbClr val="E8E8E8"/>
                 </a:solidFill>
                 <a:effectLst/>
                 <a:uLnTx/>
                 <a:uFillTx/>
-                <a:latin typeface="Segoe UI"/>
+                <a:latin typeface="Arial"/>
                 <a:ea typeface="+mn-ea"/>
                 <a:cs typeface="+mn-cs"/>
               </a:rPr>
@@ -6569,7 +6572,7 @@
             <a:avLst/>
           </a:prstGeom>
           <a:solidFill>
-            <a:srgbClr val="0B1F3A"/>
+            <a:srgbClr val="2B2B2B"/>
           </a:solidFill>
           <a:ln>
             <a:noFill/>
@@ -6642,6 +6645,7 @@
             <a:avLst/>
           </a:prstGeom>
           <a:noFill/>
+          <a:ln/>
         </p:spPr>
         <p:txBody>
           <a:bodyPr wrap="square">
@@ -6672,12 +6676,12 @@
                   <a:noFill/>
                 </a:ln>
                 <a:solidFill>
-                  <a:srgbClr val="00D48A"/>
+                  <a:srgbClr val="2E7D32"/>
                 </a:solidFill>
                 <a:effectLst/>
                 <a:uLnTx/>
                 <a:uFillTx/>
-                <a:latin typeface="Segoe UI"/>
+                <a:latin typeface="Arial"/>
                 <a:ea typeface="+mn-ea"/>
                 <a:cs typeface="+mn-cs"/>
               </a:rPr>
@@ -6701,6 +6705,7 @@
             <a:avLst/>
           </a:prstGeom>
           <a:noFill/>
+          <a:ln/>
         </p:spPr>
         <p:txBody>
           <a:bodyPr wrap="square">
@@ -6731,12 +6736,12 @@
                   <a:noFill/>
                 </a:ln>
                 <a:solidFill>
-                  <a:srgbClr val="00C8F0"/>
+                  <a:srgbClr val="D71920"/>
                 </a:solidFill>
                 <a:effectLst/>
                 <a:uLnTx/>
                 <a:uFillTx/>
-                <a:latin typeface="Segoe UI"/>
+                <a:latin typeface="Arial"/>
                 <a:ea typeface="+mn-ea"/>
                 <a:cs typeface="+mn-cs"/>
               </a:rPr>
@@ -6760,6 +6765,7 @@
             <a:avLst/>
           </a:prstGeom>
           <a:noFill/>
+          <a:ln/>
         </p:spPr>
         <p:txBody>
           <a:bodyPr wrap="square">
@@ -6790,12 +6796,12 @@
                   <a:noFill/>
                 </a:ln>
                 <a:solidFill>
-                  <a:srgbClr val="B8D0EC"/>
+                  <a:srgbClr val="E8E8E8"/>
                 </a:solidFill>
                 <a:effectLst/>
                 <a:uLnTx/>
                 <a:uFillTx/>
-                <a:latin typeface="Segoe UI"/>
+                <a:latin typeface="Arial"/>
                 <a:ea typeface="+mn-ea"/>
                 <a:cs typeface="+mn-cs"/>
               </a:rPr>
@@ -6819,7 +6825,7 @@
             <a:avLst/>
           </a:prstGeom>
           <a:solidFill>
-            <a:srgbClr val="05142E"/>
+            <a:srgbClr val="1F1F1F"/>
           </a:solidFill>
           <a:ln>
             <a:noFill/>
@@ -6892,7 +6898,7 @@
             <a:avLst/>
           </a:prstGeom>
           <a:solidFill>
-            <a:srgbClr val="8B5CF6"/>
+            <a:srgbClr val="666666"/>
           </a:solidFill>
           <a:ln>
             <a:noFill/>
@@ -6965,6 +6971,7 @@
             <a:avLst/>
           </a:prstGeom>
           <a:noFill/>
+          <a:ln/>
         </p:spPr>
         <p:txBody>
           <a:bodyPr wrap="square">
@@ -7000,7 +7007,7 @@
                 <a:effectLst/>
                 <a:uLnTx/>
                 <a:uFillTx/>
-                <a:latin typeface="Segoe UI"/>
+                <a:latin typeface="Arial"/>
                 <a:ea typeface="+mn-ea"/>
                 <a:cs typeface="+mn-cs"/>
               </a:rPr>
@@ -7024,7 +7031,7 @@
             <a:avLst/>
           </a:prstGeom>
           <a:solidFill>
-            <a:srgbClr val="05142E"/>
+            <a:srgbClr val="1F1F1F"/>
           </a:solidFill>
           <a:ln>
             <a:noFill/>
@@ -7097,7 +7104,7 @@
             <a:avLst/>
           </a:prstGeom>
           <a:solidFill>
-            <a:srgbClr val="00D48A"/>
+            <a:srgbClr val="2E7D32"/>
           </a:solidFill>
           <a:ln>
             <a:noFill/>
@@ -7170,6 +7177,7 @@
             <a:avLst/>
           </a:prstGeom>
           <a:noFill/>
+          <a:ln/>
         </p:spPr>
         <p:txBody>
           <a:bodyPr wrap="square">
@@ -7205,7 +7213,7 @@
                 <a:effectLst/>
                 <a:uLnTx/>
                 <a:uFillTx/>
-                <a:latin typeface="Segoe UI"/>
+                <a:latin typeface="Arial"/>
                 <a:ea typeface="+mn-ea"/>
                 <a:cs typeface="+mn-cs"/>
               </a:rPr>
@@ -7229,7 +7237,7 @@
             <a:avLst/>
           </a:prstGeom>
           <a:solidFill>
-            <a:srgbClr val="05142E"/>
+            <a:srgbClr val="1F1F1F"/>
           </a:solidFill>
           <a:ln>
             <a:noFill/>
@@ -7302,7 +7310,7 @@
             <a:avLst/>
           </a:prstGeom>
           <a:solidFill>
-            <a:srgbClr val="FF8C00"/>
+            <a:srgbClr val="D71920"/>
           </a:solidFill>
           <a:ln>
             <a:noFill/>
@@ -7375,6 +7383,7 @@
             <a:avLst/>
           </a:prstGeom>
           <a:noFill/>
+          <a:ln/>
         </p:spPr>
         <p:txBody>
           <a:bodyPr wrap="square">
@@ -7410,7 +7419,7 @@
                 <a:effectLst/>
                 <a:uLnTx/>
                 <a:uFillTx/>
-                <a:latin typeface="Segoe UI"/>
+                <a:latin typeface="Arial"/>
                 <a:ea typeface="+mn-ea"/>
                 <a:cs typeface="+mn-cs"/>
               </a:rPr>
@@ -7434,7 +7443,7 @@
             <a:avLst/>
           </a:prstGeom>
           <a:solidFill>
-            <a:srgbClr val="05142E"/>
+            <a:srgbClr val="1F1F1F"/>
           </a:solidFill>
           <a:ln>
             <a:noFill/>
@@ -7580,6 +7589,7 @@
             <a:avLst/>
           </a:prstGeom>
           <a:noFill/>
+          <a:ln/>
         </p:spPr>
         <p:txBody>
           <a:bodyPr wrap="square">
@@ -7615,7 +7625,7 @@
                 <a:effectLst/>
                 <a:uLnTx/>
                 <a:uFillTx/>
-                <a:latin typeface="Segoe UI"/>
+                <a:latin typeface="Arial"/>
                 <a:ea typeface="+mn-ea"/>
                 <a:cs typeface="+mn-cs"/>
               </a:rPr>
@@ -7639,7 +7649,7 @@
             <a:avLst/>
           </a:prstGeom>
           <a:solidFill>
-            <a:srgbClr val="05142E"/>
+            <a:srgbClr val="1F1F1F"/>
           </a:solidFill>
           <a:ln>
             <a:noFill/>
@@ -7712,7 +7722,7 @@
             <a:avLst/>
           </a:prstGeom>
           <a:solidFill>
-            <a:srgbClr val="0072C6"/>
+            <a:srgbClr val="D71920"/>
           </a:solidFill>
           <a:ln>
             <a:noFill/>
@@ -7785,6 +7795,7 @@
             <a:avLst/>
           </a:prstGeom>
           <a:noFill/>
+          <a:ln/>
         </p:spPr>
         <p:txBody>
           <a:bodyPr wrap="square">
@@ -7820,7 +7831,7 @@
                 <a:effectLst/>
                 <a:uLnTx/>
                 <a:uFillTx/>
-                <a:latin typeface="Segoe UI"/>
+                <a:latin typeface="Arial"/>
                 <a:ea typeface="+mn-ea"/>
                 <a:cs typeface="+mn-cs"/>
               </a:rPr>
@@ -7844,7 +7855,7 @@
             <a:avLst/>
           </a:prstGeom>
           <a:solidFill>
-            <a:srgbClr val="05142E"/>
+            <a:srgbClr val="1F1F1F"/>
           </a:solidFill>
           <a:ln>
             <a:noFill/>
@@ -7917,7 +7928,7 @@
             <a:avLst/>
           </a:prstGeom>
           <a:solidFill>
-            <a:srgbClr val="00C8F0"/>
+            <a:srgbClr val="D71920"/>
           </a:solidFill>
           <a:ln>
             <a:noFill/>
@@ -7990,6 +8001,7 @@
             <a:avLst/>
           </a:prstGeom>
           <a:noFill/>
+          <a:ln/>
         </p:spPr>
         <p:txBody>
           <a:bodyPr wrap="square">
@@ -8025,7 +8037,7 @@
                 <a:effectLst/>
                 <a:uLnTx/>
                 <a:uFillTx/>
-                <a:latin typeface="Segoe UI"/>
+                <a:latin typeface="Arial"/>
                 <a:ea typeface="+mn-ea"/>
                 <a:cs typeface="+mn-cs"/>
               </a:rPr>
@@ -8049,7 +8061,7 @@
             <a:avLst/>
           </a:prstGeom>
           <a:solidFill>
-            <a:srgbClr val="0F2845"/>
+            <a:srgbClr val="333333"/>
           </a:solidFill>
           <a:ln>
             <a:noFill/>
@@ -8122,7 +8134,7 @@
             <a:avLst/>
           </a:prstGeom>
           <a:solidFill>
-            <a:srgbClr val="00D48A"/>
+            <a:srgbClr val="2E7D32"/>
           </a:solidFill>
           <a:ln>
             <a:noFill/>
@@ -8195,6 +8207,7 @@
             <a:avLst/>
           </a:prstGeom>
           <a:noFill/>
+          <a:ln/>
         </p:spPr>
         <p:txBody>
           <a:bodyPr wrap="square">
@@ -8230,7 +8243,7 @@
                 <a:effectLst/>
                 <a:uLnTx/>
                 <a:uFillTx/>
-                <a:latin typeface="Segoe UI"/>
+                <a:latin typeface="Arial"/>
                 <a:ea typeface="+mn-ea"/>
                 <a:cs typeface="+mn-cs"/>
               </a:rPr>
@@ -8254,6 +8267,7 @@
             <a:avLst/>
           </a:prstGeom>
           <a:noFill/>
+          <a:ln/>
         </p:spPr>
         <p:txBody>
           <a:bodyPr wrap="square">
@@ -8284,12 +8298,12 @@
                   <a:noFill/>
                 </a:ln>
                 <a:solidFill>
-                  <a:srgbClr val="00D48A"/>
+                  <a:srgbClr val="2E7D32"/>
                 </a:solidFill>
                 <a:effectLst/>
                 <a:uLnTx/>
                 <a:uFillTx/>
-                <a:latin typeface="Segoe UI"/>
+                <a:latin typeface="Arial"/>
                 <a:ea typeface="+mn-ea"/>
                 <a:cs typeface="+mn-cs"/>
               </a:rPr>
@@ -8313,7 +8327,7 @@
             <a:avLst/>
           </a:prstGeom>
           <a:solidFill>
-            <a:srgbClr val="0B1F3A"/>
+            <a:srgbClr val="2B2B2B"/>
           </a:solidFill>
           <a:ln>
             <a:noFill/>
@@ -8386,7 +8400,7 @@
             <a:avLst/>
           </a:prstGeom>
           <a:solidFill>
-            <a:srgbClr val="00D48A"/>
+            <a:srgbClr val="2E7D32"/>
           </a:solidFill>
           <a:ln>
             <a:noFill/>
@@ -8459,6 +8473,7 @@
             <a:avLst/>
           </a:prstGeom>
           <a:noFill/>
+          <a:ln/>
         </p:spPr>
         <p:txBody>
           <a:bodyPr wrap="square">
@@ -8494,7 +8509,7 @@
                 <a:effectLst/>
                 <a:uLnTx/>
                 <a:uFillTx/>
-                <a:latin typeface="Segoe UI"/>
+                <a:latin typeface="Arial"/>
                 <a:ea typeface="+mn-ea"/>
                 <a:cs typeface="+mn-cs"/>
               </a:rPr>
@@ -8518,6 +8533,7 @@
             <a:avLst/>
           </a:prstGeom>
           <a:noFill/>
+          <a:ln/>
         </p:spPr>
         <p:txBody>
           <a:bodyPr wrap="square">
@@ -8548,12 +8564,12 @@
                   <a:noFill/>
                 </a:ln>
                 <a:solidFill>
-                  <a:srgbClr val="B8D0EC"/>
+                  <a:srgbClr val="E8E8E8"/>
                 </a:solidFill>
                 <a:effectLst/>
                 <a:uLnTx/>
                 <a:uFillTx/>
-                <a:latin typeface="Segoe UI"/>
+                <a:latin typeface="Arial"/>
                 <a:ea typeface="+mn-ea"/>
                 <a:cs typeface="+mn-cs"/>
               </a:rPr>
@@ -8577,7 +8593,7 @@
             <a:avLst/>
           </a:prstGeom>
           <a:solidFill>
-            <a:srgbClr val="0B1F3A"/>
+            <a:srgbClr val="2B2B2B"/>
           </a:solidFill>
           <a:ln>
             <a:noFill/>
@@ -8650,7 +8666,7 @@
             <a:avLst/>
           </a:prstGeom>
           <a:solidFill>
-            <a:srgbClr val="00D48A"/>
+            <a:srgbClr val="2E7D32"/>
           </a:solidFill>
           <a:ln>
             <a:noFill/>
@@ -8723,6 +8739,7 @@
             <a:avLst/>
           </a:prstGeom>
           <a:noFill/>
+          <a:ln/>
         </p:spPr>
         <p:txBody>
           <a:bodyPr wrap="square">
@@ -8758,7 +8775,7 @@
                 <a:effectLst/>
                 <a:uLnTx/>
                 <a:uFillTx/>
-                <a:latin typeface="Segoe UI"/>
+                <a:latin typeface="Arial"/>
                 <a:ea typeface="+mn-ea"/>
                 <a:cs typeface="+mn-cs"/>
               </a:rPr>
@@ -8782,6 +8799,7 @@
             <a:avLst/>
           </a:prstGeom>
           <a:noFill/>
+          <a:ln/>
         </p:spPr>
         <p:txBody>
           <a:bodyPr wrap="square">
@@ -8812,12 +8830,12 @@
                   <a:noFill/>
                 </a:ln>
                 <a:solidFill>
-                  <a:srgbClr val="B8D0EC"/>
+                  <a:srgbClr val="E8E8E8"/>
                 </a:solidFill>
                 <a:effectLst/>
                 <a:uLnTx/>
                 <a:uFillTx/>
-                <a:latin typeface="Segoe UI"/>
+                <a:latin typeface="Arial"/>
                 <a:ea typeface="+mn-ea"/>
                 <a:cs typeface="+mn-cs"/>
               </a:rPr>
@@ -8841,7 +8859,7 @@
             <a:avLst/>
           </a:prstGeom>
           <a:solidFill>
-            <a:srgbClr val="0B1F3A"/>
+            <a:srgbClr val="2B2B2B"/>
           </a:solidFill>
           <a:ln>
             <a:noFill/>
@@ -8914,7 +8932,7 @@
             <a:avLst/>
           </a:prstGeom>
           <a:solidFill>
-            <a:srgbClr val="00D48A"/>
+            <a:srgbClr val="2E7D32"/>
           </a:solidFill>
           <a:ln>
             <a:noFill/>
@@ -8987,6 +9005,7 @@
             <a:avLst/>
           </a:prstGeom>
           <a:noFill/>
+          <a:ln/>
         </p:spPr>
         <p:txBody>
           <a:bodyPr wrap="square">
@@ -9022,7 +9041,7 @@
                 <a:effectLst/>
                 <a:uLnTx/>
                 <a:uFillTx/>
-                <a:latin typeface="Segoe UI"/>
+                <a:latin typeface="Arial"/>
                 <a:ea typeface="+mn-ea"/>
                 <a:cs typeface="+mn-cs"/>
               </a:rPr>
@@ -9046,6 +9065,7 @@
             <a:avLst/>
           </a:prstGeom>
           <a:noFill/>
+          <a:ln/>
         </p:spPr>
         <p:txBody>
           <a:bodyPr wrap="square">
@@ -9076,12 +9096,12 @@
                   <a:noFill/>
                 </a:ln>
                 <a:solidFill>
-                  <a:srgbClr val="B8D0EC"/>
+                  <a:srgbClr val="E8E8E8"/>
                 </a:solidFill>
                 <a:effectLst/>
                 <a:uLnTx/>
                 <a:uFillTx/>
-                <a:latin typeface="Segoe UI"/>
+                <a:latin typeface="Arial"/>
                 <a:ea typeface="+mn-ea"/>
                 <a:cs typeface="+mn-cs"/>
               </a:rPr>
@@ -9105,7 +9125,7 @@
             <a:avLst/>
           </a:prstGeom>
           <a:solidFill>
-            <a:srgbClr val="0B1F3A"/>
+            <a:srgbClr val="2B2B2B"/>
           </a:solidFill>
           <a:ln>
             <a:noFill/>
@@ -9178,7 +9198,7 @@
             <a:avLst/>
           </a:prstGeom>
           <a:solidFill>
-            <a:srgbClr val="00D48A"/>
+            <a:srgbClr val="2E7D32"/>
           </a:solidFill>
           <a:ln>
             <a:noFill/>
@@ -9251,6 +9271,7 @@
             <a:avLst/>
           </a:prstGeom>
           <a:noFill/>
+          <a:ln/>
         </p:spPr>
         <p:txBody>
           <a:bodyPr wrap="square">
@@ -9286,7 +9307,7 @@
                 <a:effectLst/>
                 <a:uLnTx/>
                 <a:uFillTx/>
-                <a:latin typeface="Segoe UI"/>
+                <a:latin typeface="Arial"/>
                 <a:ea typeface="+mn-ea"/>
                 <a:cs typeface="+mn-cs"/>
               </a:rPr>
@@ -9310,6 +9331,7 @@
             <a:avLst/>
           </a:prstGeom>
           <a:noFill/>
+          <a:ln/>
         </p:spPr>
         <p:txBody>
           <a:bodyPr wrap="square">
@@ -9340,12 +9362,12 @@
                   <a:noFill/>
                 </a:ln>
                 <a:solidFill>
-                  <a:srgbClr val="B8D0EC"/>
+                  <a:srgbClr val="E8E8E8"/>
                 </a:solidFill>
                 <a:effectLst/>
                 <a:uLnTx/>
                 <a:uFillTx/>
-                <a:latin typeface="Segoe UI"/>
+                <a:latin typeface="Arial"/>
                 <a:ea typeface="+mn-ea"/>
                 <a:cs typeface="+mn-cs"/>
               </a:rPr>
@@ -9369,7 +9391,7 @@
             <a:avLst/>
           </a:prstGeom>
           <a:solidFill>
-            <a:srgbClr val="00C8F0"/>
+            <a:srgbClr val="D71920"/>
           </a:solidFill>
           <a:ln>
             <a:noFill/>
@@ -9442,7 +9464,7 @@
             <a:avLst/>
           </a:prstGeom>
           <a:solidFill>
-            <a:srgbClr val="0F2845"/>
+            <a:srgbClr val="333333"/>
           </a:solidFill>
           <a:ln>
             <a:noFill/>
@@ -9515,7 +9537,7 @@
             <a:avLst/>
           </a:prstGeom>
           <a:solidFill>
-            <a:srgbClr val="0072C6"/>
+            <a:srgbClr val="D71920"/>
           </a:solidFill>
           <a:ln>
             <a:noFill/>
@@ -9588,6 +9610,7 @@
             <a:avLst/>
           </a:prstGeom>
           <a:noFill/>
+          <a:ln/>
         </p:spPr>
         <p:txBody>
           <a:bodyPr wrap="square">
@@ -9623,7 +9646,7 @@
                 <a:effectLst/>
                 <a:uLnTx/>
                 <a:uFillTx/>
-                <a:latin typeface="Segoe UI"/>
+                <a:latin typeface="Arial"/>
                 <a:ea typeface="+mn-ea"/>
                 <a:cs typeface="+mn-cs"/>
               </a:rPr>
@@ -9647,6 +9670,7 @@
             <a:avLst/>
           </a:prstGeom>
           <a:noFill/>
+          <a:ln/>
         </p:spPr>
         <p:txBody>
           <a:bodyPr wrap="square">
@@ -9677,12 +9701,12 @@
                   <a:noFill/>
                 </a:ln>
                 <a:solidFill>
-                  <a:srgbClr val="0072C6"/>
+                  <a:srgbClr val="D71920"/>
                 </a:solidFill>
                 <a:effectLst/>
                 <a:uLnTx/>
                 <a:uFillTx/>
-                <a:latin typeface="Segoe UI"/>
+                <a:latin typeface="Arial"/>
                 <a:ea typeface="+mn-ea"/>
                 <a:cs typeface="+mn-cs"/>
               </a:rPr>
@@ -9706,7 +9730,7 @@
             <a:avLst/>
           </a:prstGeom>
           <a:solidFill>
-            <a:srgbClr val="0B1F3A"/>
+            <a:srgbClr val="2B2B2B"/>
           </a:solidFill>
           <a:ln>
             <a:noFill/>
@@ -9779,7 +9803,7 @@
             <a:avLst/>
           </a:prstGeom>
           <a:solidFill>
-            <a:srgbClr val="0072C6"/>
+            <a:srgbClr val="D71920"/>
           </a:solidFill>
           <a:ln>
             <a:noFill/>
@@ -9852,6 +9876,7 @@
             <a:avLst/>
           </a:prstGeom>
           <a:noFill/>
+          <a:ln/>
         </p:spPr>
         <p:txBody>
           <a:bodyPr wrap="square">
@@ -9887,7 +9912,7 @@
                 <a:effectLst/>
                 <a:uLnTx/>
                 <a:uFillTx/>
-                <a:latin typeface="Segoe UI"/>
+                <a:latin typeface="Arial"/>
                 <a:ea typeface="+mn-ea"/>
                 <a:cs typeface="+mn-cs"/>
               </a:rPr>
@@ -9911,6 +9936,7 @@
             <a:avLst/>
           </a:prstGeom>
           <a:noFill/>
+          <a:ln/>
         </p:spPr>
         <p:txBody>
           <a:bodyPr wrap="square">
@@ -9941,12 +9967,12 @@
                   <a:noFill/>
                 </a:ln>
                 <a:solidFill>
-                  <a:srgbClr val="B8D0EC"/>
+                  <a:srgbClr val="E8E8E8"/>
                 </a:solidFill>
                 <a:effectLst/>
                 <a:uLnTx/>
                 <a:uFillTx/>
-                <a:latin typeface="Segoe UI"/>
+                <a:latin typeface="Arial"/>
                 <a:ea typeface="+mn-ea"/>
                 <a:cs typeface="+mn-cs"/>
               </a:rPr>
@@ -9970,7 +9996,7 @@
             <a:avLst/>
           </a:prstGeom>
           <a:solidFill>
-            <a:srgbClr val="0B1F3A"/>
+            <a:srgbClr val="2B2B2B"/>
           </a:solidFill>
           <a:ln>
             <a:noFill/>
@@ -10043,7 +10069,7 @@
             <a:avLst/>
           </a:prstGeom>
           <a:solidFill>
-            <a:srgbClr val="0072C6"/>
+            <a:srgbClr val="D71920"/>
           </a:solidFill>
           <a:ln>
             <a:noFill/>
@@ -10116,6 +10142,7 @@
             <a:avLst/>
           </a:prstGeom>
           <a:noFill/>
+          <a:ln/>
         </p:spPr>
         <p:txBody>
           <a:bodyPr wrap="square">
@@ -10151,7 +10178,7 @@
                 <a:effectLst/>
                 <a:uLnTx/>
                 <a:uFillTx/>
-                <a:latin typeface="Segoe UI"/>
+                <a:latin typeface="Arial"/>
                 <a:ea typeface="+mn-ea"/>
                 <a:cs typeface="+mn-cs"/>
               </a:rPr>
@@ -10175,6 +10202,7 @@
             <a:avLst/>
           </a:prstGeom>
           <a:noFill/>
+          <a:ln/>
         </p:spPr>
         <p:txBody>
           <a:bodyPr wrap="square">
@@ -10205,12 +10233,12 @@
                   <a:noFill/>
                 </a:ln>
                 <a:solidFill>
-                  <a:srgbClr val="B8D0EC"/>
+                  <a:srgbClr val="E8E8E8"/>
                 </a:solidFill>
                 <a:effectLst/>
                 <a:uLnTx/>
                 <a:uFillTx/>
-                <a:latin typeface="Segoe UI"/>
+                <a:latin typeface="Arial"/>
                 <a:ea typeface="+mn-ea"/>
                 <a:cs typeface="+mn-cs"/>
               </a:rPr>
@@ -10234,7 +10262,7 @@
             <a:avLst/>
           </a:prstGeom>
           <a:solidFill>
-            <a:srgbClr val="0B1F3A"/>
+            <a:srgbClr val="2B2B2B"/>
           </a:solidFill>
           <a:ln>
             <a:noFill/>
@@ -10307,7 +10335,7 @@
             <a:avLst/>
           </a:prstGeom>
           <a:solidFill>
-            <a:srgbClr val="0072C6"/>
+            <a:srgbClr val="D71920"/>
           </a:solidFill>
           <a:ln>
             <a:noFill/>
@@ -10380,6 +10408,7 @@
             <a:avLst/>
           </a:prstGeom>
           <a:noFill/>
+          <a:ln/>
         </p:spPr>
         <p:txBody>
           <a:bodyPr wrap="square">
@@ -10415,7 +10444,7 @@
                 <a:effectLst/>
                 <a:uLnTx/>
                 <a:uFillTx/>
-                <a:latin typeface="Segoe UI"/>
+                <a:latin typeface="Arial"/>
                 <a:ea typeface="+mn-ea"/>
                 <a:cs typeface="+mn-cs"/>
               </a:rPr>
@@ -10439,6 +10468,7 @@
             <a:avLst/>
           </a:prstGeom>
           <a:noFill/>
+          <a:ln/>
         </p:spPr>
         <p:txBody>
           <a:bodyPr wrap="square">
@@ -10469,12 +10499,12 @@
                   <a:noFill/>
                 </a:ln>
                 <a:solidFill>
-                  <a:srgbClr val="B8D0EC"/>
+                  <a:srgbClr val="E8E8E8"/>
                 </a:solidFill>
                 <a:effectLst/>
                 <a:uLnTx/>
                 <a:uFillTx/>
-                <a:latin typeface="Segoe UI"/>
+                <a:latin typeface="Arial"/>
                 <a:ea typeface="+mn-ea"/>
                 <a:cs typeface="+mn-cs"/>
               </a:rPr>
@@ -10498,7 +10528,7 @@
             <a:avLst/>
           </a:prstGeom>
           <a:solidFill>
-            <a:srgbClr val="0B1F3A"/>
+            <a:srgbClr val="2B2B2B"/>
           </a:solidFill>
           <a:ln>
             <a:noFill/>
@@ -10571,7 +10601,7 @@
             <a:avLst/>
           </a:prstGeom>
           <a:solidFill>
-            <a:srgbClr val="0072C6"/>
+            <a:srgbClr val="D71920"/>
           </a:solidFill>
           <a:ln>
             <a:noFill/>
@@ -10644,6 +10674,7 @@
             <a:avLst/>
           </a:prstGeom>
           <a:noFill/>
+          <a:ln/>
         </p:spPr>
         <p:txBody>
           <a:bodyPr wrap="square">
@@ -10679,7 +10710,7 @@
                 <a:effectLst/>
                 <a:uLnTx/>
                 <a:uFillTx/>
-                <a:latin typeface="Segoe UI"/>
+                <a:latin typeface="Arial"/>
                 <a:ea typeface="+mn-ea"/>
                 <a:cs typeface="+mn-cs"/>
               </a:rPr>
@@ -10703,6 +10734,7 @@
             <a:avLst/>
           </a:prstGeom>
           <a:noFill/>
+          <a:ln/>
         </p:spPr>
         <p:txBody>
           <a:bodyPr wrap="square">
@@ -10733,12 +10765,12 @@
                   <a:noFill/>
                 </a:ln>
                 <a:solidFill>
-                  <a:srgbClr val="B8D0EC"/>
+                  <a:srgbClr val="E8E8E8"/>
                 </a:solidFill>
                 <a:effectLst/>
                 <a:uLnTx/>
                 <a:uFillTx/>
-                <a:latin typeface="Segoe UI"/>
+                <a:latin typeface="Arial"/>
                 <a:ea typeface="+mn-ea"/>
                 <a:cs typeface="+mn-cs"/>
               </a:rPr>
@@ -10762,7 +10794,7 @@
             <a:avLst/>
           </a:prstGeom>
           <a:solidFill>
-            <a:srgbClr val="00C8F0"/>
+            <a:srgbClr val="D71920"/>
           </a:solidFill>
           <a:ln>
             <a:noFill/>
@@ -10835,7 +10867,7 @@
             <a:avLst/>
           </a:prstGeom>
           <a:solidFill>
-            <a:srgbClr val="0F2845"/>
+            <a:srgbClr val="333333"/>
           </a:solidFill>
           <a:ln>
             <a:noFill/>
@@ -10908,7 +10940,7 @@
             <a:avLst/>
           </a:prstGeom>
           <a:solidFill>
-            <a:srgbClr val="FF8C00"/>
+            <a:srgbClr val="D71920"/>
           </a:solidFill>
           <a:ln>
             <a:noFill/>
@@ -10981,6 +11013,7 @@
             <a:avLst/>
           </a:prstGeom>
           <a:noFill/>
+          <a:ln/>
         </p:spPr>
         <p:txBody>
           <a:bodyPr wrap="square">
@@ -11016,7 +11049,7 @@
                 <a:effectLst/>
                 <a:uLnTx/>
                 <a:uFillTx/>
-                <a:latin typeface="Segoe UI"/>
+                <a:latin typeface="Arial"/>
                 <a:ea typeface="+mn-ea"/>
                 <a:cs typeface="+mn-cs"/>
               </a:rPr>
@@ -11040,6 +11073,7 @@
             <a:avLst/>
           </a:prstGeom>
           <a:noFill/>
+          <a:ln/>
         </p:spPr>
         <p:txBody>
           <a:bodyPr wrap="square">
@@ -11070,12 +11104,12 @@
                   <a:noFill/>
                 </a:ln>
                 <a:solidFill>
-                  <a:srgbClr val="FF8C00"/>
+                  <a:srgbClr val="D71920"/>
                 </a:solidFill>
                 <a:effectLst/>
                 <a:uLnTx/>
                 <a:uFillTx/>
-                <a:latin typeface="Segoe UI"/>
+                <a:latin typeface="Arial"/>
                 <a:ea typeface="+mn-ea"/>
                 <a:cs typeface="+mn-cs"/>
               </a:rPr>
@@ -11099,7 +11133,7 @@
             <a:avLst/>
           </a:prstGeom>
           <a:solidFill>
-            <a:srgbClr val="0B1F3A"/>
+            <a:srgbClr val="2B2B2B"/>
           </a:solidFill>
           <a:ln>
             <a:noFill/>
@@ -11172,7 +11206,7 @@
             <a:avLst/>
           </a:prstGeom>
           <a:solidFill>
-            <a:srgbClr val="FF8C00"/>
+            <a:srgbClr val="D71920"/>
           </a:solidFill>
           <a:ln>
             <a:noFill/>
@@ -11245,6 +11279,7 @@
             <a:avLst/>
           </a:prstGeom>
           <a:noFill/>
+          <a:ln/>
         </p:spPr>
         <p:txBody>
           <a:bodyPr wrap="square">
@@ -11280,7 +11315,7 @@
                 <a:effectLst/>
                 <a:uLnTx/>
                 <a:uFillTx/>
-                <a:latin typeface="Segoe UI"/>
+                <a:latin typeface="Arial"/>
                 <a:ea typeface="+mn-ea"/>
                 <a:cs typeface="+mn-cs"/>
               </a:rPr>
@@ -11304,6 +11339,7 @@
             <a:avLst/>
           </a:prstGeom>
           <a:noFill/>
+          <a:ln/>
         </p:spPr>
         <p:txBody>
           <a:bodyPr wrap="square">
@@ -11334,12 +11370,12 @@
                   <a:noFill/>
                 </a:ln>
                 <a:solidFill>
-                  <a:srgbClr val="B8D0EC"/>
+                  <a:srgbClr val="E8E8E8"/>
                 </a:solidFill>
                 <a:effectLst/>
                 <a:uLnTx/>
                 <a:uFillTx/>
-                <a:latin typeface="Segoe UI"/>
+                <a:latin typeface="Arial"/>
                 <a:ea typeface="+mn-ea"/>
                 <a:cs typeface="+mn-cs"/>
               </a:rPr>
@@ -11363,7 +11399,7 @@
             <a:avLst/>
           </a:prstGeom>
           <a:solidFill>
-            <a:srgbClr val="0B1F3A"/>
+            <a:srgbClr val="2B2B2B"/>
           </a:solidFill>
           <a:ln>
             <a:noFill/>
@@ -11436,7 +11472,7 @@
             <a:avLst/>
           </a:prstGeom>
           <a:solidFill>
-            <a:srgbClr val="FF8C00"/>
+            <a:srgbClr val="D71920"/>
           </a:solidFill>
           <a:ln>
             <a:noFill/>
@@ -11509,6 +11545,7 @@
             <a:avLst/>
           </a:prstGeom>
           <a:noFill/>
+          <a:ln/>
         </p:spPr>
         <p:txBody>
           <a:bodyPr wrap="square">
@@ -11544,7 +11581,7 @@
                 <a:effectLst/>
                 <a:uLnTx/>
                 <a:uFillTx/>
-                <a:latin typeface="Segoe UI"/>
+                <a:latin typeface="Arial"/>
                 <a:ea typeface="+mn-ea"/>
                 <a:cs typeface="+mn-cs"/>
               </a:rPr>
@@ -11568,6 +11605,7 @@
             <a:avLst/>
           </a:prstGeom>
           <a:noFill/>
+          <a:ln/>
         </p:spPr>
         <p:txBody>
           <a:bodyPr wrap="square">
@@ -11598,12 +11636,12 @@
                   <a:noFill/>
                 </a:ln>
                 <a:solidFill>
-                  <a:srgbClr val="B8D0EC"/>
+                  <a:srgbClr val="E8E8E8"/>
                 </a:solidFill>
                 <a:effectLst/>
                 <a:uLnTx/>
                 <a:uFillTx/>
-                <a:latin typeface="Segoe UI"/>
+                <a:latin typeface="Arial"/>
                 <a:ea typeface="+mn-ea"/>
                 <a:cs typeface="+mn-cs"/>
               </a:rPr>
@@ -11627,7 +11665,7 @@
             <a:avLst/>
           </a:prstGeom>
           <a:solidFill>
-            <a:srgbClr val="0B1F3A"/>
+            <a:srgbClr val="2B2B2B"/>
           </a:solidFill>
           <a:ln>
             <a:noFill/>
@@ -11700,7 +11738,7 @@
             <a:avLst/>
           </a:prstGeom>
           <a:solidFill>
-            <a:srgbClr val="FF8C00"/>
+            <a:srgbClr val="D71920"/>
           </a:solidFill>
           <a:ln>
             <a:noFill/>
@@ -11773,6 +11811,7 @@
             <a:avLst/>
           </a:prstGeom>
           <a:noFill/>
+          <a:ln/>
         </p:spPr>
         <p:txBody>
           <a:bodyPr wrap="square">
@@ -11808,7 +11847,7 @@
                 <a:effectLst/>
                 <a:uLnTx/>
                 <a:uFillTx/>
-                <a:latin typeface="Segoe UI"/>
+                <a:latin typeface="Arial"/>
                 <a:ea typeface="+mn-ea"/>
                 <a:cs typeface="+mn-cs"/>
               </a:rPr>
@@ -11832,6 +11871,7 @@
             <a:avLst/>
           </a:prstGeom>
           <a:noFill/>
+          <a:ln/>
         </p:spPr>
         <p:txBody>
           <a:bodyPr wrap="square">
@@ -11862,12 +11902,12 @@
                   <a:noFill/>
                 </a:ln>
                 <a:solidFill>
-                  <a:srgbClr val="B8D0EC"/>
+                  <a:srgbClr val="E8E8E8"/>
                 </a:solidFill>
                 <a:effectLst/>
                 <a:uLnTx/>
                 <a:uFillTx/>
-                <a:latin typeface="Segoe UI"/>
+                <a:latin typeface="Arial"/>
                 <a:ea typeface="+mn-ea"/>
                 <a:cs typeface="+mn-cs"/>
               </a:rPr>
@@ -11891,7 +11931,7 @@
             <a:avLst/>
           </a:prstGeom>
           <a:solidFill>
-            <a:srgbClr val="0B1F3A"/>
+            <a:srgbClr val="2B2B2B"/>
           </a:solidFill>
           <a:ln>
             <a:noFill/>
@@ -11964,7 +12004,7 @@
             <a:avLst/>
           </a:prstGeom>
           <a:solidFill>
-            <a:srgbClr val="FF8C00"/>
+            <a:srgbClr val="D71920"/>
           </a:solidFill>
           <a:ln>
             <a:noFill/>
@@ -12037,6 +12077,7 @@
             <a:avLst/>
           </a:prstGeom>
           <a:noFill/>
+          <a:ln/>
         </p:spPr>
         <p:txBody>
           <a:bodyPr wrap="square">
@@ -12072,7 +12113,7 @@
                 <a:effectLst/>
                 <a:uLnTx/>
                 <a:uFillTx/>
-                <a:latin typeface="Segoe UI"/>
+                <a:latin typeface="Arial"/>
                 <a:ea typeface="+mn-ea"/>
                 <a:cs typeface="+mn-cs"/>
               </a:rPr>
@@ -12096,6 +12137,7 @@
             <a:avLst/>
           </a:prstGeom>
           <a:noFill/>
+          <a:ln/>
         </p:spPr>
         <p:txBody>
           <a:bodyPr wrap="square">
@@ -12126,12 +12168,12 @@
                   <a:noFill/>
                 </a:ln>
                 <a:solidFill>
-                  <a:srgbClr val="B8D0EC"/>
+                  <a:srgbClr val="E8E8E8"/>
                 </a:solidFill>
                 <a:effectLst/>
                 <a:uLnTx/>
                 <a:uFillTx/>
-                <a:latin typeface="Segoe UI"/>
+                <a:latin typeface="Arial"/>
                 <a:ea typeface="+mn-ea"/>
                 <a:cs typeface="+mn-cs"/>
               </a:rPr>
@@ -12155,7 +12197,7 @@
             <a:avLst/>
           </a:prstGeom>
           <a:solidFill>
-            <a:srgbClr val="00C8F0"/>
+            <a:srgbClr val="D71920"/>
           </a:solidFill>
           <a:ln>
             <a:noFill/>
@@ -12228,7 +12270,7 @@
             <a:avLst/>
           </a:prstGeom>
           <a:solidFill>
-            <a:srgbClr val="0F2845"/>
+            <a:srgbClr val="333333"/>
           </a:solidFill>
           <a:ln>
             <a:noFill/>
@@ -12301,7 +12343,7 @@
             <a:avLst/>
           </a:prstGeom>
           <a:solidFill>
-            <a:srgbClr val="8B5CF6"/>
+            <a:srgbClr val="666666"/>
           </a:solidFill>
           <a:ln>
             <a:noFill/>
@@ -12374,6 +12416,7 @@
             <a:avLst/>
           </a:prstGeom>
           <a:noFill/>
+          <a:ln/>
         </p:spPr>
         <p:txBody>
           <a:bodyPr wrap="square">
@@ -12409,7 +12452,7 @@
                 <a:effectLst/>
                 <a:uLnTx/>
                 <a:uFillTx/>
-                <a:latin typeface="Segoe UI"/>
+                <a:latin typeface="Arial"/>
                 <a:ea typeface="+mn-ea"/>
                 <a:cs typeface="+mn-cs"/>
               </a:rPr>
@@ -12433,6 +12476,7 @@
             <a:avLst/>
           </a:prstGeom>
           <a:noFill/>
+          <a:ln/>
         </p:spPr>
         <p:txBody>
           <a:bodyPr wrap="square">
@@ -12463,12 +12507,12 @@
                   <a:noFill/>
                 </a:ln>
                 <a:solidFill>
-                  <a:srgbClr val="8B5CF6"/>
+                  <a:srgbClr val="E8E8E8"/>
                 </a:solidFill>
                 <a:effectLst/>
                 <a:uLnTx/>
                 <a:uFillTx/>
-                <a:latin typeface="Segoe UI"/>
+                <a:latin typeface="Arial"/>
                 <a:ea typeface="+mn-ea"/>
                 <a:cs typeface="+mn-cs"/>
               </a:rPr>
@@ -12492,7 +12536,7 @@
             <a:avLst/>
           </a:prstGeom>
           <a:solidFill>
-            <a:srgbClr val="0B1F3A"/>
+            <a:srgbClr val="2B2B2B"/>
           </a:solidFill>
           <a:ln>
             <a:noFill/>
@@ -12565,7 +12609,7 @@
             <a:avLst/>
           </a:prstGeom>
           <a:solidFill>
-            <a:srgbClr val="8B5CF6"/>
+            <a:srgbClr val="666666"/>
           </a:solidFill>
           <a:ln>
             <a:noFill/>
@@ -12638,6 +12682,7 @@
             <a:avLst/>
           </a:prstGeom>
           <a:noFill/>
+          <a:ln/>
         </p:spPr>
         <p:txBody>
           <a:bodyPr wrap="square">
@@ -12673,7 +12718,7 @@
                 <a:effectLst/>
                 <a:uLnTx/>
                 <a:uFillTx/>
-                <a:latin typeface="Segoe UI"/>
+                <a:latin typeface="Arial"/>
                 <a:ea typeface="+mn-ea"/>
                 <a:cs typeface="+mn-cs"/>
               </a:rPr>
@@ -12697,6 +12742,7 @@
             <a:avLst/>
           </a:prstGeom>
           <a:noFill/>
+          <a:ln/>
         </p:spPr>
         <p:txBody>
           <a:bodyPr wrap="square">
@@ -12727,12 +12773,12 @@
                   <a:noFill/>
                 </a:ln>
                 <a:solidFill>
-                  <a:srgbClr val="B8D0EC"/>
+                  <a:srgbClr val="E8E8E8"/>
                 </a:solidFill>
                 <a:effectLst/>
                 <a:uLnTx/>
                 <a:uFillTx/>
-                <a:latin typeface="Segoe UI"/>
+                <a:latin typeface="Arial"/>
                 <a:ea typeface="+mn-ea"/>
                 <a:cs typeface="+mn-cs"/>
               </a:rPr>
@@ -12756,7 +12802,7 @@
             <a:avLst/>
           </a:prstGeom>
           <a:solidFill>
-            <a:srgbClr val="0B1F3A"/>
+            <a:srgbClr val="2B2B2B"/>
           </a:solidFill>
           <a:ln>
             <a:noFill/>
@@ -12829,7 +12875,7 @@
             <a:avLst/>
           </a:prstGeom>
           <a:solidFill>
-            <a:srgbClr val="8B5CF6"/>
+            <a:srgbClr val="666666"/>
           </a:solidFill>
           <a:ln>
             <a:noFill/>
@@ -12902,6 +12948,7 @@
             <a:avLst/>
           </a:prstGeom>
           <a:noFill/>
+          <a:ln/>
         </p:spPr>
         <p:txBody>
           <a:bodyPr wrap="square">
@@ -12937,7 +12984,7 @@
                 <a:effectLst/>
                 <a:uLnTx/>
                 <a:uFillTx/>
-                <a:latin typeface="Segoe UI"/>
+                <a:latin typeface="Arial"/>
                 <a:ea typeface="+mn-ea"/>
                 <a:cs typeface="+mn-cs"/>
               </a:rPr>
@@ -12961,6 +13008,7 @@
             <a:avLst/>
           </a:prstGeom>
           <a:noFill/>
+          <a:ln/>
         </p:spPr>
         <p:txBody>
           <a:bodyPr wrap="square">
@@ -12991,12 +13039,12 @@
                   <a:noFill/>
                 </a:ln>
                 <a:solidFill>
-                  <a:srgbClr val="B8D0EC"/>
+                  <a:srgbClr val="E8E8E8"/>
                 </a:solidFill>
                 <a:effectLst/>
                 <a:uLnTx/>
                 <a:uFillTx/>
-                <a:latin typeface="Segoe UI"/>
+                <a:latin typeface="Arial"/>
                 <a:ea typeface="+mn-ea"/>
                 <a:cs typeface="+mn-cs"/>
               </a:rPr>
@@ -13020,7 +13068,7 @@
             <a:avLst/>
           </a:prstGeom>
           <a:solidFill>
-            <a:srgbClr val="0B1F3A"/>
+            <a:srgbClr val="2B2B2B"/>
           </a:solidFill>
           <a:ln>
             <a:noFill/>
@@ -13093,7 +13141,7 @@
             <a:avLst/>
           </a:prstGeom>
           <a:solidFill>
-            <a:srgbClr val="8B5CF6"/>
+            <a:srgbClr val="666666"/>
           </a:solidFill>
           <a:ln>
             <a:noFill/>
@@ -13166,6 +13214,7 @@
             <a:avLst/>
           </a:prstGeom>
           <a:noFill/>
+          <a:ln/>
         </p:spPr>
         <p:txBody>
           <a:bodyPr wrap="square">
@@ -13201,7 +13250,7 @@
                 <a:effectLst/>
                 <a:uLnTx/>
                 <a:uFillTx/>
-                <a:latin typeface="Segoe UI"/>
+                <a:latin typeface="Arial"/>
                 <a:ea typeface="+mn-ea"/>
                 <a:cs typeface="+mn-cs"/>
               </a:rPr>
@@ -13225,6 +13274,7 @@
             <a:avLst/>
           </a:prstGeom>
           <a:noFill/>
+          <a:ln/>
         </p:spPr>
         <p:txBody>
           <a:bodyPr wrap="square">
@@ -13255,12 +13305,12 @@
                   <a:noFill/>
                 </a:ln>
                 <a:solidFill>
-                  <a:srgbClr val="B8D0EC"/>
+                  <a:srgbClr val="E8E8E8"/>
                 </a:solidFill>
                 <a:effectLst/>
                 <a:uLnTx/>
                 <a:uFillTx/>
-                <a:latin typeface="Segoe UI"/>
+                <a:latin typeface="Arial"/>
                 <a:ea typeface="+mn-ea"/>
                 <a:cs typeface="+mn-cs"/>
               </a:rPr>
@@ -13284,7 +13334,7 @@
             <a:avLst/>
           </a:prstGeom>
           <a:solidFill>
-            <a:srgbClr val="0B1F3A"/>
+            <a:srgbClr val="2B2B2B"/>
           </a:solidFill>
           <a:ln>
             <a:noFill/>
@@ -13357,7 +13407,7 @@
             <a:avLst/>
           </a:prstGeom>
           <a:solidFill>
-            <a:srgbClr val="8B5CF6"/>
+            <a:srgbClr val="666666"/>
           </a:solidFill>
           <a:ln>
             <a:noFill/>
@@ -13430,6 +13480,7 @@
             <a:avLst/>
           </a:prstGeom>
           <a:noFill/>
+          <a:ln/>
         </p:spPr>
         <p:txBody>
           <a:bodyPr wrap="square">
@@ -13465,7 +13516,7 @@
                 <a:effectLst/>
                 <a:uLnTx/>
                 <a:uFillTx/>
-                <a:latin typeface="Segoe UI"/>
+                <a:latin typeface="Arial"/>
                 <a:ea typeface="+mn-ea"/>
                 <a:cs typeface="+mn-cs"/>
               </a:rPr>
@@ -13489,6 +13540,7 @@
             <a:avLst/>
           </a:prstGeom>
           <a:noFill/>
+          <a:ln/>
         </p:spPr>
         <p:txBody>
           <a:bodyPr wrap="square">
@@ -13519,12 +13571,12 @@
                   <a:noFill/>
                 </a:ln>
                 <a:solidFill>
-                  <a:srgbClr val="B8D0EC"/>
+                  <a:srgbClr val="E8E8E8"/>
                 </a:solidFill>
                 <a:effectLst/>
                 <a:uLnTx/>
                 <a:uFillTx/>
-                <a:latin typeface="Segoe UI"/>
+                <a:latin typeface="Arial"/>
                 <a:ea typeface="+mn-ea"/>
                 <a:cs typeface="+mn-cs"/>
               </a:rPr>
@@ -13548,7 +13600,7 @@
             <a:avLst/>
           </a:prstGeom>
           <a:solidFill>
-            <a:srgbClr val="00C8F0"/>
+            <a:srgbClr val="D71920"/>
           </a:solidFill>
           <a:ln>
             <a:noFill/>
@@ -13621,7 +13673,7 @@
             <a:avLst/>
           </a:prstGeom>
           <a:solidFill>
-            <a:srgbClr val="0F2845"/>
+            <a:srgbClr val="333333"/>
           </a:solidFill>
           <a:ln>
             <a:noFill/>
@@ -13694,7 +13746,7 @@
             <a:avLst/>
           </a:prstGeom>
           <a:solidFill>
-            <a:srgbClr val="00A89A"/>
+            <a:srgbClr val="A70E17"/>
           </a:solidFill>
           <a:ln>
             <a:noFill/>
@@ -13767,6 +13819,7 @@
             <a:avLst/>
           </a:prstGeom>
           <a:noFill/>
+          <a:ln/>
         </p:spPr>
         <p:txBody>
           <a:bodyPr wrap="square">
@@ -13802,7 +13855,7 @@
                 <a:effectLst/>
                 <a:uLnTx/>
                 <a:uFillTx/>
-                <a:latin typeface="Segoe UI"/>
+                <a:latin typeface="Arial"/>
                 <a:ea typeface="+mn-ea"/>
                 <a:cs typeface="+mn-cs"/>
               </a:rPr>
@@ -13826,6 +13879,7 @@
             <a:avLst/>
           </a:prstGeom>
           <a:noFill/>
+          <a:ln/>
         </p:spPr>
         <p:txBody>
           <a:bodyPr wrap="square">
@@ -13856,12 +13910,12 @@
                   <a:noFill/>
                 </a:ln>
                 <a:solidFill>
-                  <a:srgbClr val="00A89A"/>
+                  <a:srgbClr val="A70E17"/>
                 </a:solidFill>
                 <a:effectLst/>
                 <a:uLnTx/>
                 <a:uFillTx/>
-                <a:latin typeface="Segoe UI"/>
+                <a:latin typeface="Arial"/>
                 <a:ea typeface="+mn-ea"/>
                 <a:cs typeface="+mn-cs"/>
               </a:rPr>
@@ -13885,7 +13939,7 @@
             <a:avLst/>
           </a:prstGeom>
           <a:solidFill>
-            <a:srgbClr val="0B1F3A"/>
+            <a:srgbClr val="2B2B2B"/>
           </a:solidFill>
           <a:ln>
             <a:noFill/>
@@ -13958,7 +14012,7 @@
             <a:avLst/>
           </a:prstGeom>
           <a:solidFill>
-            <a:srgbClr val="00A89A"/>
+            <a:srgbClr val="A70E17"/>
           </a:solidFill>
           <a:ln>
             <a:noFill/>
@@ -14031,6 +14085,7 @@
             <a:avLst/>
           </a:prstGeom>
           <a:noFill/>
+          <a:ln/>
         </p:spPr>
         <p:txBody>
           <a:bodyPr wrap="square">
@@ -14066,7 +14121,7 @@
                 <a:effectLst/>
                 <a:uLnTx/>
                 <a:uFillTx/>
-                <a:latin typeface="Segoe UI"/>
+                <a:latin typeface="Arial"/>
                 <a:ea typeface="+mn-ea"/>
                 <a:cs typeface="+mn-cs"/>
               </a:rPr>
@@ -14090,6 +14145,7 @@
             <a:avLst/>
           </a:prstGeom>
           <a:noFill/>
+          <a:ln/>
         </p:spPr>
         <p:txBody>
           <a:bodyPr wrap="square">
@@ -14120,12 +14176,12 @@
                   <a:noFill/>
                 </a:ln>
                 <a:solidFill>
-                  <a:srgbClr val="B8D0EC"/>
+                  <a:srgbClr val="E8E8E8"/>
                 </a:solidFill>
                 <a:effectLst/>
                 <a:uLnTx/>
                 <a:uFillTx/>
-                <a:latin typeface="Segoe UI"/>
+                <a:latin typeface="Arial"/>
                 <a:ea typeface="+mn-ea"/>
                 <a:cs typeface="+mn-cs"/>
               </a:rPr>
@@ -14149,7 +14205,7 @@
             <a:avLst/>
           </a:prstGeom>
           <a:solidFill>
-            <a:srgbClr val="0B1F3A"/>
+            <a:srgbClr val="2B2B2B"/>
           </a:solidFill>
           <a:ln>
             <a:noFill/>
@@ -14222,7 +14278,7 @@
             <a:avLst/>
           </a:prstGeom>
           <a:solidFill>
-            <a:srgbClr val="00A89A"/>
+            <a:srgbClr val="A70E17"/>
           </a:solidFill>
           <a:ln>
             <a:noFill/>
@@ -14295,6 +14351,7 @@
             <a:avLst/>
           </a:prstGeom>
           <a:noFill/>
+          <a:ln/>
         </p:spPr>
         <p:txBody>
           <a:bodyPr wrap="square">
@@ -14330,7 +14387,7 @@
                 <a:effectLst/>
                 <a:uLnTx/>
                 <a:uFillTx/>
-                <a:latin typeface="Segoe UI"/>
+                <a:latin typeface="Arial"/>
                 <a:ea typeface="+mn-ea"/>
                 <a:cs typeface="+mn-cs"/>
               </a:rPr>
@@ -14354,6 +14411,7 @@
             <a:avLst/>
           </a:prstGeom>
           <a:noFill/>
+          <a:ln/>
         </p:spPr>
         <p:txBody>
           <a:bodyPr wrap="square">
@@ -14384,12 +14442,12 @@
                   <a:noFill/>
                 </a:ln>
                 <a:solidFill>
-                  <a:srgbClr val="B8D0EC"/>
+                  <a:srgbClr val="E8E8E8"/>
                 </a:solidFill>
                 <a:effectLst/>
                 <a:uLnTx/>
                 <a:uFillTx/>
-                <a:latin typeface="Segoe UI"/>
+                <a:latin typeface="Arial"/>
                 <a:ea typeface="+mn-ea"/>
                 <a:cs typeface="+mn-cs"/>
               </a:rPr>
@@ -14413,7 +14471,7 @@
             <a:avLst/>
           </a:prstGeom>
           <a:solidFill>
-            <a:srgbClr val="0B1F3A"/>
+            <a:srgbClr val="2B2B2B"/>
           </a:solidFill>
           <a:ln>
             <a:noFill/>
@@ -14486,7 +14544,7 @@
             <a:avLst/>
           </a:prstGeom>
           <a:solidFill>
-            <a:srgbClr val="00A89A"/>
+            <a:srgbClr val="A70E17"/>
           </a:solidFill>
           <a:ln>
             <a:noFill/>
@@ -14559,6 +14617,7 @@
             <a:avLst/>
           </a:prstGeom>
           <a:noFill/>
+          <a:ln/>
         </p:spPr>
         <p:txBody>
           <a:bodyPr wrap="square">
@@ -14594,7 +14653,7 @@
                 <a:effectLst/>
                 <a:uLnTx/>
                 <a:uFillTx/>
-                <a:latin typeface="Segoe UI"/>
+                <a:latin typeface="Arial"/>
                 <a:ea typeface="+mn-ea"/>
                 <a:cs typeface="+mn-cs"/>
               </a:rPr>
@@ -14618,6 +14677,7 @@
             <a:avLst/>
           </a:prstGeom>
           <a:noFill/>
+          <a:ln/>
         </p:spPr>
         <p:txBody>
           <a:bodyPr wrap="square">
@@ -14648,12 +14708,12 @@
                   <a:noFill/>
                 </a:ln>
                 <a:solidFill>
-                  <a:srgbClr val="B8D0EC"/>
+                  <a:srgbClr val="E8E8E8"/>
                 </a:solidFill>
                 <a:effectLst/>
                 <a:uLnTx/>
                 <a:uFillTx/>
-                <a:latin typeface="Segoe UI"/>
+                <a:latin typeface="Arial"/>
                 <a:ea typeface="+mn-ea"/>
                 <a:cs typeface="+mn-cs"/>
               </a:rPr>
@@ -14677,7 +14737,7 @@
             <a:avLst/>
           </a:prstGeom>
           <a:solidFill>
-            <a:srgbClr val="0B1F3A"/>
+            <a:srgbClr val="2B2B2B"/>
           </a:solidFill>
           <a:ln>
             <a:noFill/>
@@ -14750,7 +14810,7 @@
             <a:avLst/>
           </a:prstGeom>
           <a:solidFill>
-            <a:srgbClr val="00A89A"/>
+            <a:srgbClr val="A70E17"/>
           </a:solidFill>
           <a:ln>
             <a:noFill/>
@@ -14823,6 +14883,7 @@
             <a:avLst/>
           </a:prstGeom>
           <a:noFill/>
+          <a:ln/>
         </p:spPr>
         <p:txBody>
           <a:bodyPr wrap="square">
@@ -14858,7 +14919,7 @@
                 <a:effectLst/>
                 <a:uLnTx/>
                 <a:uFillTx/>
-                <a:latin typeface="Segoe UI"/>
+                <a:latin typeface="Arial"/>
                 <a:ea typeface="+mn-ea"/>
                 <a:cs typeface="+mn-cs"/>
               </a:rPr>
@@ -14882,6 +14943,7 @@
             <a:avLst/>
           </a:prstGeom>
           <a:noFill/>
+          <a:ln/>
         </p:spPr>
         <p:txBody>
           <a:bodyPr wrap="square">
@@ -14912,12 +14974,12 @@
                   <a:noFill/>
                 </a:ln>
                 <a:solidFill>
-                  <a:srgbClr val="B8D0EC"/>
+                  <a:srgbClr val="E8E8E8"/>
                 </a:solidFill>
                 <a:effectLst/>
                 <a:uLnTx/>
                 <a:uFillTx/>
-                <a:latin typeface="Segoe UI"/>
+                <a:latin typeface="Arial"/>
                 <a:ea typeface="+mn-ea"/>
                 <a:cs typeface="+mn-cs"/>
               </a:rPr>
@@ -14941,7 +15003,7 @@
             <a:avLst/>
           </a:prstGeom>
           <a:solidFill>
-            <a:srgbClr val="122240"/>
+            <a:srgbClr val="2B2B2B"/>
           </a:solidFill>
           <a:ln>
             <a:noFill/>
@@ -15014,7 +15076,7 @@
             <a:avLst/>
           </a:prstGeom>
           <a:solidFill>
-            <a:srgbClr val="00C8F0"/>
+            <a:srgbClr val="D71920"/>
           </a:solidFill>
           <a:ln>
             <a:noFill/>
@@ -15087,6 +15149,7 @@
             <a:avLst/>
           </a:prstGeom>
           <a:noFill/>
+          <a:ln/>
         </p:spPr>
         <p:txBody>
           <a:bodyPr wrap="square">
@@ -15122,7 +15185,7 @@
                 <a:effectLst/>
                 <a:uLnTx/>
                 <a:uFillTx/>
-                <a:latin typeface="Segoe UI"/>
+                <a:latin typeface="Arial"/>
                 <a:ea typeface="+mn-ea"/>
                 <a:cs typeface="+mn-cs"/>
               </a:rPr>
@@ -15146,6 +15209,7 @@
             <a:avLst/>
           </a:prstGeom>
           <a:noFill/>
+          <a:ln/>
         </p:spPr>
         <p:txBody>
           <a:bodyPr wrap="square">
@@ -15176,12 +15240,12 @@
                   <a:noFill/>
                 </a:ln>
                 <a:solidFill>
-                  <a:srgbClr val="B8D0EC"/>
+                  <a:srgbClr val="E8E8E8"/>
                 </a:solidFill>
                 <a:effectLst/>
                 <a:uLnTx/>
                 <a:uFillTx/>
-                <a:latin typeface="Segoe UI"/>
+                <a:latin typeface="Arial"/>
                 <a:ea typeface="+mn-ea"/>
                 <a:cs typeface="+mn-cs"/>
               </a:rPr>
@@ -15205,7 +15269,7 @@
             <a:avLst/>
           </a:prstGeom>
           <a:solidFill>
-            <a:srgbClr val="0B1F3A"/>
+            <a:srgbClr val="2B2B2B"/>
           </a:solidFill>
           <a:ln>
             <a:noFill/>
@@ -15278,7 +15342,7 @@
             <a:avLst/>
           </a:prstGeom>
           <a:solidFill>
-            <a:srgbClr val="00D48A"/>
+            <a:srgbClr val="2E7D32"/>
           </a:solidFill>
           <a:ln>
             <a:noFill/>
@@ -15351,6 +15415,7 @@
             <a:avLst/>
           </a:prstGeom>
           <a:noFill/>
+          <a:ln/>
         </p:spPr>
         <p:txBody>
           <a:bodyPr wrap="square">
@@ -15381,12 +15446,12 @@
                   <a:noFill/>
                 </a:ln>
                 <a:solidFill>
-                  <a:srgbClr val="00D48A"/>
+                  <a:srgbClr val="2E7D32"/>
                 </a:solidFill>
                 <a:effectLst/>
                 <a:uLnTx/>
                 <a:uFillTx/>
-                <a:latin typeface="Segoe UI"/>
+                <a:latin typeface="Arial"/>
                 <a:ea typeface="+mn-ea"/>
                 <a:cs typeface="+mn-cs"/>
               </a:rPr>
@@ -15410,6 +15475,7 @@
             <a:avLst/>
           </a:prstGeom>
           <a:noFill/>
+          <a:ln/>
         </p:spPr>
         <p:txBody>
           <a:bodyPr wrap="square">
@@ -15440,12 +15506,12 @@
                   <a:noFill/>
                 </a:ln>
                 <a:solidFill>
-                  <a:srgbClr val="B8D0EC"/>
+                  <a:srgbClr val="E8E8E8"/>
                 </a:solidFill>
                 <a:effectLst/>
                 <a:uLnTx/>
                 <a:uFillTx/>
-                <a:latin typeface="Segoe UI"/>
+                <a:latin typeface="Arial"/>
                 <a:ea typeface="+mn-ea"/>
                 <a:cs typeface="+mn-cs"/>
               </a:rPr>
@@ -15469,7 +15535,7 @@
             <a:avLst/>
           </a:prstGeom>
           <a:solidFill>
-            <a:srgbClr val="0B1F3A"/>
+            <a:srgbClr val="2B2B2B"/>
           </a:solidFill>
           <a:ln>
             <a:noFill/>
@@ -15542,7 +15608,7 @@
             <a:avLst/>
           </a:prstGeom>
           <a:solidFill>
-            <a:srgbClr val="FF8C00"/>
+            <a:srgbClr val="D71920"/>
           </a:solidFill>
           <a:ln>
             <a:noFill/>
@@ -15615,6 +15681,7 @@
             <a:avLst/>
           </a:prstGeom>
           <a:noFill/>
+          <a:ln/>
         </p:spPr>
         <p:txBody>
           <a:bodyPr wrap="square">
@@ -15645,12 +15712,12 @@
                   <a:noFill/>
                 </a:ln>
                 <a:solidFill>
-                  <a:srgbClr val="FF8C00"/>
+                  <a:srgbClr val="D71920"/>
                 </a:solidFill>
                 <a:effectLst/>
                 <a:uLnTx/>
                 <a:uFillTx/>
-                <a:latin typeface="Segoe UI"/>
+                <a:latin typeface="Arial"/>
                 <a:ea typeface="+mn-ea"/>
                 <a:cs typeface="+mn-cs"/>
               </a:rPr>
@@ -15674,6 +15741,7 @@
             <a:avLst/>
           </a:prstGeom>
           <a:noFill/>
+          <a:ln/>
         </p:spPr>
         <p:txBody>
           <a:bodyPr wrap="square">
@@ -15704,12 +15772,12 @@
                   <a:noFill/>
                 </a:ln>
                 <a:solidFill>
-                  <a:srgbClr val="B8D0EC"/>
+                  <a:srgbClr val="E8E8E8"/>
                 </a:solidFill>
                 <a:effectLst/>
                 <a:uLnTx/>
                 <a:uFillTx/>
-                <a:latin typeface="Segoe UI"/>
+                <a:latin typeface="Arial"/>
                 <a:ea typeface="+mn-ea"/>
                 <a:cs typeface="+mn-cs"/>
               </a:rPr>
@@ -15733,7 +15801,7 @@
             <a:avLst/>
           </a:prstGeom>
           <a:solidFill>
-            <a:srgbClr val="0B1F3A"/>
+            <a:srgbClr val="2B2B2B"/>
           </a:solidFill>
           <a:ln>
             <a:noFill/>
@@ -15806,7 +15874,7 @@
             <a:avLst/>
           </a:prstGeom>
           <a:solidFill>
-            <a:srgbClr val="8B5CF6"/>
+            <a:srgbClr val="666666"/>
           </a:solidFill>
           <a:ln>
             <a:noFill/>
@@ -15879,6 +15947,7 @@
             <a:avLst/>
           </a:prstGeom>
           <a:noFill/>
+          <a:ln/>
         </p:spPr>
         <p:txBody>
           <a:bodyPr wrap="square">
@@ -15909,12 +15978,12 @@
                   <a:noFill/>
                 </a:ln>
                 <a:solidFill>
-                  <a:srgbClr val="8B5CF6"/>
+                  <a:srgbClr val="E8E8E8"/>
                 </a:solidFill>
                 <a:effectLst/>
                 <a:uLnTx/>
                 <a:uFillTx/>
-                <a:latin typeface="Segoe UI"/>
+                <a:latin typeface="Arial"/>
                 <a:ea typeface="+mn-ea"/>
                 <a:cs typeface="+mn-cs"/>
               </a:rPr>
@@ -15938,6 +16007,7 @@
             <a:avLst/>
           </a:prstGeom>
           <a:noFill/>
+          <a:ln/>
         </p:spPr>
         <p:txBody>
           <a:bodyPr wrap="square">
@@ -15968,12 +16038,12 @@
                   <a:noFill/>
                 </a:ln>
                 <a:solidFill>
-                  <a:srgbClr val="B8D0EC"/>
+                  <a:srgbClr val="E8E8E8"/>
                 </a:solidFill>
                 <a:effectLst/>
                 <a:uLnTx/>
                 <a:uFillTx/>
-                <a:latin typeface="Segoe UI"/>
+                <a:latin typeface="Arial"/>
                 <a:ea typeface="+mn-ea"/>
                 <a:cs typeface="+mn-cs"/>
               </a:rPr>
@@ -15997,7 +16067,7 @@
             <a:avLst/>
           </a:prstGeom>
           <a:solidFill>
-            <a:srgbClr val="0B1F3A"/>
+            <a:srgbClr val="2B2B2B"/>
           </a:solidFill>
           <a:ln>
             <a:noFill/>
@@ -16070,7 +16140,7 @@
             <a:avLst/>
           </a:prstGeom>
           <a:solidFill>
-            <a:srgbClr val="00C8F0"/>
+            <a:srgbClr val="D71920"/>
           </a:solidFill>
           <a:ln>
             <a:noFill/>
@@ -16143,6 +16213,7 @@
             <a:avLst/>
           </a:prstGeom>
           <a:noFill/>
+          <a:ln/>
         </p:spPr>
         <p:txBody>
           <a:bodyPr wrap="square">
@@ -16173,12 +16244,12 @@
                   <a:noFill/>
                 </a:ln>
                 <a:solidFill>
-                  <a:srgbClr val="00C8F0"/>
+                  <a:srgbClr val="D71920"/>
                 </a:solidFill>
                 <a:effectLst/>
                 <a:uLnTx/>
                 <a:uFillTx/>
-                <a:latin typeface="Segoe UI"/>
+                <a:latin typeface="Arial"/>
                 <a:ea typeface="+mn-ea"/>
                 <a:cs typeface="+mn-cs"/>
               </a:rPr>
@@ -16202,6 +16273,7 @@
             <a:avLst/>
           </a:prstGeom>
           <a:noFill/>
+          <a:ln/>
         </p:spPr>
         <p:txBody>
           <a:bodyPr wrap="square">
@@ -16232,12 +16304,12 @@
                   <a:noFill/>
                 </a:ln>
                 <a:solidFill>
-                  <a:srgbClr val="B8D0EC"/>
+                  <a:srgbClr val="E8E8E8"/>
                 </a:solidFill>
                 <a:effectLst/>
                 <a:uLnTx/>
                 <a:uFillTx/>
-                <a:latin typeface="Segoe UI"/>
+                <a:latin typeface="Arial"/>
                 <a:ea typeface="+mn-ea"/>
                 <a:cs typeface="+mn-cs"/>
               </a:rPr>
@@ -16261,7 +16333,7 @@
             <a:avLst/>
           </a:prstGeom>
           <a:solidFill>
-            <a:srgbClr val="05142E"/>
+            <a:srgbClr val="1F1F1F"/>
           </a:solidFill>
           <a:ln>
             <a:noFill/>
@@ -16334,6 +16406,7 @@
             <a:avLst/>
           </a:prstGeom>
           <a:noFill/>
+          <a:ln/>
         </p:spPr>
         <p:txBody>
           <a:bodyPr wrap="square">
@@ -16369,7 +16442,7 @@
                 <a:effectLst/>
                 <a:uLnTx/>
                 <a:uFillTx/>
-                <a:latin typeface="Segoe UI"/>
+                <a:latin typeface="Arial"/>
                 <a:ea typeface="+mn-ea"/>
                 <a:cs typeface="+mn-cs"/>
               </a:rPr>
@@ -16393,7 +16466,7 @@
             <a:avLst/>
           </a:prstGeom>
           <a:solidFill>
-            <a:srgbClr val="0072C6"/>
+            <a:srgbClr val="D71920"/>
           </a:solidFill>
           <a:ln>
             <a:noFill/>
@@ -16466,6 +16539,7 @@
             <a:avLst/>
           </a:prstGeom>
           <a:noFill/>
+          <a:ln/>
         </p:spPr>
         <p:txBody>
           <a:bodyPr wrap="square">
@@ -16501,7 +16575,7 @@
                 <a:effectLst/>
                 <a:uLnTx/>
                 <a:uFillTx/>
-                <a:latin typeface="Segoe UI"/>
+                <a:latin typeface="Arial"/>
                 <a:ea typeface="+mn-ea"/>
                 <a:cs typeface="+mn-cs"/>
               </a:rPr>
@@ -16525,6 +16599,7 @@
             <a:avLst/>
           </a:prstGeom>
           <a:noFill/>
+          <a:ln/>
         </p:spPr>
         <p:txBody>
           <a:bodyPr wrap="square">
@@ -16560,7 +16635,7 @@
                 <a:effectLst/>
                 <a:uLnTx/>
                 <a:uFillTx/>
-                <a:latin typeface="Segoe UI"/>
+                <a:latin typeface="Arial"/>
                 <a:ea typeface="+mn-ea"/>
                 <a:cs typeface="+mn-cs"/>
               </a:rPr>
@@ -16584,6 +16659,7 @@
             <a:avLst/>
           </a:prstGeom>
           <a:noFill/>
+          <a:ln/>
         </p:spPr>
         <p:txBody>
           <a:bodyPr wrap="square">
@@ -16614,12 +16690,12 @@
                   <a:noFill/>
                 </a:ln>
                 <a:solidFill>
-                  <a:srgbClr val="B8D0EC"/>
+                  <a:srgbClr val="E8E8E8"/>
                 </a:solidFill>
                 <a:effectLst/>
                 <a:uLnTx/>
                 <a:uFillTx/>
-                <a:latin typeface="Segoe UI"/>
+                <a:latin typeface="Arial"/>
                 <a:ea typeface="+mn-ea"/>
                 <a:cs typeface="+mn-cs"/>
               </a:rPr>
@@ -16643,7 +16719,7 @@
             <a:avLst/>
           </a:prstGeom>
           <a:solidFill>
-            <a:srgbClr val="B8D0EC"/>
+            <a:srgbClr val="E8E8E8"/>
           </a:solidFill>
           <a:ln>
             <a:noFill/>
@@ -16716,7 +16792,7 @@
             <a:avLst/>
           </a:prstGeom>
           <a:solidFill>
-            <a:srgbClr val="00D48A"/>
+            <a:srgbClr val="2E7D32"/>
           </a:solidFill>
           <a:ln>
             <a:noFill/>
@@ -16789,6 +16865,7 @@
             <a:avLst/>
           </a:prstGeom>
           <a:noFill/>
+          <a:ln/>
         </p:spPr>
         <p:txBody>
           <a:bodyPr wrap="square">
@@ -16824,7 +16901,7 @@
                 <a:effectLst/>
                 <a:uLnTx/>
                 <a:uFillTx/>
-                <a:latin typeface="Segoe UI"/>
+                <a:latin typeface="Arial"/>
                 <a:ea typeface="+mn-ea"/>
                 <a:cs typeface="+mn-cs"/>
               </a:rPr>
@@ -16848,6 +16925,7 @@
             <a:avLst/>
           </a:prstGeom>
           <a:noFill/>
+          <a:ln/>
         </p:spPr>
         <p:txBody>
           <a:bodyPr wrap="square">
@@ -16883,7 +16961,7 @@
                 <a:effectLst/>
                 <a:uLnTx/>
                 <a:uFillTx/>
-                <a:latin typeface="Segoe UI"/>
+                <a:latin typeface="Arial"/>
                 <a:ea typeface="+mn-ea"/>
                 <a:cs typeface="+mn-cs"/>
               </a:rPr>
@@ -16907,6 +16985,7 @@
             <a:avLst/>
           </a:prstGeom>
           <a:noFill/>
+          <a:ln/>
         </p:spPr>
         <p:txBody>
           <a:bodyPr wrap="square">
@@ -16937,12 +17016,12 @@
                   <a:noFill/>
                 </a:ln>
                 <a:solidFill>
-                  <a:srgbClr val="B8D0EC"/>
+                  <a:srgbClr val="E8E8E8"/>
                 </a:solidFill>
                 <a:effectLst/>
                 <a:uLnTx/>
                 <a:uFillTx/>
-                <a:latin typeface="Segoe UI"/>
+                <a:latin typeface="Arial"/>
                 <a:ea typeface="+mn-ea"/>
                 <a:cs typeface="+mn-cs"/>
               </a:rPr>
@@ -16966,7 +17045,7 @@
             <a:avLst/>
           </a:prstGeom>
           <a:solidFill>
-            <a:srgbClr val="B8D0EC"/>
+            <a:srgbClr val="E8E8E8"/>
           </a:solidFill>
           <a:ln>
             <a:noFill/>
@@ -17039,7 +17118,7 @@
             <a:avLst/>
           </a:prstGeom>
           <a:solidFill>
-            <a:srgbClr val="FF8C00"/>
+            <a:srgbClr val="D71920"/>
           </a:solidFill>
           <a:ln>
             <a:noFill/>
@@ -17112,6 +17191,7 @@
             <a:avLst/>
           </a:prstGeom>
           <a:noFill/>
+          <a:ln/>
         </p:spPr>
         <p:txBody>
           <a:bodyPr wrap="square">
@@ -17147,7 +17227,7 @@
                 <a:effectLst/>
                 <a:uLnTx/>
                 <a:uFillTx/>
-                <a:latin typeface="Segoe UI"/>
+                <a:latin typeface="Arial"/>
                 <a:ea typeface="+mn-ea"/>
                 <a:cs typeface="+mn-cs"/>
               </a:rPr>
@@ -17171,6 +17251,7 @@
             <a:avLst/>
           </a:prstGeom>
           <a:noFill/>
+          <a:ln/>
         </p:spPr>
         <p:txBody>
           <a:bodyPr wrap="square">
@@ -17206,7 +17287,7 @@
                 <a:effectLst/>
                 <a:uLnTx/>
                 <a:uFillTx/>
-                <a:latin typeface="Segoe UI"/>
+                <a:latin typeface="Arial"/>
                 <a:ea typeface="+mn-ea"/>
                 <a:cs typeface="+mn-cs"/>
               </a:rPr>
@@ -17230,6 +17311,7 @@
             <a:avLst/>
           </a:prstGeom>
           <a:noFill/>
+          <a:ln/>
         </p:spPr>
         <p:txBody>
           <a:bodyPr wrap="square">
@@ -17260,12 +17342,12 @@
                   <a:noFill/>
                 </a:ln>
                 <a:solidFill>
-                  <a:srgbClr val="B8D0EC"/>
+                  <a:srgbClr val="E8E8E8"/>
                 </a:solidFill>
                 <a:effectLst/>
                 <a:uLnTx/>
                 <a:uFillTx/>
-                <a:latin typeface="Segoe UI"/>
+                <a:latin typeface="Arial"/>
                 <a:ea typeface="+mn-ea"/>
                 <a:cs typeface="+mn-cs"/>
               </a:rPr>
@@ -17289,7 +17371,7 @@
             <a:avLst/>
           </a:prstGeom>
           <a:solidFill>
-            <a:srgbClr val="B8D0EC"/>
+            <a:srgbClr val="E8E8E8"/>
           </a:solidFill>
           <a:ln>
             <a:noFill/>
@@ -17362,7 +17444,7 @@
             <a:avLst/>
           </a:prstGeom>
           <a:solidFill>
-            <a:srgbClr val="8B5CF6"/>
+            <a:srgbClr val="666666"/>
           </a:solidFill>
           <a:ln>
             <a:noFill/>
@@ -17435,6 +17517,7 @@
             <a:avLst/>
           </a:prstGeom>
           <a:noFill/>
+          <a:ln/>
         </p:spPr>
         <p:txBody>
           <a:bodyPr wrap="square">
@@ -17470,7 +17553,7 @@
                 <a:effectLst/>
                 <a:uLnTx/>
                 <a:uFillTx/>
-                <a:latin typeface="Segoe UI"/>
+                <a:latin typeface="Arial"/>
                 <a:ea typeface="+mn-ea"/>
                 <a:cs typeface="+mn-cs"/>
               </a:rPr>
@@ -17494,6 +17577,7 @@
             <a:avLst/>
           </a:prstGeom>
           <a:noFill/>
+          <a:ln/>
         </p:spPr>
         <p:txBody>
           <a:bodyPr wrap="square">
@@ -17529,7 +17613,7 @@
                 <a:effectLst/>
                 <a:uLnTx/>
                 <a:uFillTx/>
-                <a:latin typeface="Segoe UI"/>
+                <a:latin typeface="Arial"/>
                 <a:ea typeface="+mn-ea"/>
                 <a:cs typeface="+mn-cs"/>
               </a:rPr>
@@ -17553,6 +17637,7 @@
             <a:avLst/>
           </a:prstGeom>
           <a:noFill/>
+          <a:ln/>
         </p:spPr>
         <p:txBody>
           <a:bodyPr wrap="square">
@@ -17583,12 +17668,12 @@
                   <a:noFill/>
                 </a:ln>
                 <a:solidFill>
-                  <a:srgbClr val="B8D0EC"/>
+                  <a:srgbClr val="E8E8E8"/>
                 </a:solidFill>
                 <a:effectLst/>
                 <a:uLnTx/>
                 <a:uFillTx/>
-                <a:latin typeface="Segoe UI"/>
+                <a:latin typeface="Arial"/>
                 <a:ea typeface="+mn-ea"/>
                 <a:cs typeface="+mn-cs"/>
               </a:rPr>
@@ -17612,7 +17697,7 @@
             <a:avLst/>
           </a:prstGeom>
           <a:solidFill>
-            <a:srgbClr val="B8D0EC"/>
+            <a:srgbClr val="E8E8E8"/>
           </a:solidFill>
           <a:ln>
             <a:noFill/>
@@ -17685,7 +17770,7 @@
             <a:avLst/>
           </a:prstGeom>
           <a:solidFill>
-            <a:srgbClr val="00C8F0"/>
+            <a:srgbClr val="D71920"/>
           </a:solidFill>
           <a:ln>
             <a:noFill/>
@@ -17758,6 +17843,7 @@
             <a:avLst/>
           </a:prstGeom>
           <a:noFill/>
+          <a:ln/>
         </p:spPr>
         <p:txBody>
           <a:bodyPr wrap="square">
@@ -17793,7 +17879,7 @@
                 <a:effectLst/>
                 <a:uLnTx/>
                 <a:uFillTx/>
-                <a:latin typeface="Segoe UI"/>
+                <a:latin typeface="Arial"/>
                 <a:ea typeface="+mn-ea"/>
                 <a:cs typeface="+mn-cs"/>
               </a:rPr>
@@ -17817,6 +17903,7 @@
             <a:avLst/>
           </a:prstGeom>
           <a:noFill/>
+          <a:ln/>
         </p:spPr>
         <p:txBody>
           <a:bodyPr wrap="square">
@@ -17852,7 +17939,7 @@
                 <a:effectLst/>
                 <a:uLnTx/>
                 <a:uFillTx/>
-                <a:latin typeface="Segoe UI"/>
+                <a:latin typeface="Arial"/>
                 <a:ea typeface="+mn-ea"/>
                 <a:cs typeface="+mn-cs"/>
               </a:rPr>
@@ -17876,6 +17963,7 @@
             <a:avLst/>
           </a:prstGeom>
           <a:noFill/>
+          <a:ln/>
         </p:spPr>
         <p:txBody>
           <a:bodyPr wrap="square">
@@ -17906,12 +17994,12 @@
                   <a:noFill/>
                 </a:ln>
                 <a:solidFill>
-                  <a:srgbClr val="B8D0EC"/>
+                  <a:srgbClr val="E8E8E8"/>
                 </a:solidFill>
                 <a:effectLst/>
                 <a:uLnTx/>
                 <a:uFillTx/>
-                <a:latin typeface="Segoe UI"/>
+                <a:latin typeface="Arial"/>
                 <a:ea typeface="+mn-ea"/>
                 <a:cs typeface="+mn-cs"/>
               </a:rPr>
@@ -17935,7 +18023,7 @@
             <a:avLst/>
           </a:prstGeom>
           <a:solidFill>
-            <a:srgbClr val="B8D0EC"/>
+            <a:srgbClr val="E8E8E8"/>
           </a:solidFill>
           <a:ln>
             <a:noFill/>
@@ -18008,7 +18096,7 @@
             <a:avLst/>
           </a:prstGeom>
           <a:solidFill>
-            <a:srgbClr val="00D48A"/>
+            <a:srgbClr val="2E7D32"/>
           </a:solidFill>
           <a:ln>
             <a:noFill/>
@@ -18081,6 +18169,7 @@
             <a:avLst/>
           </a:prstGeom>
           <a:noFill/>
+          <a:ln/>
         </p:spPr>
         <p:txBody>
           <a:bodyPr wrap="square">
@@ -18116,7 +18205,7 @@
                 <a:effectLst/>
                 <a:uLnTx/>
                 <a:uFillTx/>
-                <a:latin typeface="Segoe UI"/>
+                <a:latin typeface="Arial"/>
                 <a:ea typeface="+mn-ea"/>
                 <a:cs typeface="+mn-cs"/>
               </a:rPr>
@@ -18140,6 +18229,7 @@
             <a:avLst/>
           </a:prstGeom>
           <a:noFill/>
+          <a:ln/>
         </p:spPr>
         <p:txBody>
           <a:bodyPr wrap="square">
@@ -18175,7 +18265,7 @@
                 <a:effectLst/>
                 <a:uLnTx/>
                 <a:uFillTx/>
-                <a:latin typeface="Segoe UI"/>
+                <a:latin typeface="Arial"/>
                 <a:ea typeface="+mn-ea"/>
                 <a:cs typeface="+mn-cs"/>
               </a:rPr>
@@ -18199,6 +18289,7 @@
             <a:avLst/>
           </a:prstGeom>
           <a:noFill/>
+          <a:ln/>
         </p:spPr>
         <p:txBody>
           <a:bodyPr wrap="square">
@@ -18229,12 +18320,12 @@
                   <a:noFill/>
                 </a:ln>
                 <a:solidFill>
-                  <a:srgbClr val="B8D0EC"/>
+                  <a:srgbClr val="E8E8E8"/>
                 </a:solidFill>
                 <a:effectLst/>
                 <a:uLnTx/>
                 <a:uFillTx/>
-                <a:latin typeface="Segoe UI"/>
+                <a:latin typeface="Arial"/>
                 <a:ea typeface="+mn-ea"/>
                 <a:cs typeface="+mn-cs"/>
               </a:rPr>
@@ -18258,7 +18349,7 @@
             <a:avLst/>
           </a:prstGeom>
           <a:solidFill>
-            <a:srgbClr val="0B1F3A"/>
+            <a:srgbClr val="2B2B2B"/>
           </a:solidFill>
           <a:ln>
             <a:noFill/>
@@ -18331,6 +18422,7 @@
             <a:avLst/>
           </a:prstGeom>
           <a:noFill/>
+          <a:ln/>
         </p:spPr>
         <p:txBody>
           <a:bodyPr wrap="square">
@@ -18361,12 +18453,12 @@
                   <a:noFill/>
                 </a:ln>
                 <a:solidFill>
-                  <a:srgbClr val="00C8F0"/>
+                  <a:srgbClr val="D71920"/>
                 </a:solidFill>
                 <a:effectLst/>
                 <a:uLnTx/>
                 <a:uFillTx/>
-                <a:latin typeface="Segoe UI"/>
+                <a:latin typeface="Arial"/>
                 <a:ea typeface="+mn-ea"/>
                 <a:cs typeface="+mn-cs"/>
               </a:rPr>
@@ -18390,7 +18482,7 @@
             <a:avLst/>
           </a:prstGeom>
           <a:solidFill>
-            <a:srgbClr val="0072C6"/>
+            <a:srgbClr val="D71920"/>
           </a:solidFill>
           <a:ln>
             <a:noFill/>
@@ -18463,6 +18555,7 @@
             <a:avLst/>
           </a:prstGeom>
           <a:noFill/>
+          <a:ln/>
         </p:spPr>
         <p:txBody>
           <a:bodyPr wrap="square">
@@ -18498,7 +18591,7 @@
                 <a:effectLst/>
                 <a:uLnTx/>
                 <a:uFillTx/>
-                <a:latin typeface="Segoe UI"/>
+                <a:latin typeface="Arial"/>
                 <a:ea typeface="+mn-ea"/>
                 <a:cs typeface="+mn-cs"/>
               </a:rPr>
@@ -18522,7 +18615,7 @@
             <a:avLst/>
           </a:prstGeom>
           <a:solidFill>
-            <a:srgbClr val="FF8C00"/>
+            <a:srgbClr val="D71920"/>
           </a:solidFill>
           <a:ln>
             <a:noFill/>
@@ -18595,6 +18688,7 @@
             <a:avLst/>
           </a:prstGeom>
           <a:noFill/>
+          <a:ln/>
         </p:spPr>
         <p:txBody>
           <a:bodyPr wrap="square">
@@ -18630,7 +18724,7 @@
                 <a:effectLst/>
                 <a:uLnTx/>
                 <a:uFillTx/>
-                <a:latin typeface="Segoe UI"/>
+                <a:latin typeface="Arial"/>
                 <a:ea typeface="+mn-ea"/>
                 <a:cs typeface="+mn-cs"/>
               </a:rPr>
@@ -18654,7 +18748,7 @@
             <a:avLst/>
           </a:prstGeom>
           <a:solidFill>
-            <a:srgbClr val="00D48A"/>
+            <a:srgbClr val="2E7D32"/>
           </a:solidFill>
           <a:ln>
             <a:noFill/>
@@ -18727,6 +18821,7 @@
             <a:avLst/>
           </a:prstGeom>
           <a:noFill/>
+          <a:ln/>
         </p:spPr>
         <p:txBody>
           <a:bodyPr wrap="square">
@@ -18762,7 +18857,7 @@
                 <a:effectLst/>
                 <a:uLnTx/>
                 <a:uFillTx/>
-                <a:latin typeface="Segoe UI"/>
+                <a:latin typeface="Arial"/>
                 <a:ea typeface="+mn-ea"/>
                 <a:cs typeface="+mn-cs"/>
               </a:rPr>
@@ -18786,7 +18881,7 @@
             <a:avLst/>
           </a:prstGeom>
           <a:solidFill>
-            <a:srgbClr val="D7F7FF"/>
+            <a:srgbClr val="F2F2F2"/>
           </a:solidFill>
           <a:ln>
             <a:noFill/>
@@ -18859,6 +18954,7 @@
             <a:avLst/>
           </a:prstGeom>
           <a:noFill/>
+          <a:ln/>
         </p:spPr>
         <p:txBody>
           <a:bodyPr wrap="square">
@@ -18889,12 +18985,12 @@
                   <a:noFill/>
                 </a:ln>
                 <a:solidFill>
-                  <a:srgbClr val="05142E"/>
+                  <a:srgbClr val="111111"/>
                 </a:solidFill>
                 <a:effectLst/>
                 <a:uLnTx/>
                 <a:uFillTx/>
-                <a:latin typeface="Segoe UI"/>
+                <a:latin typeface="Arial"/>
                 <a:ea typeface="+mn-ea"/>
                 <a:cs typeface="+mn-cs"/>
               </a:rPr>
@@ -18918,6 +19014,7 @@
             <a:avLst/>
           </a:prstGeom>
           <a:noFill/>
+          <a:ln/>
         </p:spPr>
         <p:txBody>
           <a:bodyPr wrap="square">
@@ -18948,16 +19045,94 @@
                   <a:noFill/>
                 </a:ln>
                 <a:solidFill>
-                  <a:srgbClr val="05142E"/>
+                  <a:srgbClr val="111111"/>
                 </a:solidFill>
                 <a:effectLst/>
                 <a:uLnTx/>
                 <a:uFillTx/>
-                <a:latin typeface="Segoe UI"/>
+                <a:latin typeface="Arial"/>
                 <a:ea typeface="+mn-ea"/>
                 <a:cs typeface="+mn-cs"/>
               </a:rPr>
               <a:t>ROVO Studio | Copilot | Atlassian MCP | GitHub | Jira | Confluence | AEPLO JTAG Accelerator</a:t>
+            </a:r>
+          </a:p>
+        </p:txBody>
+      </p:sp>
+      <p:sp>
+        <p:nvSpPr>
+          <p:cNvPr id="231" name="Rectangle 230"/>
+          <p:cNvSpPr/>
+          <p:nvPr/>
+        </p:nvSpPr>
+        <p:spPr>
+          <a:xfrm>
+            <a:off x="0" y="0"/>
+            <a:ext cx="12192000" cy="32004"/>
+          </a:xfrm>
+          <a:prstGeom prst="rect">
+            <a:avLst/>
+          </a:prstGeom>
+          <a:solidFill>
+            <a:srgbClr val="D71920"/>
+          </a:solidFill>
+          <a:ln>
+            <a:noFill/>
+          </a:ln>
+        </p:spPr>
+        <p:style>
+          <a:lnRef idx="1">
+            <a:schemeClr val="accent1"/>
+          </a:lnRef>
+          <a:fillRef idx="3">
+            <a:schemeClr val="accent1"/>
+          </a:fillRef>
+          <a:effectRef idx="2">
+            <a:schemeClr val="accent1"/>
+          </a:effectRef>
+          <a:fontRef idx="minor">
+            <a:schemeClr val="lt1"/>
+          </a:fontRef>
+        </p:style>
+        <p:txBody>
+          <a:bodyPr rtlCol="0" anchor="ctr"/>
+          <a:lstStyle/>
+          <a:p>
+            <a:pPr algn="ctr"/>
+          </a:p>
+        </p:txBody>
+      </p:sp>
+      <p:sp>
+        <p:nvSpPr>
+          <p:cNvPr id="232" name="TextBox 231"/>
+          <p:cNvSpPr txBox="1"/>
+          <p:nvPr/>
+        </p:nvSpPr>
+        <p:spPr>
+          <a:xfrm>
+            <a:off x="10408920" y="128016"/>
+            <a:ext cx="1508760" cy="256032"/>
+          </a:xfrm>
+          <a:prstGeom prst="rect">
+            <a:avLst/>
+          </a:prstGeom>
+          <a:noFill/>
+        </p:spPr>
+        <p:txBody>
+          <a:bodyPr wrap="none">
+            <a:spAutoFit/>
+          </a:bodyPr>
+          <a:lstStyle/>
+          <a:p>
+            <a:pPr algn="r"/>
+            <a:r>
+              <a:rPr b="1" sz="1300">
+                <a:solidFill>
+                  <a:srgbClr val="D71920"/>
+                </a:solidFill>
+                <a:latin typeface="Arial"/>
+              </a:rPr>
+              <a:t>HONEYWELL</a:t>
             </a:r>
           </a:p>
         </p:txBody>

</xml_diff>